<commit_message>
added streamlit for real this time
</commit_message>
<xml_diff>
--- a/progress/ClassPresentation.pptx
+++ b/progress/ClassPresentation.pptx
@@ -11770,16 +11770,16 @@
           <a:lstStyle/>
           <a:p>
             <a:r>
-              <a:rPr lang="en-US" u="sng">
+              <a:rPr lang="en-US" u="sng" dirty="0">
                 <a:hlinkClick r:id="rId2"/>
               </a:rPr>
               <a:t>https://stat486final.streamlit.app/</a:t>
             </a:r>
             <a:r>
-              <a:rPr lang="en-US" u="sng"/>
+              <a:rPr lang="en-US" u="sng" dirty="0"/>
               <a:t> </a:t>
             </a:r>
-            <a:endParaRPr lang="en-US"/>
+            <a:endParaRPr lang="en-US" dirty="0"/>
           </a:p>
         </p:txBody>
       </p:sp>

</xml_diff>

<commit_message>
new file:   assets/PrecisionvsRecall.png 	new file:   assets/confusion_matrix.png 	modified:   assets/shap_summary.png 	new file:   notebooks/03_supervised_modeling_attempt2.ipynb 	modified:   progress/ClassPresentation.pptx
</commit_message>
<xml_diff>
--- a/progress/ClassPresentation.pptx
+++ b/progress/ClassPresentation.pptx
@@ -12,12 +12,13 @@
     <p:sldId id="259" r:id="rId6"/>
     <p:sldId id="266" r:id="rId7"/>
     <p:sldId id="268" r:id="rId8"/>
-    <p:sldId id="267" r:id="rId9"/>
-    <p:sldId id="263" r:id="rId10"/>
-    <p:sldId id="261" r:id="rId11"/>
-    <p:sldId id="262" r:id="rId12"/>
-    <p:sldId id="264" r:id="rId13"/>
-    <p:sldId id="265" r:id="rId14"/>
+    <p:sldId id="270" r:id="rId9"/>
+    <p:sldId id="267" r:id="rId10"/>
+    <p:sldId id="263" r:id="rId11"/>
+    <p:sldId id="261" r:id="rId12"/>
+    <p:sldId id="262" r:id="rId13"/>
+    <p:sldId id="264" r:id="rId14"/>
+    <p:sldId id="265" r:id="rId15"/>
   </p:sldIdLst>
   <p:sldSz cx="12192000" cy="6858000"/>
   <p:notesSz cx="6858000" cy="9144000"/>
@@ -1654,6 +1655,788 @@
 </file>
 
 <file path=ppt/diagrams/colors3.xml><?xml version="1.0" encoding="utf-8"?>
+<dgm:colorsDef xmlns:dgm="http://schemas.openxmlformats.org/drawingml/2006/diagram" xmlns:a="http://schemas.openxmlformats.org/drawingml/2006/main" uniqueId="urn:microsoft.com/office/officeart/2005/8/colors/colorful2">
+  <dgm:title val=""/>
+  <dgm:desc val=""/>
+  <dgm:catLst>
+    <dgm:cat type="colorful" pri="10200"/>
+  </dgm:catLst>
+  <dgm:styleLbl name="node0">
+    <dgm:fillClrLst meth="repeat">
+      <a:schemeClr val="accent1"/>
+    </dgm:fillClrLst>
+    <dgm:linClrLst meth="repeat">
+      <a:schemeClr val="lt1"/>
+    </dgm:linClrLst>
+    <dgm:effectClrLst/>
+    <dgm:txLinClrLst/>
+    <dgm:txFillClrLst/>
+    <dgm:txEffectClrLst/>
+  </dgm:styleLbl>
+  <dgm:styleLbl name="node1">
+    <dgm:fillClrLst>
+      <a:schemeClr val="accent2"/>
+      <a:schemeClr val="accent3"/>
+    </dgm:fillClrLst>
+    <dgm:linClrLst meth="repeat">
+      <a:schemeClr val="lt1"/>
+    </dgm:linClrLst>
+    <dgm:effectClrLst/>
+    <dgm:txLinClrLst/>
+    <dgm:txFillClrLst/>
+    <dgm:txEffectClrLst/>
+  </dgm:styleLbl>
+  <dgm:styleLbl name="alignNode1">
+    <dgm:fillClrLst>
+      <a:schemeClr val="accent2"/>
+      <a:schemeClr val="accent3"/>
+    </dgm:fillClrLst>
+    <dgm:linClrLst>
+      <a:schemeClr val="accent2"/>
+      <a:schemeClr val="accent3"/>
+    </dgm:linClrLst>
+    <dgm:effectClrLst/>
+    <dgm:txLinClrLst/>
+    <dgm:txFillClrLst/>
+    <dgm:txEffectClrLst/>
+  </dgm:styleLbl>
+  <dgm:styleLbl name="lnNode1">
+    <dgm:fillClrLst>
+      <a:schemeClr val="accent2"/>
+      <a:schemeClr val="accent3"/>
+    </dgm:fillClrLst>
+    <dgm:linClrLst meth="repeat">
+      <a:schemeClr val="lt1"/>
+    </dgm:linClrLst>
+    <dgm:effectClrLst/>
+    <dgm:txLinClrLst/>
+    <dgm:txFillClrLst/>
+    <dgm:txEffectClrLst/>
+  </dgm:styleLbl>
+  <dgm:styleLbl name="vennNode1">
+    <dgm:fillClrLst>
+      <a:schemeClr val="accent2">
+        <a:alpha val="50000"/>
+      </a:schemeClr>
+      <a:schemeClr val="accent3">
+        <a:alpha val="50000"/>
+      </a:schemeClr>
+    </dgm:fillClrLst>
+    <dgm:linClrLst meth="repeat">
+      <a:schemeClr val="lt1"/>
+    </dgm:linClrLst>
+    <dgm:effectClrLst/>
+    <dgm:txLinClrLst/>
+    <dgm:txFillClrLst/>
+    <dgm:txEffectClrLst/>
+  </dgm:styleLbl>
+  <dgm:styleLbl name="node2">
+    <dgm:fillClrLst>
+      <a:schemeClr val="accent3"/>
+    </dgm:fillClrLst>
+    <dgm:linClrLst meth="repeat">
+      <a:schemeClr val="lt1"/>
+    </dgm:linClrLst>
+    <dgm:effectClrLst/>
+    <dgm:txLinClrLst/>
+    <dgm:txFillClrLst/>
+    <dgm:txEffectClrLst/>
+  </dgm:styleLbl>
+  <dgm:styleLbl name="node3">
+    <dgm:fillClrLst>
+      <a:schemeClr val="accent4"/>
+    </dgm:fillClrLst>
+    <dgm:linClrLst meth="repeat">
+      <a:schemeClr val="lt1"/>
+    </dgm:linClrLst>
+    <dgm:effectClrLst/>
+    <dgm:txLinClrLst/>
+    <dgm:txFillClrLst/>
+    <dgm:txEffectClrLst/>
+  </dgm:styleLbl>
+  <dgm:styleLbl name="node4">
+    <dgm:fillClrLst>
+      <a:schemeClr val="accent5"/>
+    </dgm:fillClrLst>
+    <dgm:linClrLst meth="repeat">
+      <a:schemeClr val="lt1"/>
+    </dgm:linClrLst>
+    <dgm:effectClrLst/>
+    <dgm:txLinClrLst/>
+    <dgm:txFillClrLst/>
+    <dgm:txEffectClrLst/>
+  </dgm:styleLbl>
+  <dgm:styleLbl name="fgImgPlace1">
+    <dgm:fillClrLst>
+      <a:schemeClr val="accent2">
+        <a:tint val="50000"/>
+      </a:schemeClr>
+      <a:schemeClr val="accent3">
+        <a:tint val="50000"/>
+      </a:schemeClr>
+    </dgm:fillClrLst>
+    <dgm:linClrLst meth="repeat">
+      <a:schemeClr val="lt1"/>
+    </dgm:linClrLst>
+    <dgm:effectClrLst/>
+    <dgm:txLinClrLst/>
+    <dgm:txFillClrLst meth="repeat">
+      <a:schemeClr val="lt1"/>
+    </dgm:txFillClrLst>
+    <dgm:txEffectClrLst/>
+  </dgm:styleLbl>
+  <dgm:styleLbl name="alignImgPlace1">
+    <dgm:fillClrLst>
+      <a:schemeClr val="accent2">
+        <a:tint val="50000"/>
+      </a:schemeClr>
+      <a:schemeClr val="accent3">
+        <a:tint val="20000"/>
+      </a:schemeClr>
+    </dgm:fillClrLst>
+    <dgm:linClrLst meth="repeat">
+      <a:schemeClr val="lt1"/>
+    </dgm:linClrLst>
+    <dgm:effectClrLst/>
+    <dgm:txLinClrLst/>
+    <dgm:txFillClrLst meth="repeat">
+      <a:schemeClr val="lt1"/>
+    </dgm:txFillClrLst>
+    <dgm:txEffectClrLst/>
+  </dgm:styleLbl>
+  <dgm:styleLbl name="bgImgPlace1">
+    <dgm:fillClrLst>
+      <a:schemeClr val="accent2">
+        <a:tint val="50000"/>
+      </a:schemeClr>
+      <a:schemeClr val="accent3">
+        <a:tint val="20000"/>
+      </a:schemeClr>
+    </dgm:fillClrLst>
+    <dgm:linClrLst meth="repeat">
+      <a:schemeClr val="lt1"/>
+    </dgm:linClrLst>
+    <dgm:effectClrLst/>
+    <dgm:txLinClrLst/>
+    <dgm:txFillClrLst meth="repeat">
+      <a:schemeClr val="lt1"/>
+    </dgm:txFillClrLst>
+    <dgm:txEffectClrLst/>
+  </dgm:styleLbl>
+  <dgm:styleLbl name="sibTrans2D1">
+    <dgm:fillClrLst>
+      <a:schemeClr val="accent2"/>
+      <a:schemeClr val="accent3"/>
+    </dgm:fillClrLst>
+    <dgm:linClrLst meth="repeat">
+      <a:schemeClr val="lt1"/>
+    </dgm:linClrLst>
+    <dgm:effectClrLst/>
+    <dgm:txLinClrLst/>
+    <dgm:txFillClrLst/>
+    <dgm:txEffectClrLst/>
+  </dgm:styleLbl>
+  <dgm:styleLbl name="fgSibTrans2D1">
+    <dgm:fillClrLst>
+      <a:schemeClr val="accent2"/>
+      <a:schemeClr val="accent3"/>
+    </dgm:fillClrLst>
+    <dgm:linClrLst meth="repeat">
+      <a:schemeClr val="lt1"/>
+    </dgm:linClrLst>
+    <dgm:effectClrLst/>
+    <dgm:txLinClrLst/>
+    <dgm:txFillClrLst meth="repeat">
+      <a:schemeClr val="lt1"/>
+    </dgm:txFillClrLst>
+    <dgm:txEffectClrLst/>
+  </dgm:styleLbl>
+  <dgm:styleLbl name="bgSibTrans2D1">
+    <dgm:fillClrLst>
+      <a:schemeClr val="accent2"/>
+      <a:schemeClr val="accent3"/>
+    </dgm:fillClrLst>
+    <dgm:linClrLst meth="repeat">
+      <a:schemeClr val="lt1"/>
+    </dgm:linClrLst>
+    <dgm:effectClrLst/>
+    <dgm:txLinClrLst/>
+    <dgm:txFillClrLst meth="repeat">
+      <a:schemeClr val="lt1"/>
+    </dgm:txFillClrLst>
+    <dgm:txEffectClrLst/>
+  </dgm:styleLbl>
+  <dgm:styleLbl name="sibTrans1D1">
+    <dgm:fillClrLst/>
+    <dgm:linClrLst>
+      <a:schemeClr val="accent2"/>
+      <a:schemeClr val="accent3"/>
+    </dgm:linClrLst>
+    <dgm:effectClrLst/>
+    <dgm:txLinClrLst/>
+    <dgm:txFillClrLst meth="repeat">
+      <a:schemeClr val="tx1"/>
+    </dgm:txFillClrLst>
+    <dgm:txEffectClrLst/>
+  </dgm:styleLbl>
+  <dgm:styleLbl name="callout">
+    <dgm:fillClrLst meth="repeat">
+      <a:schemeClr val="accent2"/>
+    </dgm:fillClrLst>
+    <dgm:linClrLst meth="repeat">
+      <a:schemeClr val="accent2">
+        <a:tint val="50000"/>
+      </a:schemeClr>
+    </dgm:linClrLst>
+    <dgm:effectClrLst/>
+    <dgm:txLinClrLst/>
+    <dgm:txFillClrLst meth="repeat">
+      <a:schemeClr val="tx1"/>
+    </dgm:txFillClrLst>
+    <dgm:txEffectClrLst/>
+  </dgm:styleLbl>
+  <dgm:styleLbl name="asst0">
+    <dgm:fillClrLst meth="repeat">
+      <a:schemeClr val="accent2"/>
+    </dgm:fillClrLst>
+    <dgm:linClrLst meth="repeat">
+      <a:schemeClr val="lt1">
+        <a:shade val="80000"/>
+      </a:schemeClr>
+    </dgm:linClrLst>
+    <dgm:effectClrLst/>
+    <dgm:txLinClrLst/>
+    <dgm:txFillClrLst/>
+    <dgm:txEffectClrLst/>
+  </dgm:styleLbl>
+  <dgm:styleLbl name="asst1">
+    <dgm:fillClrLst meth="repeat">
+      <a:schemeClr val="accent3"/>
+    </dgm:fillClrLst>
+    <dgm:linClrLst meth="repeat">
+      <a:schemeClr val="lt1">
+        <a:shade val="80000"/>
+      </a:schemeClr>
+    </dgm:linClrLst>
+    <dgm:effectClrLst/>
+    <dgm:txLinClrLst/>
+    <dgm:txFillClrLst/>
+    <dgm:txEffectClrLst/>
+  </dgm:styleLbl>
+  <dgm:styleLbl name="asst2">
+    <dgm:fillClrLst>
+      <a:schemeClr val="accent4"/>
+    </dgm:fillClrLst>
+    <dgm:linClrLst meth="repeat">
+      <a:schemeClr val="lt1"/>
+    </dgm:linClrLst>
+    <dgm:effectClrLst/>
+    <dgm:txLinClrLst/>
+    <dgm:txFillClrLst/>
+    <dgm:txEffectClrLst/>
+  </dgm:styleLbl>
+  <dgm:styleLbl name="asst3">
+    <dgm:fillClrLst>
+      <a:schemeClr val="accent5"/>
+    </dgm:fillClrLst>
+    <dgm:linClrLst meth="repeat">
+      <a:schemeClr val="lt1"/>
+    </dgm:linClrLst>
+    <dgm:effectClrLst/>
+    <dgm:txLinClrLst/>
+    <dgm:txFillClrLst/>
+    <dgm:txEffectClrLst/>
+  </dgm:styleLbl>
+  <dgm:styleLbl name="asst4">
+    <dgm:fillClrLst>
+      <a:schemeClr val="accent6"/>
+    </dgm:fillClrLst>
+    <dgm:linClrLst meth="repeat">
+      <a:schemeClr val="lt1"/>
+    </dgm:linClrLst>
+    <dgm:effectClrLst/>
+    <dgm:txLinClrLst/>
+    <dgm:txFillClrLst/>
+    <dgm:txEffectClrLst/>
+  </dgm:styleLbl>
+  <dgm:styleLbl name="parChTrans2D1">
+    <dgm:fillClrLst meth="repeat">
+      <a:schemeClr val="accent2"/>
+    </dgm:fillClrLst>
+    <dgm:linClrLst meth="repeat">
+      <a:schemeClr val="lt1"/>
+    </dgm:linClrLst>
+    <dgm:effectClrLst/>
+    <dgm:txLinClrLst/>
+    <dgm:txFillClrLst meth="repeat">
+      <a:schemeClr val="lt1"/>
+    </dgm:txFillClrLst>
+    <dgm:txEffectClrLst/>
+  </dgm:styleLbl>
+  <dgm:styleLbl name="parChTrans2D2">
+    <dgm:fillClrLst meth="repeat">
+      <a:schemeClr val="accent3"/>
+    </dgm:fillClrLst>
+    <dgm:linClrLst meth="repeat">
+      <a:schemeClr val="lt1"/>
+    </dgm:linClrLst>
+    <dgm:effectClrLst/>
+    <dgm:txLinClrLst/>
+    <dgm:txFillClrLst/>
+    <dgm:txEffectClrLst/>
+  </dgm:styleLbl>
+  <dgm:styleLbl name="parChTrans2D3">
+    <dgm:fillClrLst meth="repeat">
+      <a:schemeClr val="accent4"/>
+    </dgm:fillClrLst>
+    <dgm:linClrLst meth="repeat">
+      <a:schemeClr val="lt1"/>
+    </dgm:linClrLst>
+    <dgm:effectClrLst/>
+    <dgm:txLinClrLst/>
+    <dgm:txFillClrLst/>
+    <dgm:txEffectClrLst/>
+  </dgm:styleLbl>
+  <dgm:styleLbl name="parChTrans2D4">
+    <dgm:fillClrLst meth="repeat">
+      <a:schemeClr val="accent5"/>
+    </dgm:fillClrLst>
+    <dgm:linClrLst meth="repeat">
+      <a:schemeClr val="lt1"/>
+    </dgm:linClrLst>
+    <dgm:effectClrLst/>
+    <dgm:txLinClrLst/>
+    <dgm:txFillClrLst meth="repeat">
+      <a:schemeClr val="lt1"/>
+    </dgm:txFillClrLst>
+    <dgm:txEffectClrLst/>
+  </dgm:styleLbl>
+  <dgm:styleLbl name="parChTrans1D1">
+    <dgm:fillClrLst meth="repeat">
+      <a:schemeClr val="accent2"/>
+    </dgm:fillClrLst>
+    <dgm:linClrLst meth="repeat">
+      <a:schemeClr val="accent2"/>
+    </dgm:linClrLst>
+    <dgm:effectClrLst/>
+    <dgm:txLinClrLst/>
+    <dgm:txFillClrLst meth="repeat">
+      <a:schemeClr val="tx1"/>
+    </dgm:txFillClrLst>
+    <dgm:txEffectClrLst/>
+  </dgm:styleLbl>
+  <dgm:styleLbl name="parChTrans1D2">
+    <dgm:fillClrLst meth="repeat">
+      <a:schemeClr val="accent2">
+        <a:tint val="90000"/>
+      </a:schemeClr>
+    </dgm:fillClrLst>
+    <dgm:linClrLst meth="repeat">
+      <a:schemeClr val="accent3"/>
+    </dgm:linClrLst>
+    <dgm:effectClrLst/>
+    <dgm:txLinClrLst/>
+    <dgm:txFillClrLst meth="repeat">
+      <a:schemeClr val="tx1"/>
+    </dgm:txFillClrLst>
+    <dgm:txEffectClrLst/>
+  </dgm:styleLbl>
+  <dgm:styleLbl name="parChTrans1D3">
+    <dgm:fillClrLst meth="repeat">
+      <a:schemeClr val="accent2">
+        <a:tint val="70000"/>
+      </a:schemeClr>
+    </dgm:fillClrLst>
+    <dgm:linClrLst meth="repeat">
+      <a:schemeClr val="accent4"/>
+    </dgm:linClrLst>
+    <dgm:effectClrLst/>
+    <dgm:txLinClrLst/>
+    <dgm:txFillClrLst meth="repeat">
+      <a:schemeClr val="tx1"/>
+    </dgm:txFillClrLst>
+    <dgm:txEffectClrLst/>
+  </dgm:styleLbl>
+  <dgm:styleLbl name="parChTrans1D4">
+    <dgm:fillClrLst meth="repeat">
+      <a:schemeClr val="accent2">
+        <a:tint val="50000"/>
+      </a:schemeClr>
+    </dgm:fillClrLst>
+    <dgm:linClrLst meth="repeat">
+      <a:schemeClr val="accent5"/>
+    </dgm:linClrLst>
+    <dgm:effectClrLst/>
+    <dgm:txLinClrLst/>
+    <dgm:txFillClrLst meth="repeat">
+      <a:schemeClr val="tx1"/>
+    </dgm:txFillClrLst>
+    <dgm:txEffectClrLst/>
+  </dgm:styleLbl>
+  <dgm:styleLbl name="fgAcc1">
+    <dgm:fillClrLst meth="repeat">
+      <a:schemeClr val="lt1">
+        <a:alpha val="90000"/>
+      </a:schemeClr>
+    </dgm:fillClrLst>
+    <dgm:linClrLst>
+      <a:schemeClr val="accent2"/>
+      <a:schemeClr val="accent3"/>
+    </dgm:linClrLst>
+    <dgm:effectClrLst/>
+    <dgm:txLinClrLst/>
+    <dgm:txFillClrLst meth="repeat">
+      <a:schemeClr val="dk1"/>
+    </dgm:txFillClrLst>
+    <dgm:txEffectClrLst/>
+  </dgm:styleLbl>
+  <dgm:styleLbl name="conFgAcc1">
+    <dgm:fillClrLst meth="repeat">
+      <a:schemeClr val="lt1">
+        <a:alpha val="90000"/>
+      </a:schemeClr>
+    </dgm:fillClrLst>
+    <dgm:linClrLst>
+      <a:schemeClr val="accent2"/>
+      <a:schemeClr val="accent3"/>
+    </dgm:linClrLst>
+    <dgm:effectClrLst/>
+    <dgm:txLinClrLst/>
+    <dgm:txFillClrLst meth="repeat">
+      <a:schemeClr val="dk1"/>
+    </dgm:txFillClrLst>
+    <dgm:txEffectClrLst/>
+  </dgm:styleLbl>
+  <dgm:styleLbl name="alignAcc1">
+    <dgm:fillClrLst meth="repeat">
+      <a:schemeClr val="lt1">
+        <a:alpha val="90000"/>
+      </a:schemeClr>
+    </dgm:fillClrLst>
+    <dgm:linClrLst>
+      <a:schemeClr val="accent2"/>
+      <a:schemeClr val="accent3"/>
+    </dgm:linClrLst>
+    <dgm:effectClrLst/>
+    <dgm:txLinClrLst/>
+    <dgm:txFillClrLst meth="repeat">
+      <a:schemeClr val="dk1"/>
+    </dgm:txFillClrLst>
+    <dgm:txEffectClrLst/>
+  </dgm:styleLbl>
+  <dgm:styleLbl name="trAlignAcc1">
+    <dgm:fillClrLst meth="repeat">
+      <a:schemeClr val="lt1">
+        <a:alpha val="40000"/>
+      </a:schemeClr>
+    </dgm:fillClrLst>
+    <dgm:linClrLst meth="repeat">
+      <a:schemeClr val="accent2"/>
+    </dgm:linClrLst>
+    <dgm:effectClrLst/>
+    <dgm:txLinClrLst/>
+    <dgm:txFillClrLst meth="repeat">
+      <a:schemeClr val="dk1"/>
+    </dgm:txFillClrLst>
+    <dgm:txEffectClrLst/>
+  </dgm:styleLbl>
+  <dgm:styleLbl name="bgAcc1">
+    <dgm:fillClrLst meth="repeat">
+      <a:schemeClr val="lt1">
+        <a:alpha val="90000"/>
+      </a:schemeClr>
+    </dgm:fillClrLst>
+    <dgm:linClrLst>
+      <a:schemeClr val="accent2"/>
+      <a:schemeClr val="accent3"/>
+    </dgm:linClrLst>
+    <dgm:effectClrLst/>
+    <dgm:txLinClrLst/>
+    <dgm:txFillClrLst meth="repeat">
+      <a:schemeClr val="dk1"/>
+    </dgm:txFillClrLst>
+    <dgm:txEffectClrLst/>
+  </dgm:styleLbl>
+  <dgm:styleLbl name="solidFgAcc1">
+    <dgm:fillClrLst meth="repeat">
+      <a:schemeClr val="lt1"/>
+    </dgm:fillClrLst>
+    <dgm:linClrLst>
+      <a:schemeClr val="accent2"/>
+      <a:schemeClr val="accent3"/>
+    </dgm:linClrLst>
+    <dgm:effectClrLst/>
+    <dgm:txLinClrLst/>
+    <dgm:txFillClrLst meth="repeat">
+      <a:schemeClr val="dk1"/>
+    </dgm:txFillClrLst>
+    <dgm:txEffectClrLst/>
+  </dgm:styleLbl>
+  <dgm:styleLbl name="solidAlignAcc1">
+    <dgm:fillClrLst meth="repeat">
+      <a:schemeClr val="lt1"/>
+    </dgm:fillClrLst>
+    <dgm:linClrLst>
+      <a:schemeClr val="accent2"/>
+      <a:schemeClr val="accent3"/>
+    </dgm:linClrLst>
+    <dgm:effectClrLst/>
+    <dgm:txLinClrLst/>
+    <dgm:txFillClrLst meth="repeat">
+      <a:schemeClr val="dk1"/>
+    </dgm:txFillClrLst>
+    <dgm:txEffectClrLst/>
+  </dgm:styleLbl>
+  <dgm:styleLbl name="solidBgAcc1">
+    <dgm:fillClrLst meth="repeat">
+      <a:schemeClr val="lt1"/>
+    </dgm:fillClrLst>
+    <dgm:linClrLst>
+      <a:schemeClr val="accent2"/>
+      <a:schemeClr val="accent3"/>
+    </dgm:linClrLst>
+    <dgm:effectClrLst/>
+    <dgm:txLinClrLst/>
+    <dgm:txFillClrLst meth="repeat">
+      <a:schemeClr val="dk1"/>
+    </dgm:txFillClrLst>
+    <dgm:txEffectClrLst/>
+  </dgm:styleLbl>
+  <dgm:styleLbl name="fgAccFollowNode1">
+    <dgm:fillClrLst>
+      <a:schemeClr val="accent2">
+        <a:tint val="40000"/>
+        <a:alpha val="90000"/>
+      </a:schemeClr>
+      <a:schemeClr val="accent3">
+        <a:tint val="40000"/>
+        <a:alpha val="90000"/>
+      </a:schemeClr>
+    </dgm:fillClrLst>
+    <dgm:linClrLst>
+      <a:schemeClr val="accent2">
+        <a:tint val="40000"/>
+        <a:alpha val="90000"/>
+      </a:schemeClr>
+      <a:schemeClr val="accent3">
+        <a:tint val="40000"/>
+        <a:alpha val="90000"/>
+      </a:schemeClr>
+    </dgm:linClrLst>
+    <dgm:effectClrLst/>
+    <dgm:txLinClrLst/>
+    <dgm:txFillClrLst meth="repeat">
+      <a:schemeClr val="dk1"/>
+    </dgm:txFillClrLst>
+    <dgm:txEffectClrLst/>
+  </dgm:styleLbl>
+  <dgm:styleLbl name="alignAccFollowNode1">
+    <dgm:fillClrLst>
+      <a:schemeClr val="accent2">
+        <a:tint val="40000"/>
+        <a:alpha val="90000"/>
+      </a:schemeClr>
+      <a:schemeClr val="accent3">
+        <a:tint val="40000"/>
+        <a:alpha val="90000"/>
+      </a:schemeClr>
+    </dgm:fillClrLst>
+    <dgm:linClrLst>
+      <a:schemeClr val="accent2">
+        <a:tint val="40000"/>
+        <a:alpha val="90000"/>
+      </a:schemeClr>
+      <a:schemeClr val="accent3">
+        <a:tint val="40000"/>
+        <a:alpha val="90000"/>
+      </a:schemeClr>
+    </dgm:linClrLst>
+    <dgm:effectClrLst/>
+    <dgm:txLinClrLst/>
+    <dgm:txFillClrLst meth="repeat">
+      <a:schemeClr val="dk1"/>
+    </dgm:txFillClrLst>
+    <dgm:txEffectClrLst/>
+  </dgm:styleLbl>
+  <dgm:styleLbl name="bgAccFollowNode1">
+    <dgm:fillClrLst>
+      <a:schemeClr val="accent2">
+        <a:tint val="40000"/>
+        <a:alpha val="90000"/>
+      </a:schemeClr>
+      <a:schemeClr val="accent3">
+        <a:tint val="40000"/>
+        <a:alpha val="90000"/>
+      </a:schemeClr>
+    </dgm:fillClrLst>
+    <dgm:linClrLst>
+      <a:schemeClr val="accent2">
+        <a:tint val="40000"/>
+        <a:alpha val="90000"/>
+      </a:schemeClr>
+      <a:schemeClr val="accent3">
+        <a:tint val="40000"/>
+        <a:alpha val="90000"/>
+      </a:schemeClr>
+    </dgm:linClrLst>
+    <dgm:effectClrLst/>
+    <dgm:txLinClrLst/>
+    <dgm:txFillClrLst meth="repeat">
+      <a:schemeClr val="dk1"/>
+    </dgm:txFillClrLst>
+    <dgm:txEffectClrLst/>
+  </dgm:styleLbl>
+  <dgm:styleLbl name="fgAcc0">
+    <dgm:fillClrLst meth="repeat">
+      <a:schemeClr val="lt1">
+        <a:alpha val="90000"/>
+      </a:schemeClr>
+    </dgm:fillClrLst>
+    <dgm:linClrLst>
+      <a:schemeClr val="accent1"/>
+    </dgm:linClrLst>
+    <dgm:effectClrLst/>
+    <dgm:txLinClrLst/>
+    <dgm:txFillClrLst meth="repeat">
+      <a:schemeClr val="dk1"/>
+    </dgm:txFillClrLst>
+    <dgm:txEffectClrLst/>
+  </dgm:styleLbl>
+  <dgm:styleLbl name="fgAcc2">
+    <dgm:fillClrLst meth="repeat">
+      <a:schemeClr val="lt1">
+        <a:alpha val="90000"/>
+      </a:schemeClr>
+    </dgm:fillClrLst>
+    <dgm:linClrLst>
+      <a:schemeClr val="accent3"/>
+    </dgm:linClrLst>
+    <dgm:effectClrLst/>
+    <dgm:txLinClrLst/>
+    <dgm:txFillClrLst meth="repeat">
+      <a:schemeClr val="dk1"/>
+    </dgm:txFillClrLst>
+    <dgm:txEffectClrLst/>
+  </dgm:styleLbl>
+  <dgm:styleLbl name="fgAcc3">
+    <dgm:fillClrLst meth="repeat">
+      <a:schemeClr val="lt1">
+        <a:alpha val="90000"/>
+      </a:schemeClr>
+    </dgm:fillClrLst>
+    <dgm:linClrLst>
+      <a:schemeClr val="accent4"/>
+    </dgm:linClrLst>
+    <dgm:effectClrLst/>
+    <dgm:txLinClrLst/>
+    <dgm:txFillClrLst meth="repeat">
+      <a:schemeClr val="dk1"/>
+    </dgm:txFillClrLst>
+    <dgm:txEffectClrLst/>
+  </dgm:styleLbl>
+  <dgm:styleLbl name="fgAcc4">
+    <dgm:fillClrLst meth="repeat">
+      <a:schemeClr val="lt1">
+        <a:alpha val="90000"/>
+      </a:schemeClr>
+    </dgm:fillClrLst>
+    <dgm:linClrLst>
+      <a:schemeClr val="accent5"/>
+    </dgm:linClrLst>
+    <dgm:effectClrLst/>
+    <dgm:txLinClrLst/>
+    <dgm:txFillClrLst meth="repeat">
+      <a:schemeClr val="dk1"/>
+    </dgm:txFillClrLst>
+    <dgm:txEffectClrLst/>
+  </dgm:styleLbl>
+  <dgm:styleLbl name="bgShp">
+    <dgm:fillClrLst meth="repeat">
+      <a:schemeClr val="accent2">
+        <a:tint val="40000"/>
+      </a:schemeClr>
+    </dgm:fillClrLst>
+    <dgm:linClrLst meth="repeat">
+      <a:schemeClr val="dk1"/>
+    </dgm:linClrLst>
+    <dgm:effectClrLst/>
+    <dgm:txLinClrLst/>
+    <dgm:txFillClrLst meth="repeat">
+      <a:schemeClr val="dk1"/>
+    </dgm:txFillClrLst>
+    <dgm:txEffectClrLst/>
+  </dgm:styleLbl>
+  <dgm:styleLbl name="dkBgShp">
+    <dgm:fillClrLst meth="repeat">
+      <a:schemeClr val="accent2">
+        <a:shade val="90000"/>
+      </a:schemeClr>
+    </dgm:fillClrLst>
+    <dgm:linClrLst meth="repeat">
+      <a:schemeClr val="dk1"/>
+    </dgm:linClrLst>
+    <dgm:effectClrLst/>
+    <dgm:txLinClrLst/>
+    <dgm:txFillClrLst meth="repeat">
+      <a:schemeClr val="lt1"/>
+    </dgm:txFillClrLst>
+    <dgm:txEffectClrLst/>
+  </dgm:styleLbl>
+  <dgm:styleLbl name="trBgShp">
+    <dgm:fillClrLst meth="repeat">
+      <a:schemeClr val="accent2">
+        <a:tint val="50000"/>
+        <a:alpha val="40000"/>
+      </a:schemeClr>
+    </dgm:fillClrLst>
+    <dgm:linClrLst meth="repeat">
+      <a:schemeClr val="accent2"/>
+    </dgm:linClrLst>
+    <dgm:effectClrLst/>
+    <dgm:txLinClrLst/>
+    <dgm:txFillClrLst meth="repeat">
+      <a:schemeClr val="lt1"/>
+    </dgm:txFillClrLst>
+    <dgm:txEffectClrLst/>
+  </dgm:styleLbl>
+  <dgm:styleLbl name="fgShp">
+    <dgm:fillClrLst meth="repeat">
+      <a:schemeClr val="accent2">
+        <a:tint val="40000"/>
+      </a:schemeClr>
+    </dgm:fillClrLst>
+    <dgm:linClrLst meth="repeat">
+      <a:schemeClr val="lt1"/>
+    </dgm:linClrLst>
+    <dgm:effectClrLst/>
+    <dgm:txLinClrLst/>
+    <dgm:txFillClrLst meth="repeat">
+      <a:schemeClr val="dk1"/>
+    </dgm:txFillClrLst>
+    <dgm:txEffectClrLst/>
+  </dgm:styleLbl>
+  <dgm:styleLbl name="revTx">
+    <dgm:fillClrLst meth="repeat">
+      <a:schemeClr val="lt1">
+        <a:alpha val="0"/>
+      </a:schemeClr>
+    </dgm:fillClrLst>
+    <dgm:linClrLst meth="repeat">
+      <a:schemeClr val="dk1">
+        <a:alpha val="0"/>
+      </a:schemeClr>
+    </dgm:linClrLst>
+    <dgm:effectClrLst/>
+    <dgm:txLinClrLst/>
+    <dgm:txFillClrLst meth="repeat">
+      <a:schemeClr val="tx1"/>
+    </dgm:txFillClrLst>
+    <dgm:txEffectClrLst/>
+  </dgm:styleLbl>
+</dgm:colorsDef>
+</file>
+
+<file path=ppt/diagrams/colors4.xml><?xml version="1.0" encoding="utf-8"?>
 <dgm:colorsDef xmlns:dgm="http://schemas.openxmlformats.org/drawingml/2006/diagram" xmlns:a="http://schemas.openxmlformats.org/drawingml/2006/main" uniqueId="urn:microsoft.com/office/officeart/2005/8/colors/colorful1">
   <dgm:title val=""/>
   <dgm:desc val=""/>
@@ -3265,6 +4048,180 @@
 </file>
 
 <file path=ppt/diagrams/data3.xml><?xml version="1.0" encoding="utf-8"?>
+<dgm:dataModel xmlns:dgm="http://schemas.openxmlformats.org/drawingml/2006/diagram" xmlns:a="http://schemas.openxmlformats.org/drawingml/2006/main">
+  <dgm:ptLst>
+    <dgm:pt modelId="{F4ACA3A3-C523-4399-B9A3-810A20A8C0D8}" type="doc">
+      <dgm:prSet loTypeId="urn:microsoft.com/office/officeart/2005/8/layout/hierarchy1" loCatId="hierarchy" qsTypeId="urn:microsoft.com/office/officeart/2005/8/quickstyle/simple1" qsCatId="simple" csTypeId="urn:microsoft.com/office/officeart/2005/8/colors/colorful2" csCatId="colorful"/>
+      <dgm:spPr/>
+      <dgm:t>
+        <a:bodyPr/>
+        <a:lstStyle/>
+        <a:p>
+          <a:endParaRPr lang="en-US"/>
+        </a:p>
+      </dgm:t>
+    </dgm:pt>
+    <dgm:pt modelId="{FC396CF3-2130-472D-8BB5-F44AB3645B75}">
+      <dgm:prSet/>
+      <dgm:spPr/>
+      <dgm:t>
+        <a:bodyPr/>
+        <a:lstStyle/>
+        <a:p>
+          <a:r>
+            <a:rPr lang="en-US"/>
+            <a:t>Ultimately, despite our hypothesis, our XGBoost model still struggled to consistently identify Cinderella teams. </a:t>
+          </a:r>
+        </a:p>
+      </dgm:t>
+    </dgm:pt>
+    <dgm:pt modelId="{60E2C6C7-2217-425F-8405-EDBEC5208323}" type="parTrans" cxnId="{7B44718F-334E-4484-9740-96668BF1CF86}">
+      <dgm:prSet/>
+      <dgm:spPr/>
+      <dgm:t>
+        <a:bodyPr/>
+        <a:lstStyle/>
+        <a:p>
+          <a:endParaRPr lang="en-US"/>
+        </a:p>
+      </dgm:t>
+    </dgm:pt>
+    <dgm:pt modelId="{5E84E926-6E1C-49B6-B5E5-BD0762710070}" type="sibTrans" cxnId="{7B44718F-334E-4484-9740-96668BF1CF86}">
+      <dgm:prSet/>
+      <dgm:spPr/>
+      <dgm:t>
+        <a:bodyPr/>
+        <a:lstStyle/>
+        <a:p>
+          <a:endParaRPr lang="en-US"/>
+        </a:p>
+      </dgm:t>
+    </dgm:pt>
+    <dgm:pt modelId="{4BABE728-AE20-457E-862F-ED595B676281}">
+      <dgm:prSet/>
+      <dgm:spPr/>
+      <dgm:t>
+        <a:bodyPr/>
+        <a:lstStyle/>
+        <a:p>
+          <a:r>
+            <a:rPr lang="en-US"/>
+            <a:t>While it performed better than a random guess, it wasn’t drastically better. </a:t>
+          </a:r>
+        </a:p>
+      </dgm:t>
+    </dgm:pt>
+    <dgm:pt modelId="{08FD178D-B3D4-4DE0-A97B-38DA3FB60881}" type="parTrans" cxnId="{C4C6BFD8-DBC8-401B-BAEB-5A70460B0A9E}">
+      <dgm:prSet/>
+      <dgm:spPr/>
+      <dgm:t>
+        <a:bodyPr/>
+        <a:lstStyle/>
+        <a:p>
+          <a:endParaRPr lang="en-US"/>
+        </a:p>
+      </dgm:t>
+    </dgm:pt>
+    <dgm:pt modelId="{1AAFCA55-E135-42D4-A026-A9CA1FBF6D5A}" type="sibTrans" cxnId="{C4C6BFD8-DBC8-401B-BAEB-5A70460B0A9E}">
+      <dgm:prSet/>
+      <dgm:spPr/>
+      <dgm:t>
+        <a:bodyPr/>
+        <a:lstStyle/>
+        <a:p>
+          <a:endParaRPr lang="en-US"/>
+        </a:p>
+      </dgm:t>
+    </dgm:pt>
+    <dgm:pt modelId="{B870DEF7-B568-48C6-8FC5-87A9C7144686}" type="pres">
+      <dgm:prSet presAssocID="{F4ACA3A3-C523-4399-B9A3-810A20A8C0D8}" presName="hierChild1" presStyleCnt="0">
+        <dgm:presLayoutVars>
+          <dgm:chPref val="1"/>
+          <dgm:dir/>
+          <dgm:animOne val="branch"/>
+          <dgm:animLvl val="lvl"/>
+          <dgm:resizeHandles/>
+        </dgm:presLayoutVars>
+      </dgm:prSet>
+      <dgm:spPr/>
+    </dgm:pt>
+    <dgm:pt modelId="{84600E0C-73F6-4DE1-A621-5F69ACDE1865}" type="pres">
+      <dgm:prSet presAssocID="{FC396CF3-2130-472D-8BB5-F44AB3645B75}" presName="hierRoot1" presStyleCnt="0"/>
+      <dgm:spPr/>
+    </dgm:pt>
+    <dgm:pt modelId="{2574BF3F-33C5-46BF-A66E-F42558F38699}" type="pres">
+      <dgm:prSet presAssocID="{FC396CF3-2130-472D-8BB5-F44AB3645B75}" presName="composite" presStyleCnt="0"/>
+      <dgm:spPr/>
+    </dgm:pt>
+    <dgm:pt modelId="{7F92F17A-6998-4BC2-A362-04352AE8FAC2}" type="pres">
+      <dgm:prSet presAssocID="{FC396CF3-2130-472D-8BB5-F44AB3645B75}" presName="background" presStyleLbl="node0" presStyleIdx="0" presStyleCnt="2"/>
+      <dgm:spPr/>
+    </dgm:pt>
+    <dgm:pt modelId="{C1612A79-1CF3-485A-BB2D-65B0D03A50AF}" type="pres">
+      <dgm:prSet presAssocID="{FC396CF3-2130-472D-8BB5-F44AB3645B75}" presName="text" presStyleLbl="fgAcc0" presStyleIdx="0" presStyleCnt="2">
+        <dgm:presLayoutVars>
+          <dgm:chPref val="3"/>
+        </dgm:presLayoutVars>
+      </dgm:prSet>
+      <dgm:spPr/>
+    </dgm:pt>
+    <dgm:pt modelId="{810CC1D7-061B-46D3-9E42-F6BB561BBB79}" type="pres">
+      <dgm:prSet presAssocID="{FC396CF3-2130-472D-8BB5-F44AB3645B75}" presName="hierChild2" presStyleCnt="0"/>
+      <dgm:spPr/>
+    </dgm:pt>
+    <dgm:pt modelId="{339F8818-24CA-4F16-AAE1-BD0FAFA333B0}" type="pres">
+      <dgm:prSet presAssocID="{4BABE728-AE20-457E-862F-ED595B676281}" presName="hierRoot1" presStyleCnt="0"/>
+      <dgm:spPr/>
+    </dgm:pt>
+    <dgm:pt modelId="{AD7AFACD-457C-4847-BC6C-8D2A4B95327C}" type="pres">
+      <dgm:prSet presAssocID="{4BABE728-AE20-457E-862F-ED595B676281}" presName="composite" presStyleCnt="0"/>
+      <dgm:spPr/>
+    </dgm:pt>
+    <dgm:pt modelId="{EB53B146-46D1-4C30-B1BF-DC61C66E6D97}" type="pres">
+      <dgm:prSet presAssocID="{4BABE728-AE20-457E-862F-ED595B676281}" presName="background" presStyleLbl="node0" presStyleIdx="1" presStyleCnt="2"/>
+      <dgm:spPr/>
+    </dgm:pt>
+    <dgm:pt modelId="{020CA961-0403-48B2-B4A4-13A36FCBDD7E}" type="pres">
+      <dgm:prSet presAssocID="{4BABE728-AE20-457E-862F-ED595B676281}" presName="text" presStyleLbl="fgAcc0" presStyleIdx="1" presStyleCnt="2">
+        <dgm:presLayoutVars>
+          <dgm:chPref val="3"/>
+        </dgm:presLayoutVars>
+      </dgm:prSet>
+      <dgm:spPr/>
+    </dgm:pt>
+    <dgm:pt modelId="{00B8055C-205B-464C-B7C1-9EF97DB09311}" type="pres">
+      <dgm:prSet presAssocID="{4BABE728-AE20-457E-862F-ED595B676281}" presName="hierChild2" presStyleCnt="0"/>
+      <dgm:spPr/>
+    </dgm:pt>
+  </dgm:ptLst>
+  <dgm:cxnLst>
+    <dgm:cxn modelId="{D9AFF00E-60E3-455E-9CA2-2010011A35B4}" type="presOf" srcId="{F4ACA3A3-C523-4399-B9A3-810A20A8C0D8}" destId="{B870DEF7-B568-48C6-8FC5-87A9C7144686}" srcOrd="0" destOrd="0" presId="urn:microsoft.com/office/officeart/2005/8/layout/hierarchy1"/>
+    <dgm:cxn modelId="{7B44718F-334E-4484-9740-96668BF1CF86}" srcId="{F4ACA3A3-C523-4399-B9A3-810A20A8C0D8}" destId="{FC396CF3-2130-472D-8BB5-F44AB3645B75}" srcOrd="0" destOrd="0" parTransId="{60E2C6C7-2217-425F-8405-EDBEC5208323}" sibTransId="{5E84E926-6E1C-49B6-B5E5-BD0762710070}"/>
+    <dgm:cxn modelId="{5FB0F891-B91F-4FC8-8C37-A5EAEDBCC7AA}" type="presOf" srcId="{FC396CF3-2130-472D-8BB5-F44AB3645B75}" destId="{C1612A79-1CF3-485A-BB2D-65B0D03A50AF}" srcOrd="0" destOrd="0" presId="urn:microsoft.com/office/officeart/2005/8/layout/hierarchy1"/>
+    <dgm:cxn modelId="{C4C6BFD8-DBC8-401B-BAEB-5A70460B0A9E}" srcId="{F4ACA3A3-C523-4399-B9A3-810A20A8C0D8}" destId="{4BABE728-AE20-457E-862F-ED595B676281}" srcOrd="1" destOrd="0" parTransId="{08FD178D-B3D4-4DE0-A97B-38DA3FB60881}" sibTransId="{1AAFCA55-E135-42D4-A026-A9CA1FBF6D5A}"/>
+    <dgm:cxn modelId="{812B15E3-3709-4102-BB0A-C978B1385319}" type="presOf" srcId="{4BABE728-AE20-457E-862F-ED595B676281}" destId="{020CA961-0403-48B2-B4A4-13A36FCBDD7E}" srcOrd="0" destOrd="0" presId="urn:microsoft.com/office/officeart/2005/8/layout/hierarchy1"/>
+    <dgm:cxn modelId="{178B04D2-878D-4BF8-8648-C9CCA8886A4D}" type="presParOf" srcId="{B870DEF7-B568-48C6-8FC5-87A9C7144686}" destId="{84600E0C-73F6-4DE1-A621-5F69ACDE1865}" srcOrd="0" destOrd="0" presId="urn:microsoft.com/office/officeart/2005/8/layout/hierarchy1"/>
+    <dgm:cxn modelId="{CF0E9070-4E5D-41BA-9F65-2F94E5ACE39B}" type="presParOf" srcId="{84600E0C-73F6-4DE1-A621-5F69ACDE1865}" destId="{2574BF3F-33C5-46BF-A66E-F42558F38699}" srcOrd="0" destOrd="0" presId="urn:microsoft.com/office/officeart/2005/8/layout/hierarchy1"/>
+    <dgm:cxn modelId="{C4E87152-A135-49D6-8377-28227FC637F0}" type="presParOf" srcId="{2574BF3F-33C5-46BF-A66E-F42558F38699}" destId="{7F92F17A-6998-4BC2-A362-04352AE8FAC2}" srcOrd="0" destOrd="0" presId="urn:microsoft.com/office/officeart/2005/8/layout/hierarchy1"/>
+    <dgm:cxn modelId="{6BE1598E-555C-4FE2-AC1C-C4F6EB9E251C}" type="presParOf" srcId="{2574BF3F-33C5-46BF-A66E-F42558F38699}" destId="{C1612A79-1CF3-485A-BB2D-65B0D03A50AF}" srcOrd="1" destOrd="0" presId="urn:microsoft.com/office/officeart/2005/8/layout/hierarchy1"/>
+    <dgm:cxn modelId="{FA33CF50-3DD3-4D4F-9364-21D28F5321B7}" type="presParOf" srcId="{84600E0C-73F6-4DE1-A621-5F69ACDE1865}" destId="{810CC1D7-061B-46D3-9E42-F6BB561BBB79}" srcOrd="1" destOrd="0" presId="urn:microsoft.com/office/officeart/2005/8/layout/hierarchy1"/>
+    <dgm:cxn modelId="{BD97C2DF-F4A9-4D90-902C-974AD863456A}" type="presParOf" srcId="{B870DEF7-B568-48C6-8FC5-87A9C7144686}" destId="{339F8818-24CA-4F16-AAE1-BD0FAFA333B0}" srcOrd="1" destOrd="0" presId="urn:microsoft.com/office/officeart/2005/8/layout/hierarchy1"/>
+    <dgm:cxn modelId="{09AB2E30-0E3D-478D-88B2-AF48093E7350}" type="presParOf" srcId="{339F8818-24CA-4F16-AAE1-BD0FAFA333B0}" destId="{AD7AFACD-457C-4847-BC6C-8D2A4B95327C}" srcOrd="0" destOrd="0" presId="urn:microsoft.com/office/officeart/2005/8/layout/hierarchy1"/>
+    <dgm:cxn modelId="{AB222D1D-F99D-4D5F-995D-890AD09AA927}" type="presParOf" srcId="{AD7AFACD-457C-4847-BC6C-8D2A4B95327C}" destId="{EB53B146-46D1-4C30-B1BF-DC61C66E6D97}" srcOrd="0" destOrd="0" presId="urn:microsoft.com/office/officeart/2005/8/layout/hierarchy1"/>
+    <dgm:cxn modelId="{BB6191F3-04B6-4D8A-A032-A1955BE69368}" type="presParOf" srcId="{AD7AFACD-457C-4847-BC6C-8D2A4B95327C}" destId="{020CA961-0403-48B2-B4A4-13A36FCBDD7E}" srcOrd="1" destOrd="0" presId="urn:microsoft.com/office/officeart/2005/8/layout/hierarchy1"/>
+    <dgm:cxn modelId="{44F890BA-E120-4F93-B3C5-5806E4DAF85E}" type="presParOf" srcId="{339F8818-24CA-4F16-AAE1-BD0FAFA333B0}" destId="{00B8055C-205B-464C-B7C1-9EF97DB09311}" srcOrd="1" destOrd="0" presId="urn:microsoft.com/office/officeart/2005/8/layout/hierarchy1"/>
+  </dgm:cxnLst>
+  <dgm:bg/>
+  <dgm:whole/>
+  <dgm:extLst>
+    <a:ext uri="http://schemas.microsoft.com/office/drawing/2008/diagram">
+      <dsp:dataModelExt xmlns:dsp="http://schemas.microsoft.com/office/drawing/2008/diagram" relId="rId6" minVer="http://schemas.openxmlformats.org/drawingml/2006/diagram"/>
+    </a:ext>
+  </dgm:extLst>
+</dgm:dataModel>
+</file>
+
+<file path=ppt/diagrams/data4.xml><?xml version="1.0" encoding="utf-8"?>
 <dgm:dataModel xmlns:dgm="http://schemas.openxmlformats.org/drawingml/2006/diagram" xmlns:a="http://schemas.openxmlformats.org/drawingml/2006/main">
   <dgm:ptLst>
     <dgm:pt modelId="{9A956502-3703-4132-AC03-69BF4A493969}" type="doc">
@@ -4582,6 +5539,280 @@
 </file>
 
 <file path=ppt/diagrams/drawing3.xml><?xml version="1.0" encoding="utf-8"?>
+<dsp:drawing xmlns:dgm="http://schemas.openxmlformats.org/drawingml/2006/diagram" xmlns:dsp="http://schemas.microsoft.com/office/drawing/2008/diagram" xmlns:a="http://schemas.openxmlformats.org/drawingml/2006/main">
+  <dsp:spTree>
+    <dsp:nvGrpSpPr>
+      <dsp:cNvPr id="0" name=""/>
+      <dsp:cNvGrpSpPr/>
+    </dsp:nvGrpSpPr>
+    <dsp:grpSpPr/>
+    <dsp:sp modelId="{7F92F17A-6998-4BC2-A362-04352AE8FAC2}">
+      <dsp:nvSpPr>
+        <dsp:cNvPr id="0" name=""/>
+        <dsp:cNvSpPr/>
+      </dsp:nvSpPr>
+      <dsp:spPr>
+        <a:xfrm>
+          <a:off x="134291" y="612"/>
+          <a:ext cx="4332795" cy="2751325"/>
+        </a:xfrm>
+        <a:prstGeom prst="roundRect">
+          <a:avLst>
+            <a:gd name="adj" fmla="val 10000"/>
+          </a:avLst>
+        </a:prstGeom>
+        <a:solidFill>
+          <a:schemeClr val="accent1">
+            <a:hueOff val="0"/>
+            <a:satOff val="0"/>
+            <a:lumOff val="0"/>
+            <a:alphaOff val="0"/>
+          </a:schemeClr>
+        </a:solidFill>
+        <a:ln w="19050" cap="flat" cmpd="sng" algn="ctr">
+          <a:solidFill>
+            <a:schemeClr val="lt1">
+              <a:hueOff val="0"/>
+              <a:satOff val="0"/>
+              <a:lumOff val="0"/>
+              <a:alphaOff val="0"/>
+            </a:schemeClr>
+          </a:solidFill>
+          <a:prstDash val="solid"/>
+          <a:miter lim="800000"/>
+        </a:ln>
+        <a:effectLst/>
+      </dsp:spPr>
+      <dsp:style>
+        <a:lnRef idx="2">
+          <a:scrgbClr r="0" g="0" b="0"/>
+        </a:lnRef>
+        <a:fillRef idx="1">
+          <a:scrgbClr r="0" g="0" b="0"/>
+        </a:fillRef>
+        <a:effectRef idx="0">
+          <a:scrgbClr r="0" g="0" b="0"/>
+        </a:effectRef>
+        <a:fontRef idx="minor">
+          <a:schemeClr val="lt1"/>
+        </a:fontRef>
+      </dsp:style>
+    </dsp:sp>
+    <dsp:sp modelId="{C1612A79-1CF3-485A-BB2D-65B0D03A50AF}">
+      <dsp:nvSpPr>
+        <dsp:cNvPr id="0" name=""/>
+        <dsp:cNvSpPr/>
+      </dsp:nvSpPr>
+      <dsp:spPr>
+        <a:xfrm>
+          <a:off x="615713" y="457963"/>
+          <a:ext cx="4332795" cy="2751325"/>
+        </a:xfrm>
+        <a:prstGeom prst="roundRect">
+          <a:avLst>
+            <a:gd name="adj" fmla="val 10000"/>
+          </a:avLst>
+        </a:prstGeom>
+        <a:solidFill>
+          <a:schemeClr val="lt1">
+            <a:alpha val="90000"/>
+            <a:hueOff val="0"/>
+            <a:satOff val="0"/>
+            <a:lumOff val="0"/>
+            <a:alphaOff val="0"/>
+          </a:schemeClr>
+        </a:solidFill>
+        <a:ln w="19050" cap="flat" cmpd="sng" algn="ctr">
+          <a:solidFill>
+            <a:schemeClr val="accent1">
+              <a:hueOff val="0"/>
+              <a:satOff val="0"/>
+              <a:lumOff val="0"/>
+              <a:alphaOff val="0"/>
+            </a:schemeClr>
+          </a:solidFill>
+          <a:prstDash val="solid"/>
+          <a:miter lim="800000"/>
+        </a:ln>
+        <a:effectLst/>
+      </dsp:spPr>
+      <dsp:style>
+        <a:lnRef idx="2">
+          <a:scrgbClr r="0" g="0" b="0"/>
+        </a:lnRef>
+        <a:fillRef idx="1">
+          <a:scrgbClr r="0" g="0" b="0"/>
+        </a:fillRef>
+        <a:effectRef idx="0">
+          <a:scrgbClr r="0" g="0" b="0"/>
+        </a:effectRef>
+        <a:fontRef idx="minor"/>
+      </dsp:style>
+      <dsp:txBody>
+        <a:bodyPr spcFirstLastPara="0" vert="horz" wrap="square" lIns="110490" tIns="110490" rIns="110490" bIns="110490" numCol="1" spcCol="1270" anchor="ctr" anchorCtr="0">
+          <a:noAutofit/>
+        </a:bodyPr>
+        <a:lstStyle/>
+        <a:p>
+          <a:pPr marL="0" lvl="0" indent="0" algn="ctr" defTabSz="1289050">
+            <a:lnSpc>
+              <a:spcPct val="90000"/>
+            </a:lnSpc>
+            <a:spcBef>
+              <a:spcPct val="0"/>
+            </a:spcBef>
+            <a:spcAft>
+              <a:spcPct val="35000"/>
+            </a:spcAft>
+            <a:buNone/>
+          </a:pPr>
+          <a:r>
+            <a:rPr lang="en-US" sz="2900" kern="1200"/>
+            <a:t>Ultimately, despite our hypothesis, our XGBoost model still struggled to consistently identify Cinderella teams. </a:t>
+          </a:r>
+        </a:p>
+      </dsp:txBody>
+      <dsp:txXfrm>
+        <a:off x="696297" y="538547"/>
+        <a:ext cx="4171627" cy="2590157"/>
+      </dsp:txXfrm>
+    </dsp:sp>
+    <dsp:sp modelId="{EB53B146-46D1-4C30-B1BF-DC61C66E6D97}">
+      <dsp:nvSpPr>
+        <dsp:cNvPr id="0" name=""/>
+        <dsp:cNvSpPr/>
+      </dsp:nvSpPr>
+      <dsp:spPr>
+        <a:xfrm>
+          <a:off x="5429930" y="612"/>
+          <a:ext cx="4332795" cy="2751325"/>
+        </a:xfrm>
+        <a:prstGeom prst="roundRect">
+          <a:avLst>
+            <a:gd name="adj" fmla="val 10000"/>
+          </a:avLst>
+        </a:prstGeom>
+        <a:solidFill>
+          <a:schemeClr val="accent1">
+            <a:hueOff val="0"/>
+            <a:satOff val="0"/>
+            <a:lumOff val="0"/>
+            <a:alphaOff val="0"/>
+          </a:schemeClr>
+        </a:solidFill>
+        <a:ln w="19050" cap="flat" cmpd="sng" algn="ctr">
+          <a:solidFill>
+            <a:schemeClr val="lt1">
+              <a:hueOff val="0"/>
+              <a:satOff val="0"/>
+              <a:lumOff val="0"/>
+              <a:alphaOff val="0"/>
+            </a:schemeClr>
+          </a:solidFill>
+          <a:prstDash val="solid"/>
+          <a:miter lim="800000"/>
+        </a:ln>
+        <a:effectLst/>
+      </dsp:spPr>
+      <dsp:style>
+        <a:lnRef idx="2">
+          <a:scrgbClr r="0" g="0" b="0"/>
+        </a:lnRef>
+        <a:fillRef idx="1">
+          <a:scrgbClr r="0" g="0" b="0"/>
+        </a:fillRef>
+        <a:effectRef idx="0">
+          <a:scrgbClr r="0" g="0" b="0"/>
+        </a:effectRef>
+        <a:fontRef idx="minor">
+          <a:schemeClr val="lt1"/>
+        </a:fontRef>
+      </dsp:style>
+    </dsp:sp>
+    <dsp:sp modelId="{020CA961-0403-48B2-B4A4-13A36FCBDD7E}">
+      <dsp:nvSpPr>
+        <dsp:cNvPr id="0" name=""/>
+        <dsp:cNvSpPr/>
+      </dsp:nvSpPr>
+      <dsp:spPr>
+        <a:xfrm>
+          <a:off x="5911352" y="457963"/>
+          <a:ext cx="4332795" cy="2751325"/>
+        </a:xfrm>
+        <a:prstGeom prst="roundRect">
+          <a:avLst>
+            <a:gd name="adj" fmla="val 10000"/>
+          </a:avLst>
+        </a:prstGeom>
+        <a:solidFill>
+          <a:schemeClr val="lt1">
+            <a:alpha val="90000"/>
+            <a:hueOff val="0"/>
+            <a:satOff val="0"/>
+            <a:lumOff val="0"/>
+            <a:alphaOff val="0"/>
+          </a:schemeClr>
+        </a:solidFill>
+        <a:ln w="19050" cap="flat" cmpd="sng" algn="ctr">
+          <a:solidFill>
+            <a:schemeClr val="accent1">
+              <a:hueOff val="0"/>
+              <a:satOff val="0"/>
+              <a:lumOff val="0"/>
+              <a:alphaOff val="0"/>
+            </a:schemeClr>
+          </a:solidFill>
+          <a:prstDash val="solid"/>
+          <a:miter lim="800000"/>
+        </a:ln>
+        <a:effectLst/>
+      </dsp:spPr>
+      <dsp:style>
+        <a:lnRef idx="2">
+          <a:scrgbClr r="0" g="0" b="0"/>
+        </a:lnRef>
+        <a:fillRef idx="1">
+          <a:scrgbClr r="0" g="0" b="0"/>
+        </a:fillRef>
+        <a:effectRef idx="0">
+          <a:scrgbClr r="0" g="0" b="0"/>
+        </a:effectRef>
+        <a:fontRef idx="minor"/>
+      </dsp:style>
+      <dsp:txBody>
+        <a:bodyPr spcFirstLastPara="0" vert="horz" wrap="square" lIns="110490" tIns="110490" rIns="110490" bIns="110490" numCol="1" spcCol="1270" anchor="ctr" anchorCtr="0">
+          <a:noAutofit/>
+        </a:bodyPr>
+        <a:lstStyle/>
+        <a:p>
+          <a:pPr marL="0" lvl="0" indent="0" algn="ctr" defTabSz="1289050">
+            <a:lnSpc>
+              <a:spcPct val="90000"/>
+            </a:lnSpc>
+            <a:spcBef>
+              <a:spcPct val="0"/>
+            </a:spcBef>
+            <a:spcAft>
+              <a:spcPct val="35000"/>
+            </a:spcAft>
+            <a:buNone/>
+          </a:pPr>
+          <a:r>
+            <a:rPr lang="en-US" sz="2900" kern="1200"/>
+            <a:t>While it performed better than a random guess, it wasn’t drastically better. </a:t>
+          </a:r>
+        </a:p>
+      </dsp:txBody>
+      <dsp:txXfrm>
+        <a:off x="5991936" y="538547"/>
+        <a:ext cx="4171627" cy="2590157"/>
+      </dsp:txXfrm>
+    </dsp:sp>
+  </dsp:spTree>
+</dsp:drawing>
+</file>
+
+<file path=ppt/diagrams/drawing4.xml><?xml version="1.0" encoding="utf-8"?>
 <dsp:drawing xmlns:dgm="http://schemas.openxmlformats.org/drawingml/2006/diagram" xmlns:dsp="http://schemas.microsoft.com/office/drawing/2008/diagram" xmlns:a="http://schemas.openxmlformats.org/drawingml/2006/main">
   <dsp:spTree>
     <dsp:nvGrpSpPr>
@@ -6010,6 +7241,569 @@
 </dgm:layoutDef>
 </file>
 
+<file path=ppt/diagrams/layout4.xml><?xml version="1.0" encoding="utf-8"?>
+<dgm:layoutDef xmlns:dgm="http://schemas.openxmlformats.org/drawingml/2006/diagram" xmlns:a="http://schemas.openxmlformats.org/drawingml/2006/main" uniqueId="urn:microsoft.com/office/officeart/2005/8/layout/hierarchy1">
+  <dgm:title val=""/>
+  <dgm:desc val=""/>
+  <dgm:catLst>
+    <dgm:cat type="hierarchy" pri="2000"/>
+  </dgm:catLst>
+  <dgm:sampData>
+    <dgm:dataModel>
+      <dgm:ptLst>
+        <dgm:pt modelId="0" type="doc"/>
+        <dgm:pt modelId="1">
+          <dgm:prSet phldr="1"/>
+        </dgm:pt>
+        <dgm:pt modelId="2">
+          <dgm:prSet phldr="1"/>
+        </dgm:pt>
+        <dgm:pt modelId="21">
+          <dgm:prSet phldr="1"/>
+        </dgm:pt>
+        <dgm:pt modelId="22">
+          <dgm:prSet phldr="1"/>
+        </dgm:pt>
+        <dgm:pt modelId="3">
+          <dgm:prSet phldr="1"/>
+        </dgm:pt>
+        <dgm:pt modelId="31">
+          <dgm:prSet phldr="1"/>
+        </dgm:pt>
+      </dgm:ptLst>
+      <dgm:cxnLst>
+        <dgm:cxn modelId="4" srcId="0" destId="1" srcOrd="0" destOrd="0"/>
+        <dgm:cxn modelId="5" srcId="1" destId="2" srcOrd="0" destOrd="0"/>
+        <dgm:cxn modelId="6" srcId="1" destId="3" srcOrd="1" destOrd="0"/>
+        <dgm:cxn modelId="23" srcId="2" destId="21" srcOrd="0" destOrd="0"/>
+        <dgm:cxn modelId="24" srcId="2" destId="22" srcOrd="1" destOrd="0"/>
+        <dgm:cxn modelId="33" srcId="3" destId="31" srcOrd="0" destOrd="0"/>
+      </dgm:cxnLst>
+      <dgm:bg/>
+      <dgm:whole/>
+    </dgm:dataModel>
+  </dgm:sampData>
+  <dgm:styleData>
+    <dgm:dataModel>
+      <dgm:ptLst>
+        <dgm:pt modelId="0" type="doc"/>
+        <dgm:pt modelId="1"/>
+        <dgm:pt modelId="11"/>
+        <dgm:pt modelId="12"/>
+      </dgm:ptLst>
+      <dgm:cxnLst>
+        <dgm:cxn modelId="2" srcId="0" destId="1" srcOrd="0" destOrd="0"/>
+        <dgm:cxn modelId="13" srcId="1" destId="11" srcOrd="0" destOrd="0"/>
+        <dgm:cxn modelId="14" srcId="1" destId="12" srcOrd="1" destOrd="0"/>
+      </dgm:cxnLst>
+      <dgm:bg/>
+      <dgm:whole/>
+    </dgm:dataModel>
+  </dgm:styleData>
+  <dgm:clrData>
+    <dgm:dataModel>
+      <dgm:ptLst>
+        <dgm:pt modelId="0" type="doc"/>
+        <dgm:pt modelId="1"/>
+        <dgm:pt modelId="2"/>
+        <dgm:pt modelId="21"/>
+        <dgm:pt modelId="211"/>
+        <dgm:pt modelId="3"/>
+        <dgm:pt modelId="31"/>
+        <dgm:pt modelId="311"/>
+      </dgm:ptLst>
+      <dgm:cxnLst>
+        <dgm:cxn modelId="4" srcId="0" destId="1" srcOrd="0" destOrd="0"/>
+        <dgm:cxn modelId="5" srcId="1" destId="2" srcOrd="0" destOrd="0"/>
+        <dgm:cxn modelId="6" srcId="1" destId="3" srcOrd="1" destOrd="0"/>
+        <dgm:cxn modelId="23" srcId="2" destId="21" srcOrd="0" destOrd="0"/>
+        <dgm:cxn modelId="24" srcId="21" destId="211" srcOrd="0" destOrd="0"/>
+        <dgm:cxn modelId="33" srcId="3" destId="31" srcOrd="0" destOrd="0"/>
+        <dgm:cxn modelId="34" srcId="31" destId="311" srcOrd="0" destOrd="0"/>
+      </dgm:cxnLst>
+      <dgm:bg/>
+      <dgm:whole/>
+    </dgm:dataModel>
+  </dgm:clrData>
+  <dgm:layoutNode name="hierChild1">
+    <dgm:varLst>
+      <dgm:chPref val="1"/>
+      <dgm:dir/>
+      <dgm:animOne val="branch"/>
+      <dgm:animLvl val="lvl"/>
+      <dgm:resizeHandles/>
+    </dgm:varLst>
+    <dgm:choose name="Name0">
+      <dgm:if name="Name1" func="var" arg="dir" op="equ" val="norm">
+        <dgm:alg type="hierChild">
+          <dgm:param type="linDir" val="fromL"/>
+        </dgm:alg>
+      </dgm:if>
+      <dgm:else name="Name2">
+        <dgm:alg type="hierChild">
+          <dgm:param type="linDir" val="fromR"/>
+        </dgm:alg>
+      </dgm:else>
+    </dgm:choose>
+    <dgm:shape xmlns:r="http://schemas.openxmlformats.org/officeDocument/2006/relationships" r:blip="">
+      <dgm:adjLst/>
+    </dgm:shape>
+    <dgm:presOf/>
+    <dgm:constrLst>
+      <dgm:constr type="primFontSz" for="des" ptType="node" op="equ" val="65"/>
+      <dgm:constr type="w" for="des" forName="composite" refType="w"/>
+      <dgm:constr type="h" for="des" forName="composite" refType="w" refFor="des" refForName="composite" fact="0.667"/>
+      <dgm:constr type="w" for="des" forName="composite2" refType="w" refFor="des" refForName="composite"/>
+      <dgm:constr type="h" for="des" forName="composite2" refType="h" refFor="des" refForName="composite"/>
+      <dgm:constr type="w" for="des" forName="composite3" refType="w" refFor="des" refForName="composite"/>
+      <dgm:constr type="h" for="des" forName="composite3" refType="h" refFor="des" refForName="composite"/>
+      <dgm:constr type="w" for="des" forName="composite4" refType="w" refFor="des" refForName="composite"/>
+      <dgm:constr type="h" for="des" forName="composite4" refType="h" refFor="des" refForName="composite"/>
+      <dgm:constr type="w" for="des" forName="composite5" refType="w" refFor="des" refForName="composite"/>
+      <dgm:constr type="h" for="des" forName="composite5" refType="h" refFor="des" refForName="composite"/>
+      <dgm:constr type="sibSp" refType="w" refFor="des" refForName="composite" fact="0.1"/>
+      <dgm:constr type="sibSp" for="des" forName="hierChild2" refType="sibSp"/>
+      <dgm:constr type="sibSp" for="des" forName="hierChild3" refType="sibSp"/>
+      <dgm:constr type="sibSp" for="des" forName="hierChild4" refType="sibSp"/>
+      <dgm:constr type="sibSp" for="des" forName="hierChild5" refType="sibSp"/>
+      <dgm:constr type="sibSp" for="des" forName="hierChild6" refType="sibSp"/>
+      <dgm:constr type="sp" for="des" forName="hierRoot1" refType="h" refFor="des" refForName="composite" fact="0.25"/>
+      <dgm:constr type="sp" for="des" forName="hierRoot2" refType="sp" refFor="des" refForName="hierRoot1"/>
+      <dgm:constr type="sp" for="des" forName="hierRoot3" refType="sp" refFor="des" refForName="hierRoot1"/>
+      <dgm:constr type="sp" for="des" forName="hierRoot4" refType="sp" refFor="des" refForName="hierRoot1"/>
+      <dgm:constr type="sp" for="des" forName="hierRoot5" refType="sp" refFor="des" refForName="hierRoot1"/>
+    </dgm:constrLst>
+    <dgm:ruleLst/>
+    <dgm:forEach name="Name3" axis="ch">
+      <dgm:forEach name="Name4" axis="self" ptType="node">
+        <dgm:layoutNode name="hierRoot1">
+          <dgm:alg type="hierRoot"/>
+          <dgm:shape xmlns:r="http://schemas.openxmlformats.org/officeDocument/2006/relationships" r:blip="">
+            <dgm:adjLst/>
+          </dgm:shape>
+          <dgm:presOf/>
+          <dgm:constrLst>
+            <dgm:constr type="bendDist" for="des" ptType="parTrans" refType="sp" fact="0.5"/>
+          </dgm:constrLst>
+          <dgm:ruleLst/>
+          <dgm:layoutNode name="composite">
+            <dgm:alg type="composite"/>
+            <dgm:shape xmlns:r="http://schemas.openxmlformats.org/officeDocument/2006/relationships" r:blip="">
+              <dgm:adjLst/>
+            </dgm:shape>
+            <dgm:presOf/>
+            <dgm:constrLst>
+              <dgm:constr type="w" for="ch" forName="background" refType="w" fact="0.9"/>
+              <dgm:constr type="h" for="ch" forName="background" refType="w" refFor="ch" refForName="background" fact="0.635"/>
+              <dgm:constr type="t" for="ch" forName="background"/>
+              <dgm:constr type="l" for="ch" forName="background"/>
+              <dgm:constr type="w" for="ch" forName="text" refType="w" fact="0.9"/>
+              <dgm:constr type="h" for="ch" forName="text" refType="w" refFor="ch" refForName="text" fact="0.635"/>
+              <dgm:constr type="t" for="ch" forName="text" refType="w" fact="0.095"/>
+              <dgm:constr type="l" for="ch" forName="text" refType="w" fact="0.1"/>
+            </dgm:constrLst>
+            <dgm:ruleLst/>
+            <dgm:layoutNode name="background" styleLbl="node0" moveWith="text">
+              <dgm:alg type="sp"/>
+              <dgm:shape xmlns:r="http://schemas.openxmlformats.org/officeDocument/2006/relationships" type="roundRect" r:blip="">
+                <dgm:adjLst>
+                  <dgm:adj idx="1" val="0.1"/>
+                </dgm:adjLst>
+              </dgm:shape>
+              <dgm:presOf/>
+              <dgm:constrLst/>
+              <dgm:ruleLst/>
+            </dgm:layoutNode>
+            <dgm:layoutNode name="text" styleLbl="fgAcc0">
+              <dgm:varLst>
+                <dgm:chPref val="3"/>
+              </dgm:varLst>
+              <dgm:alg type="tx"/>
+              <dgm:shape xmlns:r="http://schemas.openxmlformats.org/officeDocument/2006/relationships" type="roundRect" r:blip="">
+                <dgm:adjLst>
+                  <dgm:adj idx="1" val="0.1"/>
+                </dgm:adjLst>
+              </dgm:shape>
+              <dgm:presOf axis="self"/>
+              <dgm:constrLst>
+                <dgm:constr type="tMarg" refType="primFontSz" fact="0.3"/>
+                <dgm:constr type="bMarg" refType="primFontSz" fact="0.3"/>
+                <dgm:constr type="lMarg" refType="primFontSz" fact="0.3"/>
+                <dgm:constr type="rMarg" refType="primFontSz" fact="0.3"/>
+              </dgm:constrLst>
+              <dgm:ruleLst>
+                <dgm:rule type="primFontSz" val="5" fact="NaN" max="NaN"/>
+              </dgm:ruleLst>
+            </dgm:layoutNode>
+          </dgm:layoutNode>
+          <dgm:layoutNode name="hierChild2">
+            <dgm:choose name="Name5">
+              <dgm:if name="Name6" func="var" arg="dir" op="equ" val="norm">
+                <dgm:alg type="hierChild">
+                  <dgm:param type="linDir" val="fromL"/>
+                </dgm:alg>
+              </dgm:if>
+              <dgm:else name="Name7">
+                <dgm:alg type="hierChild">
+                  <dgm:param type="linDir" val="fromR"/>
+                </dgm:alg>
+              </dgm:else>
+            </dgm:choose>
+            <dgm:shape xmlns:r="http://schemas.openxmlformats.org/officeDocument/2006/relationships" r:blip="">
+              <dgm:adjLst/>
+            </dgm:shape>
+            <dgm:presOf/>
+            <dgm:constrLst/>
+            <dgm:ruleLst/>
+            <dgm:forEach name="Name8" axis="ch">
+              <dgm:forEach name="Name9" axis="self" ptType="parTrans" cnt="1">
+                <dgm:layoutNode name="Name10">
+                  <dgm:alg type="conn">
+                    <dgm:param type="dim" val="1D"/>
+                    <dgm:param type="endSty" val="noArr"/>
+                    <dgm:param type="connRout" val="bend"/>
+                    <dgm:param type="bendPt" val="end"/>
+                    <dgm:param type="begPts" val="bCtr"/>
+                    <dgm:param type="endPts" val="tCtr"/>
+                    <dgm:param type="srcNode" val="background"/>
+                    <dgm:param type="dstNode" val="background2"/>
+                  </dgm:alg>
+                  <dgm:shape xmlns:r="http://schemas.openxmlformats.org/officeDocument/2006/relationships" type="conn" r:blip="" zOrderOff="-999">
+                    <dgm:adjLst/>
+                  </dgm:shape>
+                  <dgm:presOf axis="self"/>
+                  <dgm:constrLst>
+                    <dgm:constr type="begPad"/>
+                    <dgm:constr type="endPad"/>
+                  </dgm:constrLst>
+                  <dgm:ruleLst/>
+                </dgm:layoutNode>
+              </dgm:forEach>
+              <dgm:forEach name="Name11" axis="self" ptType="node">
+                <dgm:layoutNode name="hierRoot2">
+                  <dgm:alg type="hierRoot"/>
+                  <dgm:shape xmlns:r="http://schemas.openxmlformats.org/officeDocument/2006/relationships" r:blip="">
+                    <dgm:adjLst/>
+                  </dgm:shape>
+                  <dgm:presOf/>
+                  <dgm:constrLst>
+                    <dgm:constr type="bendDist" for="des" ptType="parTrans" refType="sp" fact="0.5"/>
+                  </dgm:constrLst>
+                  <dgm:ruleLst/>
+                  <dgm:layoutNode name="composite2">
+                    <dgm:alg type="composite"/>
+                    <dgm:shape xmlns:r="http://schemas.openxmlformats.org/officeDocument/2006/relationships" r:blip="">
+                      <dgm:adjLst/>
+                    </dgm:shape>
+                    <dgm:presOf/>
+                    <dgm:constrLst>
+                      <dgm:constr type="w" for="ch" forName="background2" refType="w" fact="0.9"/>
+                      <dgm:constr type="h" for="ch" forName="background2" refType="w" refFor="ch" refForName="background2" fact="0.635"/>
+                      <dgm:constr type="t" for="ch" forName="background2"/>
+                      <dgm:constr type="l" for="ch" forName="background2"/>
+                      <dgm:constr type="w" for="ch" forName="text2" refType="w" fact="0.9"/>
+                      <dgm:constr type="h" for="ch" forName="text2" refType="w" refFor="ch" refForName="text2" fact="0.635"/>
+                      <dgm:constr type="t" for="ch" forName="text2" refType="w" fact="0.095"/>
+                      <dgm:constr type="l" for="ch" forName="text2" refType="w" fact="0.1"/>
+                    </dgm:constrLst>
+                    <dgm:ruleLst/>
+                    <dgm:layoutNode name="background2" moveWith="text2">
+                      <dgm:alg type="sp"/>
+                      <dgm:shape xmlns:r="http://schemas.openxmlformats.org/officeDocument/2006/relationships" type="roundRect" r:blip="">
+                        <dgm:adjLst>
+                          <dgm:adj idx="1" val="0.1"/>
+                        </dgm:adjLst>
+                      </dgm:shape>
+                      <dgm:presOf/>
+                      <dgm:constrLst/>
+                      <dgm:ruleLst/>
+                    </dgm:layoutNode>
+                    <dgm:layoutNode name="text2" styleLbl="fgAcc2">
+                      <dgm:varLst>
+                        <dgm:chPref val="3"/>
+                      </dgm:varLst>
+                      <dgm:alg type="tx"/>
+                      <dgm:shape xmlns:r="http://schemas.openxmlformats.org/officeDocument/2006/relationships" type="roundRect" r:blip="">
+                        <dgm:adjLst>
+                          <dgm:adj idx="1" val="0.1"/>
+                        </dgm:adjLst>
+                      </dgm:shape>
+                      <dgm:presOf axis="self"/>
+                      <dgm:constrLst>
+                        <dgm:constr type="tMarg" refType="primFontSz" fact="0.3"/>
+                        <dgm:constr type="bMarg" refType="primFontSz" fact="0.3"/>
+                        <dgm:constr type="lMarg" refType="primFontSz" fact="0.3"/>
+                        <dgm:constr type="rMarg" refType="primFontSz" fact="0.3"/>
+                      </dgm:constrLst>
+                      <dgm:ruleLst>
+                        <dgm:rule type="primFontSz" val="5" fact="NaN" max="NaN"/>
+                      </dgm:ruleLst>
+                    </dgm:layoutNode>
+                  </dgm:layoutNode>
+                  <dgm:layoutNode name="hierChild3">
+                    <dgm:choose name="Name12">
+                      <dgm:if name="Name13" func="var" arg="dir" op="equ" val="norm">
+                        <dgm:alg type="hierChild">
+                          <dgm:param type="linDir" val="fromL"/>
+                        </dgm:alg>
+                      </dgm:if>
+                      <dgm:else name="Name14">
+                        <dgm:alg type="hierChild">
+                          <dgm:param type="linDir" val="fromR"/>
+                        </dgm:alg>
+                      </dgm:else>
+                    </dgm:choose>
+                    <dgm:shape xmlns:r="http://schemas.openxmlformats.org/officeDocument/2006/relationships" r:blip="">
+                      <dgm:adjLst/>
+                    </dgm:shape>
+                    <dgm:presOf/>
+                    <dgm:constrLst/>
+                    <dgm:ruleLst/>
+                    <dgm:forEach name="Name15" axis="ch">
+                      <dgm:forEach name="Name16" axis="self" ptType="parTrans" cnt="1">
+                        <dgm:layoutNode name="Name17">
+                          <dgm:alg type="conn">
+                            <dgm:param type="dim" val="1D"/>
+                            <dgm:param type="endSty" val="noArr"/>
+                            <dgm:param type="connRout" val="bend"/>
+                            <dgm:param type="bendPt" val="end"/>
+                            <dgm:param type="begPts" val="bCtr"/>
+                            <dgm:param type="endPts" val="tCtr"/>
+                            <dgm:param type="srcNode" val="background2"/>
+                            <dgm:param type="dstNode" val="background3"/>
+                          </dgm:alg>
+                          <dgm:shape xmlns:r="http://schemas.openxmlformats.org/officeDocument/2006/relationships" type="conn" r:blip="" zOrderOff="-999">
+                            <dgm:adjLst/>
+                          </dgm:shape>
+                          <dgm:presOf axis="self"/>
+                          <dgm:constrLst>
+                            <dgm:constr type="begPad"/>
+                            <dgm:constr type="endPad"/>
+                          </dgm:constrLst>
+                          <dgm:ruleLst/>
+                        </dgm:layoutNode>
+                      </dgm:forEach>
+                      <dgm:forEach name="Name18" axis="self" ptType="node">
+                        <dgm:layoutNode name="hierRoot3">
+                          <dgm:alg type="hierRoot"/>
+                          <dgm:shape xmlns:r="http://schemas.openxmlformats.org/officeDocument/2006/relationships" r:blip="">
+                            <dgm:adjLst/>
+                          </dgm:shape>
+                          <dgm:presOf/>
+                          <dgm:constrLst>
+                            <dgm:constr type="bendDist" for="des" ptType="parTrans" refType="sp" fact="0.5"/>
+                          </dgm:constrLst>
+                          <dgm:ruleLst/>
+                          <dgm:layoutNode name="composite3">
+                            <dgm:alg type="composite"/>
+                            <dgm:shape xmlns:r="http://schemas.openxmlformats.org/officeDocument/2006/relationships" r:blip="">
+                              <dgm:adjLst/>
+                            </dgm:shape>
+                            <dgm:presOf/>
+                            <dgm:constrLst>
+                              <dgm:constr type="w" for="ch" forName="background3" refType="w" fact="0.9"/>
+                              <dgm:constr type="h" for="ch" forName="background3" refType="w" refFor="ch" refForName="background3" fact="0.635"/>
+                              <dgm:constr type="t" for="ch" forName="background3"/>
+                              <dgm:constr type="l" for="ch" forName="background3"/>
+                              <dgm:constr type="w" for="ch" forName="text3" refType="w" fact="0.9"/>
+                              <dgm:constr type="h" for="ch" forName="text3" refType="w" refFor="ch" refForName="text3" fact="0.635"/>
+                              <dgm:constr type="t" for="ch" forName="text3" refType="w" fact="0.095"/>
+                              <dgm:constr type="l" for="ch" forName="text3" refType="w" fact="0.1"/>
+                            </dgm:constrLst>
+                            <dgm:ruleLst/>
+                            <dgm:layoutNode name="background3" moveWith="text3">
+                              <dgm:alg type="sp"/>
+                              <dgm:shape xmlns:r="http://schemas.openxmlformats.org/officeDocument/2006/relationships" type="roundRect" r:blip="">
+                                <dgm:adjLst>
+                                  <dgm:adj idx="1" val="0.1"/>
+                                </dgm:adjLst>
+                              </dgm:shape>
+                              <dgm:presOf/>
+                              <dgm:constrLst/>
+                              <dgm:ruleLst/>
+                            </dgm:layoutNode>
+                            <dgm:layoutNode name="text3" styleLbl="fgAcc3">
+                              <dgm:varLst>
+                                <dgm:chPref val="3"/>
+                              </dgm:varLst>
+                              <dgm:alg type="tx"/>
+                              <dgm:shape xmlns:r="http://schemas.openxmlformats.org/officeDocument/2006/relationships" type="roundRect" r:blip="">
+                                <dgm:adjLst>
+                                  <dgm:adj idx="1" val="0.1"/>
+                                </dgm:adjLst>
+                              </dgm:shape>
+                              <dgm:presOf axis="self"/>
+                              <dgm:constrLst>
+                                <dgm:constr type="tMarg" refType="primFontSz" fact="0.3"/>
+                                <dgm:constr type="bMarg" refType="primFontSz" fact="0.3"/>
+                                <dgm:constr type="lMarg" refType="primFontSz" fact="0.3"/>
+                                <dgm:constr type="rMarg" refType="primFontSz" fact="0.3"/>
+                              </dgm:constrLst>
+                              <dgm:ruleLst>
+                                <dgm:rule type="primFontSz" val="5" fact="NaN" max="NaN"/>
+                              </dgm:ruleLst>
+                            </dgm:layoutNode>
+                          </dgm:layoutNode>
+                          <dgm:layoutNode name="hierChild4">
+                            <dgm:choose name="Name19">
+                              <dgm:if name="Name20" func="var" arg="dir" op="equ" val="norm">
+                                <dgm:alg type="hierChild">
+                                  <dgm:param type="linDir" val="fromL"/>
+                                </dgm:alg>
+                              </dgm:if>
+                              <dgm:else name="Name21">
+                                <dgm:alg type="hierChild">
+                                  <dgm:param type="linDir" val="fromR"/>
+                                </dgm:alg>
+                              </dgm:else>
+                            </dgm:choose>
+                            <dgm:shape xmlns:r="http://schemas.openxmlformats.org/officeDocument/2006/relationships" r:blip="">
+                              <dgm:adjLst/>
+                            </dgm:shape>
+                            <dgm:presOf/>
+                            <dgm:constrLst/>
+                            <dgm:ruleLst/>
+                            <dgm:forEach name="repeat" axis="ch">
+                              <dgm:forEach name="Name22" axis="self" ptType="parTrans" cnt="1">
+                                <dgm:layoutNode name="Name23">
+                                  <dgm:choose name="Name24">
+                                    <dgm:if name="Name25" axis="self" func="depth" op="lte" val="4">
+                                      <dgm:alg type="conn">
+                                        <dgm:param type="dim" val="1D"/>
+                                        <dgm:param type="endSty" val="noArr"/>
+                                        <dgm:param type="connRout" val="bend"/>
+                                        <dgm:param type="bendPt" val="end"/>
+                                        <dgm:param type="begPts" val="bCtr"/>
+                                        <dgm:param type="endPts" val="tCtr"/>
+                                        <dgm:param type="srcNode" val="background3"/>
+                                        <dgm:param type="dstNode" val="background4"/>
+                                      </dgm:alg>
+                                    </dgm:if>
+                                    <dgm:else name="Name26">
+                                      <dgm:alg type="conn">
+                                        <dgm:param type="dim" val="1D"/>
+                                        <dgm:param type="endSty" val="noArr"/>
+                                        <dgm:param type="connRout" val="bend"/>
+                                        <dgm:param type="bendPt" val="end"/>
+                                        <dgm:param type="begPts" val="bCtr"/>
+                                        <dgm:param type="endPts" val="tCtr"/>
+                                        <dgm:param type="srcNode" val="background4"/>
+                                        <dgm:param type="dstNode" val="background4"/>
+                                      </dgm:alg>
+                                    </dgm:else>
+                                  </dgm:choose>
+                                  <dgm:shape xmlns:r="http://schemas.openxmlformats.org/officeDocument/2006/relationships" type="conn" r:blip="" zOrderOff="-999">
+                                    <dgm:adjLst/>
+                                  </dgm:shape>
+                                  <dgm:presOf axis="self"/>
+                                  <dgm:constrLst>
+                                    <dgm:constr type="begPad"/>
+                                    <dgm:constr type="endPad"/>
+                                  </dgm:constrLst>
+                                  <dgm:ruleLst/>
+                                </dgm:layoutNode>
+                              </dgm:forEach>
+                              <dgm:forEach name="Name27" axis="self" ptType="node">
+                                <dgm:layoutNode name="hierRoot4">
+                                  <dgm:alg type="hierRoot"/>
+                                  <dgm:shape xmlns:r="http://schemas.openxmlformats.org/officeDocument/2006/relationships" r:blip="">
+                                    <dgm:adjLst/>
+                                  </dgm:shape>
+                                  <dgm:presOf/>
+                                  <dgm:constrLst>
+                                    <dgm:constr type="bendDist" for="des" ptType="parTrans" refType="sp" fact="0.5"/>
+                                  </dgm:constrLst>
+                                  <dgm:ruleLst/>
+                                  <dgm:layoutNode name="composite4">
+                                    <dgm:alg type="composite"/>
+                                    <dgm:shape xmlns:r="http://schemas.openxmlformats.org/officeDocument/2006/relationships" r:blip="">
+                                      <dgm:adjLst/>
+                                    </dgm:shape>
+                                    <dgm:presOf/>
+                                    <dgm:constrLst>
+                                      <dgm:constr type="w" for="ch" forName="background4" refType="w" fact="0.9"/>
+                                      <dgm:constr type="h" for="ch" forName="background4" refType="w" refFor="ch" refForName="background4" fact="0.635"/>
+                                      <dgm:constr type="t" for="ch" forName="background4"/>
+                                      <dgm:constr type="l" for="ch" forName="background4"/>
+                                      <dgm:constr type="w" for="ch" forName="text4" refType="w" fact="0.9"/>
+                                      <dgm:constr type="h" for="ch" forName="text4" refType="w" refFor="ch" refForName="text4" fact="0.635"/>
+                                      <dgm:constr type="t" for="ch" forName="text4" refType="w" fact="0.095"/>
+                                      <dgm:constr type="l" for="ch" forName="text4" refType="w" fact="0.1"/>
+                                    </dgm:constrLst>
+                                    <dgm:ruleLst/>
+                                    <dgm:layoutNode name="background4" moveWith="text4">
+                                      <dgm:alg type="sp"/>
+                                      <dgm:shape xmlns:r="http://schemas.openxmlformats.org/officeDocument/2006/relationships" type="roundRect" r:blip="">
+                                        <dgm:adjLst>
+                                          <dgm:adj idx="1" val="0.1"/>
+                                        </dgm:adjLst>
+                                      </dgm:shape>
+                                      <dgm:presOf/>
+                                      <dgm:constrLst/>
+                                      <dgm:ruleLst/>
+                                    </dgm:layoutNode>
+                                    <dgm:layoutNode name="text4" styleLbl="fgAcc4">
+                                      <dgm:varLst>
+                                        <dgm:chPref val="3"/>
+                                      </dgm:varLst>
+                                      <dgm:alg type="tx"/>
+                                      <dgm:shape xmlns:r="http://schemas.openxmlformats.org/officeDocument/2006/relationships" type="roundRect" r:blip="">
+                                        <dgm:adjLst>
+                                          <dgm:adj idx="1" val="0.1"/>
+                                        </dgm:adjLst>
+                                      </dgm:shape>
+                                      <dgm:presOf axis="self"/>
+                                      <dgm:constrLst>
+                                        <dgm:constr type="tMarg" refType="primFontSz" fact="0.3"/>
+                                        <dgm:constr type="bMarg" refType="primFontSz" fact="0.3"/>
+                                        <dgm:constr type="lMarg" refType="primFontSz" fact="0.3"/>
+                                        <dgm:constr type="rMarg" refType="primFontSz" fact="0.3"/>
+                                      </dgm:constrLst>
+                                      <dgm:ruleLst>
+                                        <dgm:rule type="primFontSz" val="5" fact="NaN" max="NaN"/>
+                                      </dgm:ruleLst>
+                                    </dgm:layoutNode>
+                                  </dgm:layoutNode>
+                                  <dgm:layoutNode name="hierChild5">
+                                    <dgm:choose name="Name28">
+                                      <dgm:if name="Name29" func="var" arg="dir" op="equ" val="norm">
+                                        <dgm:alg type="hierChild">
+                                          <dgm:param type="linDir" val="fromL"/>
+                                        </dgm:alg>
+                                      </dgm:if>
+                                      <dgm:else name="Name30">
+                                        <dgm:alg type="hierChild">
+                                          <dgm:param type="linDir" val="fromR"/>
+                                        </dgm:alg>
+                                      </dgm:else>
+                                    </dgm:choose>
+                                    <dgm:shape xmlns:r="http://schemas.openxmlformats.org/officeDocument/2006/relationships" r:blip="">
+                                      <dgm:adjLst/>
+                                    </dgm:shape>
+                                    <dgm:presOf/>
+                                    <dgm:constrLst/>
+                                    <dgm:ruleLst/>
+                                    <dgm:forEach name="Name31" ref="repeat"/>
+                                  </dgm:layoutNode>
+                                </dgm:layoutNode>
+                              </dgm:forEach>
+                            </dgm:forEach>
+                          </dgm:layoutNode>
+                        </dgm:layoutNode>
+                      </dgm:forEach>
+                    </dgm:forEach>
+                  </dgm:layoutNode>
+                </dgm:layoutNode>
+              </dgm:forEach>
+            </dgm:forEach>
+          </dgm:layoutNode>
+        </dgm:layoutNode>
+      </dgm:forEach>
+    </dgm:forEach>
+  </dgm:layoutNode>
+</dgm:layoutDef>
+</file>
+
 <file path=ppt/diagrams/quickStyle1.xml><?xml version="1.0" encoding="utf-8"?>
 <dgm:styleDef xmlns:dgm="http://schemas.openxmlformats.org/drawingml/2006/diagram" xmlns:a="http://schemas.openxmlformats.org/drawingml/2006/main" uniqueId="urn:microsoft.com/office/officeart/2005/8/quickstyle/simple1">
   <dgm:title val=""/>
@@ -8079,6 +9873,1040 @@
 </file>
 
 <file path=ppt/diagrams/quickStyle3.xml><?xml version="1.0" encoding="utf-8"?>
+<dgm:styleDef xmlns:dgm="http://schemas.openxmlformats.org/drawingml/2006/diagram" xmlns:a="http://schemas.openxmlformats.org/drawingml/2006/main" uniqueId="urn:microsoft.com/office/officeart/2005/8/quickstyle/simple1">
+  <dgm:title val=""/>
+  <dgm:desc val=""/>
+  <dgm:catLst>
+    <dgm:cat type="simple" pri="10100"/>
+  </dgm:catLst>
+  <dgm:scene3d>
+    <a:camera prst="orthographicFront"/>
+    <a:lightRig rig="threePt" dir="t"/>
+  </dgm:scene3d>
+  <dgm:styleLbl name="node0">
+    <dgm:scene3d>
+      <a:camera prst="orthographicFront"/>
+      <a:lightRig rig="threePt" dir="t"/>
+    </dgm:scene3d>
+    <dgm:sp3d/>
+    <dgm:txPr/>
+    <dgm:style>
+      <a:lnRef idx="2">
+        <a:scrgbClr r="0" g="0" b="0"/>
+      </a:lnRef>
+      <a:fillRef idx="1">
+        <a:scrgbClr r="0" g="0" b="0"/>
+      </a:fillRef>
+      <a:effectRef idx="0">
+        <a:scrgbClr r="0" g="0" b="0"/>
+      </a:effectRef>
+      <a:fontRef idx="minor">
+        <a:schemeClr val="lt1"/>
+      </a:fontRef>
+    </dgm:style>
+  </dgm:styleLbl>
+  <dgm:styleLbl name="lnNode1">
+    <dgm:scene3d>
+      <a:camera prst="orthographicFront"/>
+      <a:lightRig rig="threePt" dir="t"/>
+    </dgm:scene3d>
+    <dgm:sp3d/>
+    <dgm:txPr/>
+    <dgm:style>
+      <a:lnRef idx="2">
+        <a:scrgbClr r="0" g="0" b="0"/>
+      </a:lnRef>
+      <a:fillRef idx="1">
+        <a:scrgbClr r="0" g="0" b="0"/>
+      </a:fillRef>
+      <a:effectRef idx="0">
+        <a:scrgbClr r="0" g="0" b="0"/>
+      </a:effectRef>
+      <a:fontRef idx="minor">
+        <a:schemeClr val="lt1"/>
+      </a:fontRef>
+    </dgm:style>
+  </dgm:styleLbl>
+  <dgm:styleLbl name="vennNode1">
+    <dgm:scene3d>
+      <a:camera prst="orthographicFront"/>
+      <a:lightRig rig="threePt" dir="t"/>
+    </dgm:scene3d>
+    <dgm:sp3d/>
+    <dgm:txPr/>
+    <dgm:style>
+      <a:lnRef idx="2">
+        <a:scrgbClr r="0" g="0" b="0"/>
+      </a:lnRef>
+      <a:fillRef idx="1">
+        <a:scrgbClr r="0" g="0" b="0"/>
+      </a:fillRef>
+      <a:effectRef idx="0">
+        <a:scrgbClr r="0" g="0" b="0"/>
+      </a:effectRef>
+      <a:fontRef idx="minor">
+        <a:schemeClr val="tx1"/>
+      </a:fontRef>
+    </dgm:style>
+  </dgm:styleLbl>
+  <dgm:styleLbl name="alignNode1">
+    <dgm:scene3d>
+      <a:camera prst="orthographicFront"/>
+      <a:lightRig rig="threePt" dir="t"/>
+    </dgm:scene3d>
+    <dgm:sp3d/>
+    <dgm:txPr/>
+    <dgm:style>
+      <a:lnRef idx="2">
+        <a:scrgbClr r="0" g="0" b="0"/>
+      </a:lnRef>
+      <a:fillRef idx="1">
+        <a:scrgbClr r="0" g="0" b="0"/>
+      </a:fillRef>
+      <a:effectRef idx="0">
+        <a:scrgbClr r="0" g="0" b="0"/>
+      </a:effectRef>
+      <a:fontRef idx="minor">
+        <a:schemeClr val="lt1"/>
+      </a:fontRef>
+    </dgm:style>
+  </dgm:styleLbl>
+  <dgm:styleLbl name="node1">
+    <dgm:scene3d>
+      <a:camera prst="orthographicFront"/>
+      <a:lightRig rig="threePt" dir="t"/>
+    </dgm:scene3d>
+    <dgm:sp3d/>
+    <dgm:txPr/>
+    <dgm:style>
+      <a:lnRef idx="2">
+        <a:scrgbClr r="0" g="0" b="0"/>
+      </a:lnRef>
+      <a:fillRef idx="1">
+        <a:scrgbClr r="0" g="0" b="0"/>
+      </a:fillRef>
+      <a:effectRef idx="0">
+        <a:scrgbClr r="0" g="0" b="0"/>
+      </a:effectRef>
+      <a:fontRef idx="minor">
+        <a:schemeClr val="lt1"/>
+      </a:fontRef>
+    </dgm:style>
+  </dgm:styleLbl>
+  <dgm:styleLbl name="node2">
+    <dgm:scene3d>
+      <a:camera prst="orthographicFront"/>
+      <a:lightRig rig="threePt" dir="t"/>
+    </dgm:scene3d>
+    <dgm:sp3d/>
+    <dgm:txPr/>
+    <dgm:style>
+      <a:lnRef idx="2">
+        <a:scrgbClr r="0" g="0" b="0"/>
+      </a:lnRef>
+      <a:fillRef idx="1">
+        <a:scrgbClr r="0" g="0" b="0"/>
+      </a:fillRef>
+      <a:effectRef idx="0">
+        <a:scrgbClr r="0" g="0" b="0"/>
+      </a:effectRef>
+      <a:fontRef idx="minor">
+        <a:schemeClr val="lt1"/>
+      </a:fontRef>
+    </dgm:style>
+  </dgm:styleLbl>
+  <dgm:styleLbl name="node3">
+    <dgm:scene3d>
+      <a:camera prst="orthographicFront"/>
+      <a:lightRig rig="threePt" dir="t"/>
+    </dgm:scene3d>
+    <dgm:sp3d/>
+    <dgm:txPr/>
+    <dgm:style>
+      <a:lnRef idx="2">
+        <a:scrgbClr r="0" g="0" b="0"/>
+      </a:lnRef>
+      <a:fillRef idx="1">
+        <a:scrgbClr r="0" g="0" b="0"/>
+      </a:fillRef>
+      <a:effectRef idx="0">
+        <a:scrgbClr r="0" g="0" b="0"/>
+      </a:effectRef>
+      <a:fontRef idx="minor">
+        <a:schemeClr val="lt1"/>
+      </a:fontRef>
+    </dgm:style>
+  </dgm:styleLbl>
+  <dgm:styleLbl name="node4">
+    <dgm:scene3d>
+      <a:camera prst="orthographicFront"/>
+      <a:lightRig rig="threePt" dir="t"/>
+    </dgm:scene3d>
+    <dgm:sp3d/>
+    <dgm:txPr/>
+    <dgm:style>
+      <a:lnRef idx="2">
+        <a:scrgbClr r="0" g="0" b="0"/>
+      </a:lnRef>
+      <a:fillRef idx="1">
+        <a:scrgbClr r="0" g="0" b="0"/>
+      </a:fillRef>
+      <a:effectRef idx="0">
+        <a:scrgbClr r="0" g="0" b="0"/>
+      </a:effectRef>
+      <a:fontRef idx="minor">
+        <a:schemeClr val="lt1"/>
+      </a:fontRef>
+    </dgm:style>
+  </dgm:styleLbl>
+  <dgm:styleLbl name="fgImgPlace1">
+    <dgm:scene3d>
+      <a:camera prst="orthographicFront"/>
+      <a:lightRig rig="threePt" dir="t"/>
+    </dgm:scene3d>
+    <dgm:sp3d/>
+    <dgm:txPr/>
+    <dgm:style>
+      <a:lnRef idx="2">
+        <a:scrgbClr r="0" g="0" b="0"/>
+      </a:lnRef>
+      <a:fillRef idx="1">
+        <a:scrgbClr r="0" g="0" b="0"/>
+      </a:fillRef>
+      <a:effectRef idx="0">
+        <a:scrgbClr r="0" g="0" b="0"/>
+      </a:effectRef>
+      <a:fontRef idx="minor"/>
+    </dgm:style>
+  </dgm:styleLbl>
+  <dgm:styleLbl name="alignImgPlace1">
+    <dgm:scene3d>
+      <a:camera prst="orthographicFront"/>
+      <a:lightRig rig="threePt" dir="t"/>
+    </dgm:scene3d>
+    <dgm:sp3d/>
+    <dgm:txPr/>
+    <dgm:style>
+      <a:lnRef idx="2">
+        <a:scrgbClr r="0" g="0" b="0"/>
+      </a:lnRef>
+      <a:fillRef idx="1">
+        <a:scrgbClr r="0" g="0" b="0"/>
+      </a:fillRef>
+      <a:effectRef idx="0">
+        <a:scrgbClr r="0" g="0" b="0"/>
+      </a:effectRef>
+      <a:fontRef idx="minor"/>
+    </dgm:style>
+  </dgm:styleLbl>
+  <dgm:styleLbl name="bgImgPlace1">
+    <dgm:scene3d>
+      <a:camera prst="orthographicFront"/>
+      <a:lightRig rig="threePt" dir="t"/>
+    </dgm:scene3d>
+    <dgm:sp3d/>
+    <dgm:txPr/>
+    <dgm:style>
+      <a:lnRef idx="2">
+        <a:scrgbClr r="0" g="0" b="0"/>
+      </a:lnRef>
+      <a:fillRef idx="1">
+        <a:scrgbClr r="0" g="0" b="0"/>
+      </a:fillRef>
+      <a:effectRef idx="0">
+        <a:scrgbClr r="0" g="0" b="0"/>
+      </a:effectRef>
+      <a:fontRef idx="minor"/>
+    </dgm:style>
+  </dgm:styleLbl>
+  <dgm:styleLbl name="sibTrans2D1">
+    <dgm:scene3d>
+      <a:camera prst="orthographicFront"/>
+      <a:lightRig rig="threePt" dir="t"/>
+    </dgm:scene3d>
+    <dgm:sp3d/>
+    <dgm:txPr/>
+    <dgm:style>
+      <a:lnRef idx="0">
+        <a:scrgbClr r="0" g="0" b="0"/>
+      </a:lnRef>
+      <a:fillRef idx="1">
+        <a:scrgbClr r="0" g="0" b="0"/>
+      </a:fillRef>
+      <a:effectRef idx="0">
+        <a:scrgbClr r="0" g="0" b="0"/>
+      </a:effectRef>
+      <a:fontRef idx="minor">
+        <a:schemeClr val="lt1"/>
+      </a:fontRef>
+    </dgm:style>
+  </dgm:styleLbl>
+  <dgm:styleLbl name="fgSibTrans2D1">
+    <dgm:scene3d>
+      <a:camera prst="orthographicFront"/>
+      <a:lightRig rig="threePt" dir="t"/>
+    </dgm:scene3d>
+    <dgm:sp3d/>
+    <dgm:txPr/>
+    <dgm:style>
+      <a:lnRef idx="0">
+        <a:scrgbClr r="0" g="0" b="0"/>
+      </a:lnRef>
+      <a:fillRef idx="1">
+        <a:scrgbClr r="0" g="0" b="0"/>
+      </a:fillRef>
+      <a:effectRef idx="0">
+        <a:scrgbClr r="0" g="0" b="0"/>
+      </a:effectRef>
+      <a:fontRef idx="minor">
+        <a:schemeClr val="lt1"/>
+      </a:fontRef>
+    </dgm:style>
+  </dgm:styleLbl>
+  <dgm:styleLbl name="bgSibTrans2D1">
+    <dgm:scene3d>
+      <a:camera prst="orthographicFront"/>
+      <a:lightRig rig="threePt" dir="t"/>
+    </dgm:scene3d>
+    <dgm:sp3d/>
+    <dgm:txPr/>
+    <dgm:style>
+      <a:lnRef idx="0">
+        <a:scrgbClr r="0" g="0" b="0"/>
+      </a:lnRef>
+      <a:fillRef idx="1">
+        <a:scrgbClr r="0" g="0" b="0"/>
+      </a:fillRef>
+      <a:effectRef idx="0">
+        <a:scrgbClr r="0" g="0" b="0"/>
+      </a:effectRef>
+      <a:fontRef idx="minor">
+        <a:schemeClr val="lt1"/>
+      </a:fontRef>
+    </dgm:style>
+  </dgm:styleLbl>
+  <dgm:styleLbl name="sibTrans1D1">
+    <dgm:scene3d>
+      <a:camera prst="orthographicFront"/>
+      <a:lightRig rig="threePt" dir="t"/>
+    </dgm:scene3d>
+    <dgm:sp3d/>
+    <dgm:txPr/>
+    <dgm:style>
+      <a:lnRef idx="1">
+        <a:scrgbClr r="0" g="0" b="0"/>
+      </a:lnRef>
+      <a:fillRef idx="0">
+        <a:scrgbClr r="0" g="0" b="0"/>
+      </a:fillRef>
+      <a:effectRef idx="0">
+        <a:scrgbClr r="0" g="0" b="0"/>
+      </a:effectRef>
+      <a:fontRef idx="minor"/>
+    </dgm:style>
+  </dgm:styleLbl>
+  <dgm:styleLbl name="callout">
+    <dgm:scene3d>
+      <a:camera prst="orthographicFront"/>
+      <a:lightRig rig="threePt" dir="t"/>
+    </dgm:scene3d>
+    <dgm:sp3d/>
+    <dgm:txPr/>
+    <dgm:style>
+      <a:lnRef idx="2">
+        <a:scrgbClr r="0" g="0" b="0"/>
+      </a:lnRef>
+      <a:fillRef idx="1">
+        <a:scrgbClr r="0" g="0" b="0"/>
+      </a:fillRef>
+      <a:effectRef idx="0">
+        <a:scrgbClr r="0" g="0" b="0"/>
+      </a:effectRef>
+      <a:fontRef idx="minor"/>
+    </dgm:style>
+  </dgm:styleLbl>
+  <dgm:styleLbl name="asst0">
+    <dgm:scene3d>
+      <a:camera prst="orthographicFront"/>
+      <a:lightRig rig="threePt" dir="t"/>
+    </dgm:scene3d>
+    <dgm:sp3d/>
+    <dgm:txPr/>
+    <dgm:style>
+      <a:lnRef idx="2">
+        <a:scrgbClr r="0" g="0" b="0"/>
+      </a:lnRef>
+      <a:fillRef idx="1">
+        <a:scrgbClr r="0" g="0" b="0"/>
+      </a:fillRef>
+      <a:effectRef idx="0">
+        <a:scrgbClr r="0" g="0" b="0"/>
+      </a:effectRef>
+      <a:fontRef idx="minor">
+        <a:schemeClr val="lt1"/>
+      </a:fontRef>
+    </dgm:style>
+  </dgm:styleLbl>
+  <dgm:styleLbl name="asst1">
+    <dgm:scene3d>
+      <a:camera prst="orthographicFront"/>
+      <a:lightRig rig="threePt" dir="t"/>
+    </dgm:scene3d>
+    <dgm:sp3d/>
+    <dgm:txPr/>
+    <dgm:style>
+      <a:lnRef idx="2">
+        <a:scrgbClr r="0" g="0" b="0"/>
+      </a:lnRef>
+      <a:fillRef idx="1">
+        <a:scrgbClr r="0" g="0" b="0"/>
+      </a:fillRef>
+      <a:effectRef idx="0">
+        <a:scrgbClr r="0" g="0" b="0"/>
+      </a:effectRef>
+      <a:fontRef idx="minor">
+        <a:schemeClr val="lt1"/>
+      </a:fontRef>
+    </dgm:style>
+  </dgm:styleLbl>
+  <dgm:styleLbl name="asst2">
+    <dgm:scene3d>
+      <a:camera prst="orthographicFront"/>
+      <a:lightRig rig="threePt" dir="t"/>
+    </dgm:scene3d>
+    <dgm:sp3d/>
+    <dgm:txPr/>
+    <dgm:style>
+      <a:lnRef idx="2">
+        <a:scrgbClr r="0" g="0" b="0"/>
+      </a:lnRef>
+      <a:fillRef idx="1">
+        <a:scrgbClr r="0" g="0" b="0"/>
+      </a:fillRef>
+      <a:effectRef idx="0">
+        <a:scrgbClr r="0" g="0" b="0"/>
+      </a:effectRef>
+      <a:fontRef idx="minor">
+        <a:schemeClr val="lt1"/>
+      </a:fontRef>
+    </dgm:style>
+  </dgm:styleLbl>
+  <dgm:styleLbl name="asst3">
+    <dgm:scene3d>
+      <a:camera prst="orthographicFront"/>
+      <a:lightRig rig="threePt" dir="t"/>
+    </dgm:scene3d>
+    <dgm:sp3d/>
+    <dgm:txPr/>
+    <dgm:style>
+      <a:lnRef idx="2">
+        <a:scrgbClr r="0" g="0" b="0"/>
+      </a:lnRef>
+      <a:fillRef idx="1">
+        <a:scrgbClr r="0" g="0" b="0"/>
+      </a:fillRef>
+      <a:effectRef idx="0">
+        <a:scrgbClr r="0" g="0" b="0"/>
+      </a:effectRef>
+      <a:fontRef idx="minor">
+        <a:schemeClr val="lt1"/>
+      </a:fontRef>
+    </dgm:style>
+  </dgm:styleLbl>
+  <dgm:styleLbl name="asst4">
+    <dgm:scene3d>
+      <a:camera prst="orthographicFront"/>
+      <a:lightRig rig="threePt" dir="t"/>
+    </dgm:scene3d>
+    <dgm:sp3d/>
+    <dgm:txPr/>
+    <dgm:style>
+      <a:lnRef idx="2">
+        <a:scrgbClr r="0" g="0" b="0"/>
+      </a:lnRef>
+      <a:fillRef idx="1">
+        <a:scrgbClr r="0" g="0" b="0"/>
+      </a:fillRef>
+      <a:effectRef idx="0">
+        <a:scrgbClr r="0" g="0" b="0"/>
+      </a:effectRef>
+      <a:fontRef idx="minor">
+        <a:schemeClr val="lt1"/>
+      </a:fontRef>
+    </dgm:style>
+  </dgm:styleLbl>
+  <dgm:styleLbl name="parChTrans2D1">
+    <dgm:scene3d>
+      <a:camera prst="orthographicFront"/>
+      <a:lightRig rig="threePt" dir="t"/>
+    </dgm:scene3d>
+    <dgm:sp3d/>
+    <dgm:txPr/>
+    <dgm:style>
+      <a:lnRef idx="2">
+        <a:scrgbClr r="0" g="0" b="0"/>
+      </a:lnRef>
+      <a:fillRef idx="1">
+        <a:scrgbClr r="0" g="0" b="0"/>
+      </a:fillRef>
+      <a:effectRef idx="0">
+        <a:scrgbClr r="0" g="0" b="0"/>
+      </a:effectRef>
+      <a:fontRef idx="minor">
+        <a:schemeClr val="lt1"/>
+      </a:fontRef>
+    </dgm:style>
+  </dgm:styleLbl>
+  <dgm:styleLbl name="parChTrans2D2">
+    <dgm:scene3d>
+      <a:camera prst="orthographicFront"/>
+      <a:lightRig rig="threePt" dir="t"/>
+    </dgm:scene3d>
+    <dgm:sp3d/>
+    <dgm:txPr/>
+    <dgm:style>
+      <a:lnRef idx="2">
+        <a:scrgbClr r="0" g="0" b="0"/>
+      </a:lnRef>
+      <a:fillRef idx="1">
+        <a:scrgbClr r="0" g="0" b="0"/>
+      </a:fillRef>
+      <a:effectRef idx="0">
+        <a:scrgbClr r="0" g="0" b="0"/>
+      </a:effectRef>
+      <a:fontRef idx="minor">
+        <a:schemeClr val="lt1"/>
+      </a:fontRef>
+    </dgm:style>
+  </dgm:styleLbl>
+  <dgm:styleLbl name="parChTrans2D3">
+    <dgm:scene3d>
+      <a:camera prst="orthographicFront"/>
+      <a:lightRig rig="threePt" dir="t"/>
+    </dgm:scene3d>
+    <dgm:sp3d/>
+    <dgm:txPr/>
+    <dgm:style>
+      <a:lnRef idx="2">
+        <a:scrgbClr r="0" g="0" b="0"/>
+      </a:lnRef>
+      <a:fillRef idx="1">
+        <a:scrgbClr r="0" g="0" b="0"/>
+      </a:fillRef>
+      <a:effectRef idx="0">
+        <a:scrgbClr r="0" g="0" b="0"/>
+      </a:effectRef>
+      <a:fontRef idx="minor">
+        <a:schemeClr val="lt1"/>
+      </a:fontRef>
+    </dgm:style>
+  </dgm:styleLbl>
+  <dgm:styleLbl name="parChTrans2D4">
+    <dgm:scene3d>
+      <a:camera prst="orthographicFront"/>
+      <a:lightRig rig="threePt" dir="t"/>
+    </dgm:scene3d>
+    <dgm:sp3d/>
+    <dgm:txPr/>
+    <dgm:style>
+      <a:lnRef idx="2">
+        <a:scrgbClr r="0" g="0" b="0"/>
+      </a:lnRef>
+      <a:fillRef idx="1">
+        <a:scrgbClr r="0" g="0" b="0"/>
+      </a:fillRef>
+      <a:effectRef idx="0">
+        <a:scrgbClr r="0" g="0" b="0"/>
+      </a:effectRef>
+      <a:fontRef idx="minor">
+        <a:schemeClr val="lt1"/>
+      </a:fontRef>
+    </dgm:style>
+  </dgm:styleLbl>
+  <dgm:styleLbl name="parChTrans1D1">
+    <dgm:scene3d>
+      <a:camera prst="orthographicFront"/>
+      <a:lightRig rig="threePt" dir="t"/>
+    </dgm:scene3d>
+    <dgm:sp3d/>
+    <dgm:txPr/>
+    <dgm:style>
+      <a:lnRef idx="2">
+        <a:scrgbClr r="0" g="0" b="0"/>
+      </a:lnRef>
+      <a:fillRef idx="0">
+        <a:scrgbClr r="0" g="0" b="0"/>
+      </a:fillRef>
+      <a:effectRef idx="0">
+        <a:scrgbClr r="0" g="0" b="0"/>
+      </a:effectRef>
+      <a:fontRef idx="minor"/>
+    </dgm:style>
+  </dgm:styleLbl>
+  <dgm:styleLbl name="parChTrans1D2">
+    <dgm:scene3d>
+      <a:camera prst="orthographicFront"/>
+      <a:lightRig rig="threePt" dir="t"/>
+    </dgm:scene3d>
+    <dgm:sp3d/>
+    <dgm:txPr/>
+    <dgm:style>
+      <a:lnRef idx="2">
+        <a:scrgbClr r="0" g="0" b="0"/>
+      </a:lnRef>
+      <a:fillRef idx="0">
+        <a:scrgbClr r="0" g="0" b="0"/>
+      </a:fillRef>
+      <a:effectRef idx="0">
+        <a:scrgbClr r="0" g="0" b="0"/>
+      </a:effectRef>
+      <a:fontRef idx="minor"/>
+    </dgm:style>
+  </dgm:styleLbl>
+  <dgm:styleLbl name="parChTrans1D3">
+    <dgm:scene3d>
+      <a:camera prst="orthographicFront"/>
+      <a:lightRig rig="threePt" dir="t"/>
+    </dgm:scene3d>
+    <dgm:sp3d/>
+    <dgm:txPr/>
+    <dgm:style>
+      <a:lnRef idx="2">
+        <a:scrgbClr r="0" g="0" b="0"/>
+      </a:lnRef>
+      <a:fillRef idx="0">
+        <a:scrgbClr r="0" g="0" b="0"/>
+      </a:fillRef>
+      <a:effectRef idx="0">
+        <a:scrgbClr r="0" g="0" b="0"/>
+      </a:effectRef>
+      <a:fontRef idx="minor"/>
+    </dgm:style>
+  </dgm:styleLbl>
+  <dgm:styleLbl name="parChTrans1D4">
+    <dgm:scene3d>
+      <a:camera prst="orthographicFront"/>
+      <a:lightRig rig="threePt" dir="t"/>
+    </dgm:scene3d>
+    <dgm:sp3d/>
+    <dgm:txPr/>
+    <dgm:style>
+      <a:lnRef idx="2">
+        <a:scrgbClr r="0" g="0" b="0"/>
+      </a:lnRef>
+      <a:fillRef idx="0">
+        <a:scrgbClr r="0" g="0" b="0"/>
+      </a:fillRef>
+      <a:effectRef idx="0">
+        <a:scrgbClr r="0" g="0" b="0"/>
+      </a:effectRef>
+      <a:fontRef idx="minor"/>
+    </dgm:style>
+  </dgm:styleLbl>
+  <dgm:styleLbl name="fgAcc1">
+    <dgm:scene3d>
+      <a:camera prst="orthographicFront"/>
+      <a:lightRig rig="threePt" dir="t"/>
+    </dgm:scene3d>
+    <dgm:sp3d/>
+    <dgm:txPr/>
+    <dgm:style>
+      <a:lnRef idx="2">
+        <a:scrgbClr r="0" g="0" b="0"/>
+      </a:lnRef>
+      <a:fillRef idx="1">
+        <a:scrgbClr r="0" g="0" b="0"/>
+      </a:fillRef>
+      <a:effectRef idx="0">
+        <a:scrgbClr r="0" g="0" b="0"/>
+      </a:effectRef>
+      <a:fontRef idx="minor"/>
+    </dgm:style>
+  </dgm:styleLbl>
+  <dgm:styleLbl name="conFgAcc1">
+    <dgm:scene3d>
+      <a:camera prst="orthographicFront"/>
+      <a:lightRig rig="threePt" dir="t"/>
+    </dgm:scene3d>
+    <dgm:sp3d/>
+    <dgm:txPr/>
+    <dgm:style>
+      <a:lnRef idx="2">
+        <a:scrgbClr r="0" g="0" b="0"/>
+      </a:lnRef>
+      <a:fillRef idx="1">
+        <a:scrgbClr r="0" g="0" b="0"/>
+      </a:fillRef>
+      <a:effectRef idx="0">
+        <a:scrgbClr r="0" g="0" b="0"/>
+      </a:effectRef>
+      <a:fontRef idx="minor"/>
+    </dgm:style>
+  </dgm:styleLbl>
+  <dgm:styleLbl name="alignAcc1">
+    <dgm:scene3d>
+      <a:camera prst="orthographicFront"/>
+      <a:lightRig rig="threePt" dir="t"/>
+    </dgm:scene3d>
+    <dgm:sp3d/>
+    <dgm:txPr/>
+    <dgm:style>
+      <a:lnRef idx="2">
+        <a:scrgbClr r="0" g="0" b="0"/>
+      </a:lnRef>
+      <a:fillRef idx="1">
+        <a:scrgbClr r="0" g="0" b="0"/>
+      </a:fillRef>
+      <a:effectRef idx="0">
+        <a:scrgbClr r="0" g="0" b="0"/>
+      </a:effectRef>
+      <a:fontRef idx="minor"/>
+    </dgm:style>
+  </dgm:styleLbl>
+  <dgm:styleLbl name="trAlignAcc1">
+    <dgm:scene3d>
+      <a:camera prst="orthographicFront"/>
+      <a:lightRig rig="threePt" dir="t"/>
+    </dgm:scene3d>
+    <dgm:sp3d/>
+    <dgm:txPr/>
+    <dgm:style>
+      <a:lnRef idx="1">
+        <a:scrgbClr r="0" g="0" b="0"/>
+      </a:lnRef>
+      <a:fillRef idx="1">
+        <a:scrgbClr r="0" g="0" b="0"/>
+      </a:fillRef>
+      <a:effectRef idx="0">
+        <a:scrgbClr r="0" g="0" b="0"/>
+      </a:effectRef>
+      <a:fontRef idx="minor"/>
+    </dgm:style>
+  </dgm:styleLbl>
+  <dgm:styleLbl name="bgAcc1">
+    <dgm:scene3d>
+      <a:camera prst="orthographicFront"/>
+      <a:lightRig rig="threePt" dir="t"/>
+    </dgm:scene3d>
+    <dgm:sp3d/>
+    <dgm:txPr/>
+    <dgm:style>
+      <a:lnRef idx="2">
+        <a:scrgbClr r="0" g="0" b="0"/>
+      </a:lnRef>
+      <a:fillRef idx="1">
+        <a:scrgbClr r="0" g="0" b="0"/>
+      </a:fillRef>
+      <a:effectRef idx="0">
+        <a:scrgbClr r="0" g="0" b="0"/>
+      </a:effectRef>
+      <a:fontRef idx="minor"/>
+    </dgm:style>
+  </dgm:styleLbl>
+  <dgm:styleLbl name="solidFgAcc1">
+    <dgm:scene3d>
+      <a:camera prst="orthographicFront"/>
+      <a:lightRig rig="threePt" dir="t"/>
+    </dgm:scene3d>
+    <dgm:sp3d/>
+    <dgm:txPr/>
+    <dgm:style>
+      <a:lnRef idx="2">
+        <a:scrgbClr r="0" g="0" b="0"/>
+      </a:lnRef>
+      <a:fillRef idx="1">
+        <a:scrgbClr r="0" g="0" b="0"/>
+      </a:fillRef>
+      <a:effectRef idx="0">
+        <a:scrgbClr r="0" g="0" b="0"/>
+      </a:effectRef>
+      <a:fontRef idx="minor"/>
+    </dgm:style>
+  </dgm:styleLbl>
+  <dgm:styleLbl name="solidAlignAcc1">
+    <dgm:scene3d>
+      <a:camera prst="orthographicFront"/>
+      <a:lightRig rig="threePt" dir="t"/>
+    </dgm:scene3d>
+    <dgm:sp3d/>
+    <dgm:txPr/>
+    <dgm:style>
+      <a:lnRef idx="2">
+        <a:scrgbClr r="0" g="0" b="0"/>
+      </a:lnRef>
+      <a:fillRef idx="1">
+        <a:scrgbClr r="0" g="0" b="0"/>
+      </a:fillRef>
+      <a:effectRef idx="0">
+        <a:scrgbClr r="0" g="0" b="0"/>
+      </a:effectRef>
+      <a:fontRef idx="minor"/>
+    </dgm:style>
+  </dgm:styleLbl>
+  <dgm:styleLbl name="solidBgAcc1">
+    <dgm:scene3d>
+      <a:camera prst="orthographicFront"/>
+      <a:lightRig rig="threePt" dir="t"/>
+    </dgm:scene3d>
+    <dgm:sp3d/>
+    <dgm:txPr/>
+    <dgm:style>
+      <a:lnRef idx="2">
+        <a:scrgbClr r="0" g="0" b="0"/>
+      </a:lnRef>
+      <a:fillRef idx="1">
+        <a:scrgbClr r="0" g="0" b="0"/>
+      </a:fillRef>
+      <a:effectRef idx="0">
+        <a:scrgbClr r="0" g="0" b="0"/>
+      </a:effectRef>
+      <a:fontRef idx="minor"/>
+    </dgm:style>
+  </dgm:styleLbl>
+  <dgm:styleLbl name="fgAccFollowNode1">
+    <dgm:scene3d>
+      <a:camera prst="orthographicFront"/>
+      <a:lightRig rig="threePt" dir="t"/>
+    </dgm:scene3d>
+    <dgm:sp3d/>
+    <dgm:txPr/>
+    <dgm:style>
+      <a:lnRef idx="2">
+        <a:scrgbClr r="0" g="0" b="0"/>
+      </a:lnRef>
+      <a:fillRef idx="1">
+        <a:scrgbClr r="0" g="0" b="0"/>
+      </a:fillRef>
+      <a:effectRef idx="0">
+        <a:scrgbClr r="0" g="0" b="0"/>
+      </a:effectRef>
+      <a:fontRef idx="minor"/>
+    </dgm:style>
+  </dgm:styleLbl>
+  <dgm:styleLbl name="alignAccFollowNode1">
+    <dgm:scene3d>
+      <a:camera prst="orthographicFront"/>
+      <a:lightRig rig="threePt" dir="t"/>
+    </dgm:scene3d>
+    <dgm:sp3d/>
+    <dgm:txPr/>
+    <dgm:style>
+      <a:lnRef idx="2">
+        <a:scrgbClr r="0" g="0" b="0"/>
+      </a:lnRef>
+      <a:fillRef idx="1">
+        <a:scrgbClr r="0" g="0" b="0"/>
+      </a:fillRef>
+      <a:effectRef idx="0">
+        <a:scrgbClr r="0" g="0" b="0"/>
+      </a:effectRef>
+      <a:fontRef idx="minor"/>
+    </dgm:style>
+  </dgm:styleLbl>
+  <dgm:styleLbl name="bgAccFollowNode1">
+    <dgm:scene3d>
+      <a:camera prst="orthographicFront"/>
+      <a:lightRig rig="threePt" dir="t"/>
+    </dgm:scene3d>
+    <dgm:sp3d/>
+    <dgm:txPr/>
+    <dgm:style>
+      <a:lnRef idx="2">
+        <a:scrgbClr r="0" g="0" b="0"/>
+      </a:lnRef>
+      <a:fillRef idx="1">
+        <a:scrgbClr r="0" g="0" b="0"/>
+      </a:fillRef>
+      <a:effectRef idx="0">
+        <a:scrgbClr r="0" g="0" b="0"/>
+      </a:effectRef>
+      <a:fontRef idx="minor"/>
+    </dgm:style>
+  </dgm:styleLbl>
+  <dgm:styleLbl name="fgAcc0">
+    <dgm:scene3d>
+      <a:camera prst="orthographicFront"/>
+      <a:lightRig rig="threePt" dir="t"/>
+    </dgm:scene3d>
+    <dgm:sp3d/>
+    <dgm:txPr/>
+    <dgm:style>
+      <a:lnRef idx="2">
+        <a:scrgbClr r="0" g="0" b="0"/>
+      </a:lnRef>
+      <a:fillRef idx="1">
+        <a:scrgbClr r="0" g="0" b="0"/>
+      </a:fillRef>
+      <a:effectRef idx="0">
+        <a:scrgbClr r="0" g="0" b="0"/>
+      </a:effectRef>
+      <a:fontRef idx="minor"/>
+    </dgm:style>
+  </dgm:styleLbl>
+  <dgm:styleLbl name="fgAcc2">
+    <dgm:scene3d>
+      <a:camera prst="orthographicFront"/>
+      <a:lightRig rig="threePt" dir="t"/>
+    </dgm:scene3d>
+    <dgm:sp3d/>
+    <dgm:txPr/>
+    <dgm:style>
+      <a:lnRef idx="2">
+        <a:scrgbClr r="0" g="0" b="0"/>
+      </a:lnRef>
+      <a:fillRef idx="1">
+        <a:scrgbClr r="0" g="0" b="0"/>
+      </a:fillRef>
+      <a:effectRef idx="0">
+        <a:scrgbClr r="0" g="0" b="0"/>
+      </a:effectRef>
+      <a:fontRef idx="minor"/>
+    </dgm:style>
+  </dgm:styleLbl>
+  <dgm:styleLbl name="fgAcc3">
+    <dgm:scene3d>
+      <a:camera prst="orthographicFront"/>
+      <a:lightRig rig="threePt" dir="t"/>
+    </dgm:scene3d>
+    <dgm:sp3d/>
+    <dgm:txPr/>
+    <dgm:style>
+      <a:lnRef idx="2">
+        <a:scrgbClr r="0" g="0" b="0"/>
+      </a:lnRef>
+      <a:fillRef idx="1">
+        <a:scrgbClr r="0" g="0" b="0"/>
+      </a:fillRef>
+      <a:effectRef idx="0">
+        <a:scrgbClr r="0" g="0" b="0"/>
+      </a:effectRef>
+      <a:fontRef idx="minor"/>
+    </dgm:style>
+  </dgm:styleLbl>
+  <dgm:styleLbl name="fgAcc4">
+    <dgm:scene3d>
+      <a:camera prst="orthographicFront"/>
+      <a:lightRig rig="threePt" dir="t"/>
+    </dgm:scene3d>
+    <dgm:sp3d/>
+    <dgm:txPr/>
+    <dgm:style>
+      <a:lnRef idx="2">
+        <a:scrgbClr r="0" g="0" b="0"/>
+      </a:lnRef>
+      <a:fillRef idx="1">
+        <a:scrgbClr r="0" g="0" b="0"/>
+      </a:fillRef>
+      <a:effectRef idx="0">
+        <a:scrgbClr r="0" g="0" b="0"/>
+      </a:effectRef>
+      <a:fontRef idx="minor"/>
+    </dgm:style>
+  </dgm:styleLbl>
+  <dgm:styleLbl name="bgShp">
+    <dgm:scene3d>
+      <a:camera prst="orthographicFront"/>
+      <a:lightRig rig="threePt" dir="t"/>
+    </dgm:scene3d>
+    <dgm:sp3d/>
+    <dgm:txPr/>
+    <dgm:style>
+      <a:lnRef idx="0">
+        <a:scrgbClr r="0" g="0" b="0"/>
+      </a:lnRef>
+      <a:fillRef idx="1">
+        <a:scrgbClr r="0" g="0" b="0"/>
+      </a:fillRef>
+      <a:effectRef idx="0">
+        <a:scrgbClr r="0" g="0" b="0"/>
+      </a:effectRef>
+      <a:fontRef idx="minor"/>
+    </dgm:style>
+  </dgm:styleLbl>
+  <dgm:styleLbl name="dkBgShp">
+    <dgm:scene3d>
+      <a:camera prst="orthographicFront"/>
+      <a:lightRig rig="threePt" dir="t"/>
+    </dgm:scene3d>
+    <dgm:sp3d/>
+    <dgm:txPr/>
+    <dgm:style>
+      <a:lnRef idx="0">
+        <a:scrgbClr r="0" g="0" b="0"/>
+      </a:lnRef>
+      <a:fillRef idx="1">
+        <a:scrgbClr r="0" g="0" b="0"/>
+      </a:fillRef>
+      <a:effectRef idx="0">
+        <a:scrgbClr r="0" g="0" b="0"/>
+      </a:effectRef>
+      <a:fontRef idx="minor"/>
+    </dgm:style>
+  </dgm:styleLbl>
+  <dgm:styleLbl name="trBgShp">
+    <dgm:scene3d>
+      <a:camera prst="orthographicFront"/>
+      <a:lightRig rig="threePt" dir="t"/>
+    </dgm:scene3d>
+    <dgm:sp3d/>
+    <dgm:txPr/>
+    <dgm:style>
+      <a:lnRef idx="0">
+        <a:scrgbClr r="0" g="0" b="0"/>
+      </a:lnRef>
+      <a:fillRef idx="1">
+        <a:scrgbClr r="0" g="0" b="0"/>
+      </a:fillRef>
+      <a:effectRef idx="0">
+        <a:scrgbClr r="0" g="0" b="0"/>
+      </a:effectRef>
+      <a:fontRef idx="minor"/>
+    </dgm:style>
+  </dgm:styleLbl>
+  <dgm:styleLbl name="fgShp">
+    <dgm:scene3d>
+      <a:camera prst="orthographicFront"/>
+      <a:lightRig rig="threePt" dir="t"/>
+    </dgm:scene3d>
+    <dgm:sp3d/>
+    <dgm:txPr/>
+    <dgm:style>
+      <a:lnRef idx="2">
+        <a:scrgbClr r="0" g="0" b="0"/>
+      </a:lnRef>
+      <a:fillRef idx="1">
+        <a:scrgbClr r="0" g="0" b="0"/>
+      </a:fillRef>
+      <a:effectRef idx="0">
+        <a:scrgbClr r="0" g="0" b="0"/>
+      </a:effectRef>
+      <a:fontRef idx="minor"/>
+    </dgm:style>
+  </dgm:styleLbl>
+  <dgm:styleLbl name="revTx">
+    <dgm:scene3d>
+      <a:camera prst="orthographicFront"/>
+      <a:lightRig rig="threePt" dir="t"/>
+    </dgm:scene3d>
+    <dgm:sp3d/>
+    <dgm:txPr/>
+    <dgm:style>
+      <a:lnRef idx="0">
+        <a:scrgbClr r="0" g="0" b="0"/>
+      </a:lnRef>
+      <a:fillRef idx="0">
+        <a:scrgbClr r="0" g="0" b="0"/>
+      </a:fillRef>
+      <a:effectRef idx="0">
+        <a:scrgbClr r="0" g="0" b="0"/>
+      </a:effectRef>
+      <a:fontRef idx="minor"/>
+    </dgm:style>
+  </dgm:styleLbl>
+</dgm:styleDef>
+</file>
+
+<file path=ppt/diagrams/quickStyle4.xml><?xml version="1.0" encoding="utf-8"?>
 <dgm:styleDef xmlns:dgm="http://schemas.openxmlformats.org/drawingml/2006/diagram" xmlns:a="http://schemas.openxmlformats.org/drawingml/2006/main" uniqueId="urn:microsoft.com/office/officeart/2005/8/quickstyle/simple1">
   <dgm:title val=""/>
   <dgm:desc val=""/>
@@ -9259,7 +12087,7 @@
           <a:p>
             <a:fld id="{AFEA96C4-76D9-4D10-A02D-18D5CECAB8B6}" type="datetimeFigureOut">
               <a:rPr lang="en-US" smtClean="0"/>
-              <a:t>4/9/2026</a:t>
+              <a:t>4/13/2026</a:t>
             </a:fld>
             <a:endParaRPr lang="en-US"/>
           </a:p>
@@ -9457,7 +12285,7 @@
           <a:p>
             <a:fld id="{AFEA96C4-76D9-4D10-A02D-18D5CECAB8B6}" type="datetimeFigureOut">
               <a:rPr lang="en-US" smtClean="0"/>
-              <a:t>4/9/2026</a:t>
+              <a:t>4/13/2026</a:t>
             </a:fld>
             <a:endParaRPr lang="en-US"/>
           </a:p>
@@ -9665,7 +12493,7 @@
           <a:p>
             <a:fld id="{AFEA96C4-76D9-4D10-A02D-18D5CECAB8B6}" type="datetimeFigureOut">
               <a:rPr lang="en-US" smtClean="0"/>
-              <a:t>4/9/2026</a:t>
+              <a:t>4/13/2026</a:t>
             </a:fld>
             <a:endParaRPr lang="en-US"/>
           </a:p>
@@ -9863,7 +12691,7 @@
           <a:p>
             <a:fld id="{AFEA96C4-76D9-4D10-A02D-18D5CECAB8B6}" type="datetimeFigureOut">
               <a:rPr lang="en-US" smtClean="0"/>
-              <a:t>4/9/2026</a:t>
+              <a:t>4/13/2026</a:t>
             </a:fld>
             <a:endParaRPr lang="en-US"/>
           </a:p>
@@ -10138,7 +12966,7 @@
           <a:p>
             <a:fld id="{AFEA96C4-76D9-4D10-A02D-18D5CECAB8B6}" type="datetimeFigureOut">
               <a:rPr lang="en-US" smtClean="0"/>
-              <a:t>4/9/2026</a:t>
+              <a:t>4/13/2026</a:t>
             </a:fld>
             <a:endParaRPr lang="en-US"/>
           </a:p>
@@ -10403,7 +13231,7 @@
           <a:p>
             <a:fld id="{AFEA96C4-76D9-4D10-A02D-18D5CECAB8B6}" type="datetimeFigureOut">
               <a:rPr lang="en-US" smtClean="0"/>
-              <a:t>4/9/2026</a:t>
+              <a:t>4/13/2026</a:t>
             </a:fld>
             <a:endParaRPr lang="en-US"/>
           </a:p>
@@ -10815,7 +13643,7 @@
           <a:p>
             <a:fld id="{AFEA96C4-76D9-4D10-A02D-18D5CECAB8B6}" type="datetimeFigureOut">
               <a:rPr lang="en-US" smtClean="0"/>
-              <a:t>4/9/2026</a:t>
+              <a:t>4/13/2026</a:t>
             </a:fld>
             <a:endParaRPr lang="en-US"/>
           </a:p>
@@ -10956,7 +13784,7 @@
           <a:p>
             <a:fld id="{AFEA96C4-76D9-4D10-A02D-18D5CECAB8B6}" type="datetimeFigureOut">
               <a:rPr lang="en-US" smtClean="0"/>
-              <a:t>4/9/2026</a:t>
+              <a:t>4/13/2026</a:t>
             </a:fld>
             <a:endParaRPr lang="en-US"/>
           </a:p>
@@ -11069,7 +13897,7 @@
           <a:p>
             <a:fld id="{AFEA96C4-76D9-4D10-A02D-18D5CECAB8B6}" type="datetimeFigureOut">
               <a:rPr lang="en-US" smtClean="0"/>
-              <a:t>4/9/2026</a:t>
+              <a:t>4/13/2026</a:t>
             </a:fld>
             <a:endParaRPr lang="en-US"/>
           </a:p>
@@ -11380,7 +14208,7 @@
           <a:p>
             <a:fld id="{AFEA96C4-76D9-4D10-A02D-18D5CECAB8B6}" type="datetimeFigureOut">
               <a:rPr lang="en-US" smtClean="0"/>
-              <a:t>4/9/2026</a:t>
+              <a:t>4/13/2026</a:t>
             </a:fld>
             <a:endParaRPr lang="en-US"/>
           </a:p>
@@ -11668,7 +14496,7 @@
           <a:p>
             <a:fld id="{AFEA96C4-76D9-4D10-A02D-18D5CECAB8B6}" type="datetimeFigureOut">
               <a:rPr lang="en-US" smtClean="0"/>
-              <a:t>4/9/2026</a:t>
+              <a:t>4/13/2026</a:t>
             </a:fld>
             <a:endParaRPr lang="en-US"/>
           </a:p>
@@ -11909,7 +14737,7 @@
           <a:p>
             <a:fld id="{AFEA96C4-76D9-4D10-A02D-18D5CECAB8B6}" type="datetimeFigureOut">
               <a:rPr lang="en-US" smtClean="0"/>
-              <a:t>4/9/2026</a:t>
+              <a:t>4/13/2026</a:t>
             </a:fld>
             <a:endParaRPr lang="en-US"/>
           </a:p>
@@ -12877,6 +15705,498 @@
       </p:grpSpPr>
       <p:sp useBgFill="1">
         <p:nvSpPr>
+          <p:cNvPr id="10" name="Rectangle 9">
+            <a:extLst>
+              <a:ext uri="{FF2B5EF4-FFF2-40B4-BE49-F238E27FC236}">
+                <a16:creationId xmlns:a16="http://schemas.microsoft.com/office/drawing/2014/main" id="{743AA782-23D1-4521-8CAD-47662984AA08}"/>
+              </a:ext>
+              <a:ext uri="{C183D7F6-B498-43B3-948B-1728B52AA6E4}">
+                <adec:decorative xmlns:adec="http://schemas.microsoft.com/office/drawing/2017/decorative" val="1"/>
+              </a:ext>
+            </a:extLst>
+          </p:cNvPr>
+          <p:cNvSpPr>
+            <a:spLocks noGrp="1" noRot="1" noChangeAspect="1" noMove="1" noResize="1" noEditPoints="1" noAdjustHandles="1" noChangeArrowheads="1" noChangeShapeType="1" noTextEdit="1"/>
+          </p:cNvSpPr>
+          <p:nvPr>
+            <p:extLst>
+              <p:ext uri="{386F3935-93C4-4BCD-93E2-E3B085C9AB24}">
+                <p16:designElem xmlns:p16="http://schemas.microsoft.com/office/powerpoint/2015/main" val="1"/>
+              </p:ext>
+            </p:extLst>
+          </p:nvPr>
+        </p:nvSpPr>
+        <p:spPr>
+          <a:xfrm>
+            <a:off x="0" y="0"/>
+            <a:ext cx="12192000" cy="6858000"/>
+          </a:xfrm>
+          <a:prstGeom prst="rect">
+            <a:avLst/>
+          </a:prstGeom>
+          <a:ln>
+            <a:noFill/>
+          </a:ln>
+        </p:spPr>
+        <p:style>
+          <a:lnRef idx="2">
+            <a:schemeClr val="accent1">
+              <a:shade val="50000"/>
+            </a:schemeClr>
+          </a:lnRef>
+          <a:fillRef idx="1">
+            <a:schemeClr val="accent1"/>
+          </a:fillRef>
+          <a:effectRef idx="0">
+            <a:schemeClr val="accent1"/>
+          </a:effectRef>
+          <a:fontRef idx="minor">
+            <a:schemeClr val="lt1"/>
+          </a:fontRef>
+        </p:style>
+        <p:txBody>
+          <a:bodyPr rtlCol="0" anchor="ctr"/>
+          <a:lstStyle/>
+          <a:p>
+            <a:pPr algn="ctr"/>
+            <a:endParaRPr lang="en-US"/>
+          </a:p>
+        </p:txBody>
+      </p:sp>
+      <p:sp>
+        <p:nvSpPr>
+          <p:cNvPr id="2" name="Title 1">
+            <a:extLst>
+              <a:ext uri="{FF2B5EF4-FFF2-40B4-BE49-F238E27FC236}">
+                <a16:creationId xmlns:a16="http://schemas.microsoft.com/office/drawing/2014/main" id="{0E1231AA-D68E-5E3E-38D9-A11CFECCFD27}"/>
+              </a:ext>
+            </a:extLst>
+          </p:cNvPr>
+          <p:cNvSpPr>
+            <a:spLocks noGrp="1"/>
+          </p:cNvSpPr>
+          <p:nvPr>
+            <p:ph type="title"/>
+          </p:nvPr>
+        </p:nvSpPr>
+        <p:spPr>
+          <a:xfrm>
+            <a:off x="630936" y="640080"/>
+            <a:ext cx="4818888" cy="1481328"/>
+          </a:xfrm>
+        </p:spPr>
+        <p:txBody>
+          <a:bodyPr anchor="b">
+            <a:normAutofit/>
+          </a:bodyPr>
+          <a:lstStyle/>
+          <a:p>
+            <a:r>
+              <a:rPr lang="en-US" sz="5000"/>
+              <a:t>Feature Importance</a:t>
+            </a:r>
+          </a:p>
+        </p:txBody>
+      </p:sp>
+      <p:sp>
+        <p:nvSpPr>
+          <p:cNvPr id="12" name="sketch line">
+            <a:extLst>
+              <a:ext uri="{FF2B5EF4-FFF2-40B4-BE49-F238E27FC236}">
+                <a16:creationId xmlns:a16="http://schemas.microsoft.com/office/drawing/2014/main" id="{71877DBC-BB60-40F0-AC93-2ACDBAAE60CE}"/>
+              </a:ext>
+              <a:ext uri="{C183D7F6-B498-43B3-948B-1728B52AA6E4}">
+                <adec:decorative xmlns:adec="http://schemas.microsoft.com/office/drawing/2017/decorative" val="1"/>
+              </a:ext>
+            </a:extLst>
+          </p:cNvPr>
+          <p:cNvSpPr>
+            <a:spLocks noGrp="1" noRot="1" noChangeAspect="1" noMove="1" noResize="1" noEditPoints="1" noAdjustHandles="1" noChangeArrowheads="1" noChangeShapeType="1" noTextEdit="1"/>
+          </p:cNvSpPr>
+          <p:nvPr>
+            <p:extLst>
+              <p:ext uri="{386F3935-93C4-4BCD-93E2-E3B085C9AB24}">
+                <p16:designElem xmlns:p16="http://schemas.microsoft.com/office/powerpoint/2015/main" val="1"/>
+              </p:ext>
+            </p:extLst>
+          </p:nvPr>
+        </p:nvSpPr>
+        <p:spPr>
+          <a:xfrm>
+            <a:off x="643278" y="2372868"/>
+            <a:ext cx="3255095" cy="18288"/>
+          </a:xfrm>
+          <a:custGeom>
+            <a:avLst/>
+            <a:gdLst>
+              <a:gd name="csX0" fmla="*/ 0 w 3255095"/>
+              <a:gd name="csY0" fmla="*/ 0 h 18288"/>
+              <a:gd name="csX1" fmla="*/ 618468 w 3255095"/>
+              <a:gd name="csY1" fmla="*/ 0 h 18288"/>
+              <a:gd name="csX2" fmla="*/ 1269487 w 3255095"/>
+              <a:gd name="csY2" fmla="*/ 0 h 18288"/>
+              <a:gd name="csX3" fmla="*/ 1953057 w 3255095"/>
+              <a:gd name="csY3" fmla="*/ 0 h 18288"/>
+              <a:gd name="csX4" fmla="*/ 2636627 w 3255095"/>
+              <a:gd name="csY4" fmla="*/ 0 h 18288"/>
+              <a:gd name="csX5" fmla="*/ 3255095 w 3255095"/>
+              <a:gd name="csY5" fmla="*/ 0 h 18288"/>
+              <a:gd name="csX6" fmla="*/ 3255095 w 3255095"/>
+              <a:gd name="csY6" fmla="*/ 18288 h 18288"/>
+              <a:gd name="csX7" fmla="*/ 2538974 w 3255095"/>
+              <a:gd name="csY7" fmla="*/ 18288 h 18288"/>
+              <a:gd name="csX8" fmla="*/ 1822853 w 3255095"/>
+              <a:gd name="csY8" fmla="*/ 18288 h 18288"/>
+              <a:gd name="csX9" fmla="*/ 1171834 w 3255095"/>
+              <a:gd name="csY9" fmla="*/ 18288 h 18288"/>
+              <a:gd name="csX10" fmla="*/ 0 w 3255095"/>
+              <a:gd name="csY10" fmla="*/ 18288 h 18288"/>
+              <a:gd name="csX11" fmla="*/ 0 w 3255095"/>
+              <a:gd name="csY11" fmla="*/ 0 h 18288"/>
+            </a:gdLst>
+            <a:ahLst/>
+            <a:cxnLst>
+              <a:cxn ang="0">
+                <a:pos x="csX0" y="csY0"/>
+              </a:cxn>
+              <a:cxn ang="0">
+                <a:pos x="csX1" y="csY1"/>
+              </a:cxn>
+              <a:cxn ang="0">
+                <a:pos x="csX2" y="csY2"/>
+              </a:cxn>
+              <a:cxn ang="0">
+                <a:pos x="csX3" y="csY3"/>
+              </a:cxn>
+              <a:cxn ang="0">
+                <a:pos x="csX4" y="csY4"/>
+              </a:cxn>
+              <a:cxn ang="0">
+                <a:pos x="csX5" y="csY5"/>
+              </a:cxn>
+              <a:cxn ang="0">
+                <a:pos x="csX6" y="csY6"/>
+              </a:cxn>
+              <a:cxn ang="0">
+                <a:pos x="csX7" y="csY7"/>
+              </a:cxn>
+              <a:cxn ang="0">
+                <a:pos x="csX8" y="csY8"/>
+              </a:cxn>
+              <a:cxn ang="0">
+                <a:pos x="csX9" y="csY9"/>
+              </a:cxn>
+              <a:cxn ang="0">
+                <a:pos x="csX10" y="csY10"/>
+              </a:cxn>
+              <a:cxn ang="0">
+                <a:pos x="csX11" y="csY11"/>
+              </a:cxn>
+            </a:cxnLst>
+            <a:rect l="l" t="t" r="r" b="b"/>
+            <a:pathLst>
+              <a:path w="3255095" h="18288" fill="none" extrusionOk="0">
+                <a:moveTo>
+                  <a:pt x="0" y="0"/>
+                </a:moveTo>
+                <a:cubicBezTo>
+                  <a:pt x="240201" y="-22123"/>
+                  <a:pt x="462021" y="-19623"/>
+                  <a:pt x="618468" y="0"/>
+                </a:cubicBezTo>
+                <a:cubicBezTo>
+                  <a:pt x="774915" y="19623"/>
+                  <a:pt x="974734" y="2035"/>
+                  <a:pt x="1269487" y="0"/>
+                </a:cubicBezTo>
+                <a:cubicBezTo>
+                  <a:pt x="1564240" y="-2035"/>
+                  <a:pt x="1733579" y="10639"/>
+                  <a:pt x="1953057" y="0"/>
+                </a:cubicBezTo>
+                <a:cubicBezTo>
+                  <a:pt x="2172535" y="-10639"/>
+                  <a:pt x="2453962" y="14018"/>
+                  <a:pt x="2636627" y="0"/>
+                </a:cubicBezTo>
+                <a:cubicBezTo>
+                  <a:pt x="2819292" y="-14018"/>
+                  <a:pt x="3121375" y="5399"/>
+                  <a:pt x="3255095" y="0"/>
+                </a:cubicBezTo>
+                <a:cubicBezTo>
+                  <a:pt x="3254386" y="8157"/>
+                  <a:pt x="3254682" y="12125"/>
+                  <a:pt x="3255095" y="18288"/>
+                </a:cubicBezTo>
+                <a:cubicBezTo>
+                  <a:pt x="3088545" y="23203"/>
+                  <a:pt x="2687475" y="7419"/>
+                  <a:pt x="2538974" y="18288"/>
+                </a:cubicBezTo>
+                <a:cubicBezTo>
+                  <a:pt x="2390473" y="29157"/>
+                  <a:pt x="2137381" y="-8959"/>
+                  <a:pt x="1822853" y="18288"/>
+                </a:cubicBezTo>
+                <a:cubicBezTo>
+                  <a:pt x="1508325" y="45535"/>
+                  <a:pt x="1466437" y="20385"/>
+                  <a:pt x="1171834" y="18288"/>
+                </a:cubicBezTo>
+                <a:cubicBezTo>
+                  <a:pt x="877231" y="16191"/>
+                  <a:pt x="561097" y="37643"/>
+                  <a:pt x="0" y="18288"/>
+                </a:cubicBezTo>
+                <a:cubicBezTo>
+                  <a:pt x="-46" y="12483"/>
+                  <a:pt x="-203" y="6491"/>
+                  <a:pt x="0" y="0"/>
+                </a:cubicBezTo>
+                <a:close/>
+              </a:path>
+              <a:path w="3255095" h="18288" stroke="0" extrusionOk="0">
+                <a:moveTo>
+                  <a:pt x="0" y="0"/>
+                </a:moveTo>
+                <a:cubicBezTo>
+                  <a:pt x="291965" y="19429"/>
+                  <a:pt x="363155" y="8568"/>
+                  <a:pt x="618468" y="0"/>
+                </a:cubicBezTo>
+                <a:cubicBezTo>
+                  <a:pt x="873781" y="-8568"/>
+                  <a:pt x="904459" y="-19505"/>
+                  <a:pt x="1171834" y="0"/>
+                </a:cubicBezTo>
+                <a:cubicBezTo>
+                  <a:pt x="1439209" y="19505"/>
+                  <a:pt x="1744369" y="9790"/>
+                  <a:pt x="1887955" y="0"/>
+                </a:cubicBezTo>
+                <a:cubicBezTo>
+                  <a:pt x="2031541" y="-9790"/>
+                  <a:pt x="2346378" y="21240"/>
+                  <a:pt x="2506423" y="0"/>
+                </a:cubicBezTo>
+                <a:cubicBezTo>
+                  <a:pt x="2666468" y="-21240"/>
+                  <a:pt x="2990257" y="30414"/>
+                  <a:pt x="3255095" y="0"/>
+                </a:cubicBezTo>
+                <a:cubicBezTo>
+                  <a:pt x="3254831" y="4493"/>
+                  <a:pt x="3255479" y="9472"/>
+                  <a:pt x="3255095" y="18288"/>
+                </a:cubicBezTo>
+                <a:cubicBezTo>
+                  <a:pt x="3120743" y="16690"/>
+                  <a:pt x="2759628" y="42462"/>
+                  <a:pt x="2604076" y="18288"/>
+                </a:cubicBezTo>
+                <a:cubicBezTo>
+                  <a:pt x="2448524" y="-5886"/>
+                  <a:pt x="2184336" y="19599"/>
+                  <a:pt x="1887955" y="18288"/>
+                </a:cubicBezTo>
+                <a:cubicBezTo>
+                  <a:pt x="1591574" y="16977"/>
+                  <a:pt x="1548845" y="6870"/>
+                  <a:pt x="1334589" y="18288"/>
+                </a:cubicBezTo>
+                <a:cubicBezTo>
+                  <a:pt x="1120333" y="29706"/>
+                  <a:pt x="996014" y="9662"/>
+                  <a:pt x="683570" y="18288"/>
+                </a:cubicBezTo>
+                <a:cubicBezTo>
+                  <a:pt x="371126" y="26914"/>
+                  <a:pt x="198687" y="16167"/>
+                  <a:pt x="0" y="18288"/>
+                </a:cubicBezTo>
+                <a:cubicBezTo>
+                  <a:pt x="843" y="9577"/>
+                  <a:pt x="371" y="6900"/>
+                  <a:pt x="0" y="0"/>
+                </a:cubicBezTo>
+                <a:close/>
+              </a:path>
+            </a:pathLst>
+          </a:custGeom>
+          <a:solidFill>
+            <a:schemeClr val="accent2"/>
+          </a:solidFill>
+          <a:ln w="38100" cap="rnd">
+            <a:solidFill>
+              <a:schemeClr val="accent2"/>
+            </a:solidFill>
+            <a:round/>
+            <a:extLst>
+              <a:ext uri="{C807C97D-BFC1-408E-A445-0C87EB9F89A2}">
+                <ask:lineSketchStyleProps xmlns:ask="http://schemas.microsoft.com/office/drawing/2018/sketchyshapes" sd="1219033472">
+                  <a:prstGeom prst="rect">
+                    <a:avLst/>
+                  </a:prstGeom>
+                  <ask:type>
+                    <ask:lineSketchFreehand/>
+                  </ask:type>
+                </ask:lineSketchStyleProps>
+              </a:ext>
+            </a:extLst>
+          </a:ln>
+        </p:spPr>
+        <p:style>
+          <a:lnRef idx="2">
+            <a:schemeClr val="accent1">
+              <a:shade val="50000"/>
+            </a:schemeClr>
+          </a:lnRef>
+          <a:fillRef idx="1">
+            <a:schemeClr val="accent1"/>
+          </a:fillRef>
+          <a:effectRef idx="0">
+            <a:schemeClr val="accent1"/>
+          </a:effectRef>
+          <a:fontRef idx="minor">
+            <a:schemeClr val="lt1"/>
+          </a:fontRef>
+        </p:style>
+        <p:txBody>
+          <a:bodyPr rtlCol="0" anchor="ctr"/>
+          <a:lstStyle/>
+          <a:p>
+            <a:pPr algn="ctr"/>
+            <a:endParaRPr lang="en-US"/>
+          </a:p>
+        </p:txBody>
+      </p:sp>
+      <p:sp>
+        <p:nvSpPr>
+          <p:cNvPr id="3" name="Content Placeholder 2">
+            <a:extLst>
+              <a:ext uri="{FF2B5EF4-FFF2-40B4-BE49-F238E27FC236}">
+                <a16:creationId xmlns:a16="http://schemas.microsoft.com/office/drawing/2014/main" id="{5F2610FC-C8BD-1B28-5CF1-C94A6C57EF7E}"/>
+              </a:ext>
+            </a:extLst>
+          </p:cNvPr>
+          <p:cNvSpPr>
+            <a:spLocks noGrp="1"/>
+          </p:cNvSpPr>
+          <p:nvPr>
+            <p:ph idx="1"/>
+          </p:nvPr>
+        </p:nvSpPr>
+        <p:spPr>
+          <a:xfrm>
+            <a:off x="630936" y="2660904"/>
+            <a:ext cx="4818888" cy="3547872"/>
+          </a:xfrm>
+        </p:spPr>
+        <p:txBody>
+          <a:bodyPr anchor="t">
+            <a:normAutofit/>
+          </a:bodyPr>
+          <a:lstStyle/>
+          <a:p>
+            <a:pPr marL="0" indent="0">
+              <a:buNone/>
+            </a:pPr>
+            <a:r>
+              <a:rPr lang="en-US" sz="2200" dirty="0" err="1"/>
+              <a:t>Rank_vs_TourneyAvg</a:t>
+            </a:r>
+            <a:r>
+              <a:rPr lang="en-US" sz="2200" dirty="0"/>
+              <a:t> was our top predictor with </a:t>
+            </a:r>
+            <a:r>
+              <a:rPr lang="en-US" sz="2200" dirty="0" err="1"/>
+              <a:t>SeedNum</a:t>
+            </a:r>
+            <a:r>
+              <a:rPr lang="en-US" sz="2200" dirty="0"/>
+              <a:t> being a close second. Showing that although the teams seed number was low by the tournament committee their underlying Massey Ratings metric mathematically placed them above.</a:t>
+            </a:r>
+          </a:p>
+        </p:txBody>
+      </p:sp>
+      <p:pic>
+        <p:nvPicPr>
+          <p:cNvPr id="6" name="Picture 5">
+            <a:extLst>
+              <a:ext uri="{FF2B5EF4-FFF2-40B4-BE49-F238E27FC236}">
+                <a16:creationId xmlns:a16="http://schemas.microsoft.com/office/drawing/2014/main" id="{D02FCB11-0CC0-1720-5033-8A80D2267BD8}"/>
+              </a:ext>
+            </a:extLst>
+          </p:cNvPr>
+          <p:cNvPicPr>
+            <a:picLocks noChangeAspect="1"/>
+          </p:cNvPicPr>
+          <p:nvPr/>
+        </p:nvPicPr>
+        <p:blipFill>
+          <a:blip r:embed="rId2">
+            <a:extLst>
+              <a:ext uri="{28A0092B-C50C-407E-A947-70E740481C1C}">
+                <a14:useLocalDpi xmlns:a14="http://schemas.microsoft.com/office/drawing/2010/main" val="0"/>
+              </a:ext>
+            </a:extLst>
+          </a:blip>
+          <a:stretch>
+            <a:fillRect/>
+          </a:stretch>
+        </p:blipFill>
+        <p:spPr>
+          <a:xfrm>
+            <a:off x="5449824" y="1165092"/>
+            <a:ext cx="6253816" cy="4527815"/>
+          </a:xfrm>
+          <a:prstGeom prst="rect">
+            <a:avLst/>
+          </a:prstGeom>
+        </p:spPr>
+      </p:pic>
+    </p:spTree>
+    <p:extLst>
+      <p:ext uri="{BB962C8B-B14F-4D97-AF65-F5344CB8AC3E}">
+        <p14:creationId xmlns:p14="http://schemas.microsoft.com/office/powerpoint/2010/main" val="954167436"/>
+      </p:ext>
+    </p:extLst>
+  </p:cSld>
+  <p:clrMapOvr>
+    <a:masterClrMapping/>
+  </p:clrMapOvr>
+</p:sld>
+</file>
+
+<file path=ppt/slides/slide11.xml><?xml version="1.0" encoding="utf-8"?>
+<p:sld xmlns:a="http://schemas.openxmlformats.org/drawingml/2006/main" xmlns:r="http://schemas.openxmlformats.org/officeDocument/2006/relationships" xmlns:p="http://schemas.openxmlformats.org/presentationml/2006/main">
+  <p:cSld>
+    <p:bg>
+      <p:bgPr>
+        <a:solidFill>
+          <a:schemeClr val="bg1"/>
+        </a:solidFill>
+        <a:effectLst/>
+      </p:bgPr>
+    </p:bg>
+    <p:spTree>
+      <p:nvGrpSpPr>
+        <p:cNvPr id="1" name=""/>
+        <p:cNvGrpSpPr/>
+        <p:nvPr/>
+      </p:nvGrpSpPr>
+      <p:grpSpPr>
+        <a:xfrm>
+          <a:off x="0" y="0"/>
+          <a:ext cx="0" cy="0"/>
+          <a:chOff x="0" y="0"/>
+          <a:chExt cx="0" cy="0"/>
+        </a:xfrm>
+      </p:grpSpPr>
+      <p:sp useBgFill="1">
+        <p:nvSpPr>
           <p:cNvPr id="16" name="Rectangle 15">
             <a:extLst>
               <a:ext uri="{FF2B5EF4-FFF2-40B4-BE49-F238E27FC236}">
@@ -13414,25 +16734,25 @@
           <a:lstStyle/>
           <a:p>
             <a:r>
-              <a:rPr lang="en-US" sz="1700"/>
+              <a:rPr lang="en-US" sz="1700" dirty="0"/>
               <a:t>Hypothesis: Cinderellas would be identified as distinct outliers among other low seeded teams.</a:t>
             </a:r>
           </a:p>
           <a:p>
-            <a:endParaRPr lang="en-US" sz="1700"/>
+            <a:endParaRPr lang="en-US" sz="1700" dirty="0"/>
           </a:p>
           <a:p>
             <a:r>
-              <a:rPr lang="en-US" sz="1700"/>
+              <a:rPr lang="en-US" sz="1700" dirty="0"/>
               <a:t>Reality: Isolation Forest showed that Cinderellas were mostly statistically normal to other lower ranked seeds and lacked significant variance.</a:t>
             </a:r>
           </a:p>
           <a:p>
-            <a:endParaRPr lang="en-US" sz="1700"/>
+            <a:endParaRPr lang="en-US" sz="1700" dirty="0"/>
           </a:p>
           <a:p>
             <a:r>
-              <a:rPr lang="en-US" sz="1700"/>
+              <a:rPr lang="en-US" sz="1700" dirty="0"/>
               <a:t>However, the Gaussian Mixed Model (GMM) was able to group teams into 4 distinct archetypes. It successfully grouped 82% of historical Cinderella teams into a high performing archetype (Cluster 2) where many higher ranked teams are. This suggests that they distinct enough to be identified as different from the average lower seed.</a:t>
             </a:r>
           </a:p>
@@ -13451,9 +16771,17 @@
 </p:sld>
 </file>
 
-<file path=ppt/slides/slide11.xml><?xml version="1.0" encoding="utf-8"?>
+<file path=ppt/slides/slide12.xml><?xml version="1.0" encoding="utf-8"?>
 <p:sld xmlns:a="http://schemas.openxmlformats.org/drawingml/2006/main" xmlns:r="http://schemas.openxmlformats.org/officeDocument/2006/relationships" xmlns:p="http://schemas.openxmlformats.org/presentationml/2006/main">
   <p:cSld>
+    <p:bg>
+      <p:bgPr>
+        <a:solidFill>
+          <a:schemeClr val="bg1"/>
+        </a:solidFill>
+        <a:effectLst/>
+      </p:bgPr>
+    </p:bg>
     <p:spTree>
       <p:nvGrpSpPr>
         <p:cNvPr id="1" name=""/>
@@ -13468,6 +16796,348 @@
           <a:chExt cx="0" cy="0"/>
         </a:xfrm>
       </p:grpSpPr>
+      <p:sp useBgFill="1">
+        <p:nvSpPr>
+          <p:cNvPr id="9" name="Rectangle 8">
+            <a:extLst>
+              <a:ext uri="{FF2B5EF4-FFF2-40B4-BE49-F238E27FC236}">
+                <a16:creationId xmlns:a16="http://schemas.microsoft.com/office/drawing/2014/main" id="{56E9B3E6-E277-4D68-BA48-9CB43FFBD6E2}"/>
+              </a:ext>
+              <a:ext uri="{C183D7F6-B498-43B3-948B-1728B52AA6E4}">
+                <adec:decorative xmlns:adec="http://schemas.microsoft.com/office/drawing/2017/decorative" val="1"/>
+              </a:ext>
+            </a:extLst>
+          </p:cNvPr>
+          <p:cNvSpPr>
+            <a:spLocks noGrp="1" noRot="1" noChangeAspect="1" noMove="1" noResize="1" noEditPoints="1" noAdjustHandles="1" noChangeArrowheads="1" noChangeShapeType="1" noTextEdit="1"/>
+          </p:cNvSpPr>
+          <p:nvPr>
+            <p:extLst>
+              <p:ext uri="{386F3935-93C4-4BCD-93E2-E3B085C9AB24}">
+                <p16:designElem xmlns:p16="http://schemas.microsoft.com/office/powerpoint/2015/main" val="1"/>
+              </p:ext>
+            </p:extLst>
+          </p:nvPr>
+        </p:nvSpPr>
+        <p:spPr>
+          <a:xfrm>
+            <a:off x="0" y="0"/>
+            <a:ext cx="12191999" cy="6857365"/>
+          </a:xfrm>
+          <a:prstGeom prst="rect">
+            <a:avLst/>
+          </a:prstGeom>
+          <a:ln>
+            <a:noFill/>
+          </a:ln>
+        </p:spPr>
+        <p:style>
+          <a:lnRef idx="2">
+            <a:schemeClr val="accent1">
+              <a:shade val="50000"/>
+            </a:schemeClr>
+          </a:lnRef>
+          <a:fillRef idx="1">
+            <a:schemeClr val="accent1"/>
+          </a:fillRef>
+          <a:effectRef idx="0">
+            <a:schemeClr val="accent1"/>
+          </a:effectRef>
+          <a:fontRef idx="minor">
+            <a:schemeClr val="lt1"/>
+          </a:fontRef>
+        </p:style>
+        <p:txBody>
+          <a:bodyPr rtlCol="0" anchor="ctr"/>
+          <a:lstStyle/>
+          <a:p>
+            <a:pPr algn="ctr"/>
+            <a:endParaRPr lang="en-US"/>
+          </a:p>
+        </p:txBody>
+      </p:sp>
+      <p:grpSp>
+        <p:nvGrpSpPr>
+          <p:cNvPr id="11" name="Group 10">
+            <a:extLst>
+              <a:ext uri="{FF2B5EF4-FFF2-40B4-BE49-F238E27FC236}">
+                <a16:creationId xmlns:a16="http://schemas.microsoft.com/office/drawing/2014/main" id="{AE1C45F0-260A-458C-96ED-C1F6D2151219}"/>
+              </a:ext>
+              <a:ext uri="{C183D7F6-B498-43B3-948B-1728B52AA6E4}">
+                <adec:decorative xmlns:adec="http://schemas.microsoft.com/office/drawing/2017/decorative" val="1"/>
+              </a:ext>
+            </a:extLst>
+          </p:cNvPr>
+          <p:cNvGrpSpPr>
+            <a:grpSpLocks noGrp="1" noUngrp="1" noRot="1" noChangeAspect="1" noMove="1" noResize="1"/>
+          </p:cNvGrpSpPr>
+          <p:nvPr>
+            <p:extLst>
+              <p:ext uri="{386F3935-93C4-4BCD-93E2-E3B085C9AB24}">
+                <p16:designElem xmlns:p16="http://schemas.microsoft.com/office/powerpoint/2015/main" val="1"/>
+              </p:ext>
+            </p:extLst>
+          </p:nvPr>
+        </p:nvGrpSpPr>
+        <p:grpSpPr>
+          <a:xfrm>
+            <a:off x="4" y="1216597"/>
+            <a:ext cx="731521" cy="673460"/>
+            <a:chOff x="3940602" y="308034"/>
+            <a:chExt cx="2116791" cy="3428999"/>
+          </a:xfrm>
+          <a:solidFill>
+            <a:schemeClr val="accent4"/>
+          </a:solidFill>
+        </p:grpSpPr>
+        <p:sp>
+          <p:nvSpPr>
+            <p:cNvPr id="12" name="Rectangle 11">
+              <a:extLst>
+                <a:ext uri="{FF2B5EF4-FFF2-40B4-BE49-F238E27FC236}">
+                  <a16:creationId xmlns:a16="http://schemas.microsoft.com/office/drawing/2014/main" id="{A6604B49-AD5C-4590-B051-06C8222ECD99}"/>
+                </a:ext>
+                <a:ext uri="{C183D7F6-B498-43B3-948B-1728B52AA6E4}">
+                  <adec:decorative xmlns:adec="http://schemas.microsoft.com/office/drawing/2017/decorative" val="1"/>
+                </a:ext>
+              </a:extLst>
+            </p:cNvPr>
+            <p:cNvSpPr/>
+            <p:nvPr>
+              <p:extLst>
+                <p:ext uri="{386F3935-93C4-4BCD-93E2-E3B085C9AB24}">
+                  <p16:designElem xmlns:p16="http://schemas.microsoft.com/office/powerpoint/2015/main" val="1"/>
+                </p:ext>
+              </p:extLst>
+            </p:nvPr>
+          </p:nvSpPr>
+          <p:spPr>
+            <a:xfrm>
+              <a:off x="3940602" y="308034"/>
+              <a:ext cx="566743" cy="3428999"/>
+            </a:xfrm>
+            <a:prstGeom prst="rect">
+              <a:avLst/>
+            </a:prstGeom>
+            <a:grpFill/>
+            <a:ln>
+              <a:noFill/>
+            </a:ln>
+          </p:spPr>
+          <p:style>
+            <a:lnRef idx="2">
+              <a:schemeClr val="accent1">
+                <a:shade val="50000"/>
+              </a:schemeClr>
+            </a:lnRef>
+            <a:fillRef idx="1">
+              <a:schemeClr val="accent1"/>
+            </a:fillRef>
+            <a:effectRef idx="0">
+              <a:schemeClr val="accent1"/>
+            </a:effectRef>
+            <a:fontRef idx="minor">
+              <a:schemeClr val="lt1"/>
+            </a:fontRef>
+          </p:style>
+          <p:txBody>
+            <a:bodyPr rtlCol="0" anchor="ctr"/>
+            <a:lstStyle/>
+            <a:p>
+              <a:pPr algn="ctr"/>
+              <a:endParaRPr lang="en-US"/>
+            </a:p>
+          </p:txBody>
+        </p:sp>
+        <p:sp>
+          <p:nvSpPr>
+            <p:cNvPr id="13" name="Rectangle 12">
+              <a:extLst>
+                <a:ext uri="{FF2B5EF4-FFF2-40B4-BE49-F238E27FC236}">
+                  <a16:creationId xmlns:a16="http://schemas.microsoft.com/office/drawing/2014/main" id="{743ECCAF-29C5-4537-947C-7EA1292463DB}"/>
+                </a:ext>
+                <a:ext uri="{C183D7F6-B498-43B3-948B-1728B52AA6E4}">
+                  <adec:decorative xmlns:adec="http://schemas.microsoft.com/office/drawing/2017/decorative" val="1"/>
+                </a:ext>
+              </a:extLst>
+            </p:cNvPr>
+            <p:cNvSpPr/>
+            <p:nvPr>
+              <p:extLst>
+                <p:ext uri="{386F3935-93C4-4BCD-93E2-E3B085C9AB24}">
+                  <p16:designElem xmlns:p16="http://schemas.microsoft.com/office/powerpoint/2015/main" val="1"/>
+                </p:ext>
+              </p:extLst>
+            </p:nvPr>
+          </p:nvSpPr>
+          <p:spPr>
+            <a:xfrm>
+              <a:off x="4715626" y="308034"/>
+              <a:ext cx="566743" cy="3428999"/>
+            </a:xfrm>
+            <a:prstGeom prst="rect">
+              <a:avLst/>
+            </a:prstGeom>
+            <a:grpFill/>
+            <a:ln>
+              <a:noFill/>
+            </a:ln>
+          </p:spPr>
+          <p:style>
+            <a:lnRef idx="2">
+              <a:schemeClr val="accent1">
+                <a:shade val="50000"/>
+              </a:schemeClr>
+            </a:lnRef>
+            <a:fillRef idx="1">
+              <a:schemeClr val="accent1"/>
+            </a:fillRef>
+            <a:effectRef idx="0">
+              <a:schemeClr val="accent1"/>
+            </a:effectRef>
+            <a:fontRef idx="minor">
+              <a:schemeClr val="lt1"/>
+            </a:fontRef>
+          </p:style>
+          <p:txBody>
+            <a:bodyPr rtlCol="0" anchor="ctr"/>
+            <a:lstStyle/>
+            <a:p>
+              <a:pPr algn="ctr"/>
+              <a:endParaRPr lang="en-US"/>
+            </a:p>
+          </p:txBody>
+        </p:sp>
+        <p:sp>
+          <p:nvSpPr>
+            <p:cNvPr id="14" name="Rectangle 13">
+              <a:extLst>
+                <a:ext uri="{FF2B5EF4-FFF2-40B4-BE49-F238E27FC236}">
+                  <a16:creationId xmlns:a16="http://schemas.microsoft.com/office/drawing/2014/main" id="{ED49787B-8DE6-4467-AD0A-8DECC6E0C2D6}"/>
+                </a:ext>
+                <a:ext uri="{C183D7F6-B498-43B3-948B-1728B52AA6E4}">
+                  <adec:decorative xmlns:adec="http://schemas.microsoft.com/office/drawing/2017/decorative" val="1"/>
+                </a:ext>
+              </a:extLst>
+            </p:cNvPr>
+            <p:cNvSpPr/>
+            <p:nvPr>
+              <p:extLst>
+                <p:ext uri="{386F3935-93C4-4BCD-93E2-E3B085C9AB24}">
+                  <p16:designElem xmlns:p16="http://schemas.microsoft.com/office/powerpoint/2015/main" val="1"/>
+                </p:ext>
+              </p:extLst>
+            </p:nvPr>
+          </p:nvSpPr>
+          <p:spPr>
+            <a:xfrm>
+              <a:off x="5490650" y="308034"/>
+              <a:ext cx="566743" cy="3428999"/>
+            </a:xfrm>
+            <a:prstGeom prst="rect">
+              <a:avLst/>
+            </a:prstGeom>
+            <a:grpFill/>
+            <a:ln>
+              <a:noFill/>
+            </a:ln>
+          </p:spPr>
+          <p:style>
+            <a:lnRef idx="2">
+              <a:schemeClr val="accent1">
+                <a:shade val="50000"/>
+              </a:schemeClr>
+            </a:lnRef>
+            <a:fillRef idx="1">
+              <a:schemeClr val="accent1"/>
+            </a:fillRef>
+            <a:effectRef idx="0">
+              <a:schemeClr val="accent1"/>
+            </a:effectRef>
+            <a:fontRef idx="minor">
+              <a:schemeClr val="lt1"/>
+            </a:fontRef>
+          </p:style>
+          <p:txBody>
+            <a:bodyPr rtlCol="0" anchor="ctr"/>
+            <a:lstStyle/>
+            <a:p>
+              <a:pPr algn="ctr"/>
+              <a:endParaRPr lang="en-US"/>
+            </a:p>
+          </p:txBody>
+        </p:sp>
+      </p:grpSp>
+      <p:sp>
+        <p:nvSpPr>
+          <p:cNvPr id="16" name="Rectangle 15">
+            <a:extLst>
+              <a:ext uri="{FF2B5EF4-FFF2-40B4-BE49-F238E27FC236}">
+                <a16:creationId xmlns:a16="http://schemas.microsoft.com/office/drawing/2014/main" id="{D5B0017B-2ECA-49AF-B397-DC140825DF8D}"/>
+              </a:ext>
+              <a:ext uri="{C183D7F6-B498-43B3-948B-1728B52AA6E4}">
+                <adec:decorative xmlns:adec="http://schemas.microsoft.com/office/drawing/2017/decorative" val="1"/>
+              </a:ext>
+            </a:extLst>
+          </p:cNvPr>
+          <p:cNvSpPr>
+            <a:spLocks noGrp="1" noRot="1" noChangeAspect="1" noMove="1" noResize="1" noEditPoints="1" noAdjustHandles="1" noChangeArrowheads="1" noChangeShapeType="1" noTextEdit="1"/>
+          </p:cNvSpPr>
+          <p:nvPr>
+            <p:extLst>
+              <p:ext uri="{386F3935-93C4-4BCD-93E2-E3B085C9AB24}">
+                <p16:designElem xmlns:p16="http://schemas.microsoft.com/office/powerpoint/2015/main" val="1"/>
+              </p:ext>
+            </p:extLst>
+          </p:nvPr>
+        </p:nvSpPr>
+        <p:spPr>
+          <a:xfrm>
+            <a:off x="640079" y="613954"/>
+            <a:ext cx="10907487" cy="1894116"/>
+          </a:xfrm>
+          <a:prstGeom prst="rect">
+            <a:avLst/>
+          </a:prstGeom>
+          <a:solidFill>
+            <a:schemeClr val="bg1"/>
+          </a:solidFill>
+          <a:ln>
+            <a:noFill/>
+          </a:ln>
+          <a:effectLst>
+            <a:outerShdw blurRad="139700" dist="127000" dir="5400000" algn="t" rotWithShape="0">
+              <a:prstClr val="black">
+                <a:alpha val="15000"/>
+              </a:prstClr>
+            </a:outerShdw>
+          </a:effectLst>
+        </p:spPr>
+        <p:style>
+          <a:lnRef idx="2">
+            <a:schemeClr val="accent1">
+              <a:shade val="50000"/>
+            </a:schemeClr>
+          </a:lnRef>
+          <a:fillRef idx="1">
+            <a:schemeClr val="accent1"/>
+          </a:fillRef>
+          <a:effectRef idx="0">
+            <a:schemeClr val="accent1"/>
+          </a:effectRef>
+          <a:fontRef idx="minor">
+            <a:schemeClr val="lt1"/>
+          </a:fontRef>
+        </p:style>
+        <p:txBody>
+          <a:bodyPr rtlCol="0" anchor="ctr"/>
+          <a:lstStyle/>
+          <a:p>
+            <a:pPr algn="ctr"/>
+            <a:endParaRPr lang="en-US"/>
+          </a:p>
+        </p:txBody>
+      </p:sp>
       <p:sp>
         <p:nvSpPr>
           <p:cNvPr id="2" name="Title 1">
@@ -13484,55 +17154,108 @@
             <p:ph type="title"/>
           </p:nvPr>
         </p:nvSpPr>
-        <p:spPr/>
+        <p:spPr>
+          <a:xfrm>
+            <a:off x="1043631" y="809898"/>
+            <a:ext cx="10173010" cy="1554480"/>
+          </a:xfrm>
+        </p:spPr>
         <p:txBody>
-          <a:bodyPr/>
+          <a:bodyPr anchor="ctr">
+            <a:normAutofit/>
+          </a:bodyPr>
           <a:lstStyle/>
           <a:p>
             <a:r>
-              <a:rPr lang="en-US" dirty="0"/>
+              <a:rPr lang="en-US" sz="4800"/>
               <a:t>Model Results &amp; Performance</a:t>
             </a:r>
           </a:p>
         </p:txBody>
       </p:sp>
-      <p:sp>
-        <p:nvSpPr>
-          <p:cNvPr id="3" name="Content Placeholder 2">
+      <p:cxnSp>
+        <p:nvCxnSpPr>
+          <p:cNvPr id="18" name="Straight Connector 17">
             <a:extLst>
               <a:ext uri="{FF2B5EF4-FFF2-40B4-BE49-F238E27FC236}">
-                <a16:creationId xmlns:a16="http://schemas.microsoft.com/office/drawing/2014/main" id="{32B64E96-F4EA-2976-C3B9-4DDF488B5192}"/>
+                <a16:creationId xmlns:a16="http://schemas.microsoft.com/office/drawing/2014/main" id="{6CF1BAF6-AD41-4082-B212-8A1F9A2E8779}"/>
+              </a:ext>
+              <a:ext uri="{C183D7F6-B498-43B3-948B-1728B52AA6E4}">
+                <adec:decorative xmlns:adec="http://schemas.microsoft.com/office/drawing/2017/decorative" val="1"/>
               </a:ext>
             </a:extLst>
           </p:cNvPr>
-          <p:cNvSpPr>
-            <a:spLocks noGrp="1"/>
-          </p:cNvSpPr>
+          <p:cNvCxnSpPr>
+            <a:cxnSpLocks noGrp="1" noRot="1" noChangeAspect="1" noMove="1" noResize="1" noEditPoints="1" noAdjustHandles="1" noChangeArrowheads="1" noChangeShapeType="1"/>
+          </p:cNvCxnSpPr>
+          <p:nvPr>
+            <p:extLst>
+              <p:ext uri="{386F3935-93C4-4BCD-93E2-E3B085C9AB24}">
+                <p16:designElem xmlns:p16="http://schemas.microsoft.com/office/powerpoint/2015/main" val="1"/>
+              </p:ext>
+            </p:extLst>
+          </p:nvPr>
+        </p:nvCxnSpPr>
+        <p:spPr>
+          <a:xfrm flipH="1">
+            <a:off x="838200" y="6485313"/>
+            <a:ext cx="10515600" cy="0"/>
+          </a:xfrm>
+          <a:prstGeom prst="line">
+            <a:avLst/>
+          </a:prstGeom>
+          <a:ln w="57150">
+            <a:solidFill>
+              <a:schemeClr val="accent4"/>
+            </a:solidFill>
+          </a:ln>
+        </p:spPr>
+        <p:style>
+          <a:lnRef idx="1">
+            <a:schemeClr val="accent1"/>
+          </a:lnRef>
+          <a:fillRef idx="0">
+            <a:schemeClr val="accent1"/>
+          </a:fillRef>
+          <a:effectRef idx="0">
+            <a:schemeClr val="accent1"/>
+          </a:effectRef>
+          <a:fontRef idx="minor">
+            <a:schemeClr val="tx1"/>
+          </a:fontRef>
+        </p:style>
+      </p:cxnSp>
+      <p:graphicFrame>
+        <p:nvGraphicFramePr>
+          <p:cNvPr id="5" name="Content Placeholder 2">
+            <a:extLst>
+              <a:ext uri="{FF2B5EF4-FFF2-40B4-BE49-F238E27FC236}">
+                <a16:creationId xmlns:a16="http://schemas.microsoft.com/office/drawing/2014/main" id="{E57CAA31-7FF2-A387-B574-52F1FE4C40C3}"/>
+              </a:ext>
+            </a:extLst>
+          </p:cNvPr>
+          <p:cNvGraphicFramePr>
+            <a:graphicFrameLocks noGrp="1"/>
+          </p:cNvGraphicFramePr>
           <p:nvPr>
             <p:ph idx="1"/>
+            <p:extLst>
+              <p:ext uri="{D42A27DB-BD31-4B8C-83A1-F6EECF244321}">
+                <p14:modId xmlns:p14="http://schemas.microsoft.com/office/powerpoint/2010/main" val="359548985"/>
+              </p:ext>
+            </p:extLst>
           </p:nvPr>
-        </p:nvSpPr>
-        <p:spPr/>
-        <p:txBody>
-          <a:bodyPr/>
-          <a:lstStyle/>
-          <a:p>
-            <a:r>
-              <a:rPr lang="en-US" dirty="0"/>
-              <a:t>Ultimately, despite our hypothesis, our XGBoost model still struggled to consistently identify Cinderella teams. </a:t>
-            </a:r>
-          </a:p>
-          <a:p>
-            <a:endParaRPr lang="en-US" dirty="0"/>
-          </a:p>
-          <a:p>
-            <a:r>
-              <a:rPr lang="en-US" dirty="0"/>
-              <a:t>While it performed better than a random guess, it wasn’t drastically better. </a:t>
-            </a:r>
-          </a:p>
-        </p:txBody>
-      </p:sp>
+        </p:nvGraphicFramePr>
+        <p:xfrm>
+          <a:off x="904602" y="3017519"/>
+          <a:ext cx="10378440" cy="3209902"/>
+        </p:xfrm>
+        <a:graphic>
+          <a:graphicData uri="http://schemas.openxmlformats.org/drawingml/2006/diagram">
+            <dgm:relIds xmlns:dgm="http://schemas.openxmlformats.org/drawingml/2006/diagram" xmlns:r="http://schemas.openxmlformats.org/officeDocument/2006/relationships" r:dm="rId2" r:lo="rId3" r:qs="rId4" r:cs="rId5"/>
+          </a:graphicData>
+        </a:graphic>
+      </p:graphicFrame>
     </p:spTree>
     <p:extLst>
       <p:ext uri="{BB962C8B-B14F-4D97-AF65-F5344CB8AC3E}">
@@ -13546,7 +17269,7 @@
 </p:sld>
 </file>
 
-<file path=ppt/slides/slide12.xml><?xml version="1.0" encoding="utf-8"?>
+<file path=ppt/slides/slide13.xml><?xml version="1.0" encoding="utf-8"?>
 <p:sld xmlns:a="http://schemas.openxmlformats.org/drawingml/2006/main" xmlns:r="http://schemas.openxmlformats.org/officeDocument/2006/relationships" xmlns:p="http://schemas.openxmlformats.org/presentationml/2006/main">
   <p:cSld>
     <p:bg>
@@ -14280,7 +18003,7 @@
 </p:sld>
 </file>
 
-<file path=ppt/slides/slide13.xml><?xml version="1.0" encoding="utf-8"?>
+<file path=ppt/slides/slide14.xml><?xml version="1.0" encoding="utf-8"?>
 <p:sld xmlns:a="http://schemas.openxmlformats.org/drawingml/2006/main" xmlns:r="http://schemas.openxmlformats.org/officeDocument/2006/relationships" xmlns:p="http://schemas.openxmlformats.org/presentationml/2006/main">
   <p:cSld>
     <p:bg>
@@ -17732,6 +21455,262 @@
           <a:chExt cx="0" cy="0"/>
         </a:xfrm>
       </p:grpSpPr>
+      <p:sp>
+        <p:nvSpPr>
+          <p:cNvPr id="10" name="Rectangle 9">
+            <a:extLst>
+              <a:ext uri="{FF2B5EF4-FFF2-40B4-BE49-F238E27FC236}">
+                <a16:creationId xmlns:a16="http://schemas.microsoft.com/office/drawing/2014/main" id="{6753252F-4873-4F63-801D-CC719279A7D5}"/>
+              </a:ext>
+              <a:ext uri="{C183D7F6-B498-43B3-948B-1728B52AA6E4}">
+                <adec:decorative xmlns:adec="http://schemas.microsoft.com/office/drawing/2017/decorative" val="1"/>
+              </a:ext>
+            </a:extLst>
+          </p:cNvPr>
+          <p:cNvSpPr>
+            <a:spLocks noGrp="1" noRot="1" noChangeAspect="1" noMove="1" noResize="1" noEditPoints="1" noAdjustHandles="1" noChangeArrowheads="1" noChangeShapeType="1" noTextEdit="1"/>
+          </p:cNvSpPr>
+          <p:nvPr>
+            <p:extLst>
+              <p:ext uri="{386F3935-93C4-4BCD-93E2-E3B085C9AB24}">
+                <p16:designElem xmlns:p16="http://schemas.microsoft.com/office/powerpoint/2015/main" val="1"/>
+              </p:ext>
+            </p:extLst>
+          </p:nvPr>
+        </p:nvSpPr>
+        <p:spPr>
+          <a:xfrm>
+            <a:off x="0" y="0"/>
+            <a:ext cx="12192000" cy="6858000"/>
+          </a:xfrm>
+          <a:prstGeom prst="rect">
+            <a:avLst/>
+          </a:prstGeom>
+          <a:solidFill>
+            <a:srgbClr val="FFFFFF"/>
+          </a:solidFill>
+          <a:ln>
+            <a:noFill/>
+          </a:ln>
+        </p:spPr>
+        <p:style>
+          <a:lnRef idx="2">
+            <a:schemeClr val="accent1">
+              <a:shade val="50000"/>
+            </a:schemeClr>
+          </a:lnRef>
+          <a:fillRef idx="1">
+            <a:schemeClr val="accent1"/>
+          </a:fillRef>
+          <a:effectRef idx="0">
+            <a:schemeClr val="accent1"/>
+          </a:effectRef>
+          <a:fontRef idx="minor">
+            <a:schemeClr val="lt1"/>
+          </a:fontRef>
+        </p:style>
+        <p:txBody>
+          <a:bodyPr rtlCol="0" anchor="ctr"/>
+          <a:lstStyle/>
+          <a:p>
+            <a:pPr algn="ctr"/>
+            <a:endParaRPr lang="en-US"/>
+          </a:p>
+        </p:txBody>
+      </p:sp>
+      <p:sp>
+        <p:nvSpPr>
+          <p:cNvPr id="12" name="Rectangle 11">
+            <a:extLst>
+              <a:ext uri="{FF2B5EF4-FFF2-40B4-BE49-F238E27FC236}">
+                <a16:creationId xmlns:a16="http://schemas.microsoft.com/office/drawing/2014/main" id="{047C8CCB-F95D-4249-92DD-651249D3535A}"/>
+              </a:ext>
+              <a:ext uri="{C183D7F6-B498-43B3-948B-1728B52AA6E4}">
+                <adec:decorative xmlns:adec="http://schemas.microsoft.com/office/drawing/2017/decorative" val="1"/>
+              </a:ext>
+            </a:extLst>
+          </p:cNvPr>
+          <p:cNvSpPr>
+            <a:spLocks noGrp="1" noRot="1" noChangeAspect="1" noMove="1" noResize="1" noEditPoints="1" noAdjustHandles="1" noChangeArrowheads="1" noChangeShapeType="1" noTextEdit="1"/>
+          </p:cNvSpPr>
+          <p:nvPr>
+            <p:extLst>
+              <p:ext uri="{386F3935-93C4-4BCD-93E2-E3B085C9AB24}">
+                <p16:designElem xmlns:p16="http://schemas.microsoft.com/office/powerpoint/2015/main" val="1"/>
+              </p:ext>
+            </p:extLst>
+          </p:nvPr>
+        </p:nvSpPr>
+        <p:spPr>
+          <a:xfrm>
+            <a:off x="0" y="0"/>
+            <a:ext cx="2013557" cy="6858000"/>
+          </a:xfrm>
+          <a:prstGeom prst="rect">
+            <a:avLst/>
+          </a:prstGeom>
+          <a:solidFill>
+            <a:srgbClr val="AD675B"/>
+          </a:solidFill>
+          <a:ln>
+            <a:noFill/>
+          </a:ln>
+        </p:spPr>
+        <p:style>
+          <a:lnRef idx="2">
+            <a:schemeClr val="accent1">
+              <a:shade val="50000"/>
+            </a:schemeClr>
+          </a:lnRef>
+          <a:fillRef idx="1">
+            <a:schemeClr val="accent1"/>
+          </a:fillRef>
+          <a:effectRef idx="0">
+            <a:schemeClr val="accent1"/>
+          </a:effectRef>
+          <a:fontRef idx="minor">
+            <a:schemeClr val="lt1"/>
+          </a:fontRef>
+        </p:style>
+        <p:txBody>
+          <a:bodyPr rtlCol="0" anchor="ctr"/>
+          <a:lstStyle/>
+          <a:p>
+            <a:pPr algn="ctr"/>
+            <a:endParaRPr lang="en-US"/>
+          </a:p>
+        </p:txBody>
+      </p:sp>
+      <p:sp>
+        <p:nvSpPr>
+          <p:cNvPr id="2" name="Title 1">
+            <a:extLst>
+              <a:ext uri="{FF2B5EF4-FFF2-40B4-BE49-F238E27FC236}">
+                <a16:creationId xmlns:a16="http://schemas.microsoft.com/office/drawing/2014/main" id="{896FC1C8-1C43-FB92-E60C-885A31315466}"/>
+              </a:ext>
+            </a:extLst>
+          </p:cNvPr>
+          <p:cNvSpPr>
+            <a:spLocks noGrp="1"/>
+          </p:cNvSpPr>
+          <p:nvPr>
+            <p:ph type="title"/>
+          </p:nvPr>
+        </p:nvSpPr>
+        <p:spPr>
+          <a:xfrm>
+            <a:off x="640080" y="2074363"/>
+            <a:ext cx="2752354" cy="2709275"/>
+          </a:xfrm>
+          <a:prstGeom prst="ellipse">
+            <a:avLst/>
+          </a:prstGeom>
+          <a:solidFill>
+            <a:srgbClr val="262626"/>
+          </a:solidFill>
+          <a:ln w="174625" cmpd="thinThick">
+            <a:solidFill>
+              <a:srgbClr val="262626"/>
+            </a:solidFill>
+          </a:ln>
+        </p:spPr>
+        <p:txBody>
+          <a:bodyPr vert="horz" lIns="91440" tIns="45720" rIns="91440" bIns="45720" rtlCol="0" anchor="ctr">
+            <a:normAutofit/>
+          </a:bodyPr>
+          <a:lstStyle/>
+          <a:p>
+            <a:pPr algn="ctr"/>
+            <a:r>
+              <a:rPr lang="en-US" sz="2200" kern="1200" dirty="0">
+                <a:solidFill>
+                  <a:srgbClr val="FFFFFF"/>
+                </a:solidFill>
+                <a:latin typeface="+mj-lt"/>
+                <a:ea typeface="+mj-ea"/>
+                <a:cs typeface="+mj-cs"/>
+              </a:rPr>
+              <a:t>Despite Performing Better, the Model Still Performed Poorly</a:t>
+            </a:r>
+          </a:p>
+        </p:txBody>
+      </p:sp>
+      <p:pic>
+        <p:nvPicPr>
+          <p:cNvPr id="5" name="Content Placeholder 4">
+            <a:extLst>
+              <a:ext uri="{FF2B5EF4-FFF2-40B4-BE49-F238E27FC236}">
+                <a16:creationId xmlns:a16="http://schemas.microsoft.com/office/drawing/2014/main" id="{026DB3CB-699D-9D5E-8272-BF83E89665E9}"/>
+              </a:ext>
+            </a:extLst>
+          </p:cNvPr>
+          <p:cNvPicPr>
+            <a:picLocks noGrp="1" noChangeAspect="1"/>
+          </p:cNvPicPr>
+          <p:nvPr>
+            <p:ph idx="1"/>
+          </p:nvPr>
+        </p:nvPicPr>
+        <p:blipFill>
+          <a:blip r:embed="rId2">
+            <a:extLst>
+              <a:ext uri="{28A0092B-C50C-407E-A947-70E740481C1C}">
+                <a14:useLocalDpi xmlns:a14="http://schemas.microsoft.com/office/drawing/2010/main" val="0"/>
+              </a:ext>
+            </a:extLst>
+          </a:blip>
+          <a:stretch>
+            <a:fillRect/>
+          </a:stretch>
+        </p:blipFill>
+        <p:spPr>
+          <a:xfrm>
+            <a:off x="4399266" y="961812"/>
+            <a:ext cx="6466866" cy="4930987"/>
+          </a:xfrm>
+          <a:prstGeom prst="rect">
+            <a:avLst/>
+          </a:prstGeom>
+        </p:spPr>
+      </p:pic>
+    </p:spTree>
+    <p:extLst>
+      <p:ext uri="{BB962C8B-B14F-4D97-AF65-F5344CB8AC3E}">
+        <p14:creationId xmlns:p14="http://schemas.microsoft.com/office/powerpoint/2010/main" val="3755968374"/>
+      </p:ext>
+    </p:extLst>
+  </p:cSld>
+  <p:clrMapOvr>
+    <a:masterClrMapping/>
+  </p:clrMapOvr>
+</p:sld>
+</file>
+
+<file path=ppt/slides/slide9.xml><?xml version="1.0" encoding="utf-8"?>
+<p:sld xmlns:a="http://schemas.openxmlformats.org/drawingml/2006/main" xmlns:r="http://schemas.openxmlformats.org/officeDocument/2006/relationships" xmlns:p="http://schemas.openxmlformats.org/presentationml/2006/main">
+  <p:cSld>
+    <p:bg>
+      <p:bgPr>
+        <a:solidFill>
+          <a:schemeClr val="bg1"/>
+        </a:solidFill>
+        <a:effectLst/>
+      </p:bgPr>
+    </p:bg>
+    <p:spTree>
+      <p:nvGrpSpPr>
+        <p:cNvPr id="1" name=""/>
+        <p:cNvGrpSpPr/>
+        <p:nvPr/>
+      </p:nvGrpSpPr>
+      <p:grpSpPr>
+        <a:xfrm>
+          <a:off x="0" y="0"/>
+          <a:ext cx="0" cy="0"/>
+          <a:chOff x="0" y="0"/>
+          <a:chExt cx="0" cy="0"/>
+        </a:xfrm>
+      </p:grpSpPr>
       <p:sp useBgFill="1">
         <p:nvSpPr>
           <p:cNvPr id="8" name="Rectangle 7">
@@ -18173,498 +22152,6 @@
 </p:sld>
 </file>
 
-<file path=ppt/slides/slide9.xml><?xml version="1.0" encoding="utf-8"?>
-<p:sld xmlns:a="http://schemas.openxmlformats.org/drawingml/2006/main" xmlns:r="http://schemas.openxmlformats.org/officeDocument/2006/relationships" xmlns:p="http://schemas.openxmlformats.org/presentationml/2006/main">
-  <p:cSld>
-    <p:bg>
-      <p:bgPr>
-        <a:solidFill>
-          <a:schemeClr val="bg1"/>
-        </a:solidFill>
-        <a:effectLst/>
-      </p:bgPr>
-    </p:bg>
-    <p:spTree>
-      <p:nvGrpSpPr>
-        <p:cNvPr id="1" name=""/>
-        <p:cNvGrpSpPr/>
-        <p:nvPr/>
-      </p:nvGrpSpPr>
-      <p:grpSpPr>
-        <a:xfrm>
-          <a:off x="0" y="0"/>
-          <a:ext cx="0" cy="0"/>
-          <a:chOff x="0" y="0"/>
-          <a:chExt cx="0" cy="0"/>
-        </a:xfrm>
-      </p:grpSpPr>
-      <p:sp useBgFill="1">
-        <p:nvSpPr>
-          <p:cNvPr id="10" name="Rectangle 9">
-            <a:extLst>
-              <a:ext uri="{FF2B5EF4-FFF2-40B4-BE49-F238E27FC236}">
-                <a16:creationId xmlns:a16="http://schemas.microsoft.com/office/drawing/2014/main" id="{743AA782-23D1-4521-8CAD-47662984AA08}"/>
-              </a:ext>
-              <a:ext uri="{C183D7F6-B498-43B3-948B-1728B52AA6E4}">
-                <adec:decorative xmlns:adec="http://schemas.microsoft.com/office/drawing/2017/decorative" val="1"/>
-              </a:ext>
-            </a:extLst>
-          </p:cNvPr>
-          <p:cNvSpPr>
-            <a:spLocks noGrp="1" noRot="1" noChangeAspect="1" noMove="1" noResize="1" noEditPoints="1" noAdjustHandles="1" noChangeArrowheads="1" noChangeShapeType="1" noTextEdit="1"/>
-          </p:cNvSpPr>
-          <p:nvPr>
-            <p:extLst>
-              <p:ext uri="{386F3935-93C4-4BCD-93E2-E3B085C9AB24}">
-                <p16:designElem xmlns:p16="http://schemas.microsoft.com/office/powerpoint/2015/main" val="1"/>
-              </p:ext>
-            </p:extLst>
-          </p:nvPr>
-        </p:nvSpPr>
-        <p:spPr>
-          <a:xfrm>
-            <a:off x="0" y="0"/>
-            <a:ext cx="12192000" cy="6858000"/>
-          </a:xfrm>
-          <a:prstGeom prst="rect">
-            <a:avLst/>
-          </a:prstGeom>
-          <a:ln>
-            <a:noFill/>
-          </a:ln>
-        </p:spPr>
-        <p:style>
-          <a:lnRef idx="2">
-            <a:schemeClr val="accent1">
-              <a:shade val="50000"/>
-            </a:schemeClr>
-          </a:lnRef>
-          <a:fillRef idx="1">
-            <a:schemeClr val="accent1"/>
-          </a:fillRef>
-          <a:effectRef idx="0">
-            <a:schemeClr val="accent1"/>
-          </a:effectRef>
-          <a:fontRef idx="minor">
-            <a:schemeClr val="lt1"/>
-          </a:fontRef>
-        </p:style>
-        <p:txBody>
-          <a:bodyPr rtlCol="0" anchor="ctr"/>
-          <a:lstStyle/>
-          <a:p>
-            <a:pPr algn="ctr"/>
-            <a:endParaRPr lang="en-US"/>
-          </a:p>
-        </p:txBody>
-      </p:sp>
-      <p:sp>
-        <p:nvSpPr>
-          <p:cNvPr id="2" name="Title 1">
-            <a:extLst>
-              <a:ext uri="{FF2B5EF4-FFF2-40B4-BE49-F238E27FC236}">
-                <a16:creationId xmlns:a16="http://schemas.microsoft.com/office/drawing/2014/main" id="{0E1231AA-D68E-5E3E-38D9-A11CFECCFD27}"/>
-              </a:ext>
-            </a:extLst>
-          </p:cNvPr>
-          <p:cNvSpPr>
-            <a:spLocks noGrp="1"/>
-          </p:cNvSpPr>
-          <p:nvPr>
-            <p:ph type="title"/>
-          </p:nvPr>
-        </p:nvSpPr>
-        <p:spPr>
-          <a:xfrm>
-            <a:off x="630936" y="640080"/>
-            <a:ext cx="4818888" cy="1481328"/>
-          </a:xfrm>
-        </p:spPr>
-        <p:txBody>
-          <a:bodyPr anchor="b">
-            <a:normAutofit/>
-          </a:bodyPr>
-          <a:lstStyle/>
-          <a:p>
-            <a:r>
-              <a:rPr lang="en-US" sz="5000"/>
-              <a:t>Feature Importance</a:t>
-            </a:r>
-          </a:p>
-        </p:txBody>
-      </p:sp>
-      <p:sp>
-        <p:nvSpPr>
-          <p:cNvPr id="12" name="sketch line">
-            <a:extLst>
-              <a:ext uri="{FF2B5EF4-FFF2-40B4-BE49-F238E27FC236}">
-                <a16:creationId xmlns:a16="http://schemas.microsoft.com/office/drawing/2014/main" id="{71877DBC-BB60-40F0-AC93-2ACDBAAE60CE}"/>
-              </a:ext>
-              <a:ext uri="{C183D7F6-B498-43B3-948B-1728B52AA6E4}">
-                <adec:decorative xmlns:adec="http://schemas.microsoft.com/office/drawing/2017/decorative" val="1"/>
-              </a:ext>
-            </a:extLst>
-          </p:cNvPr>
-          <p:cNvSpPr>
-            <a:spLocks noGrp="1" noRot="1" noChangeAspect="1" noMove="1" noResize="1" noEditPoints="1" noAdjustHandles="1" noChangeArrowheads="1" noChangeShapeType="1" noTextEdit="1"/>
-          </p:cNvSpPr>
-          <p:nvPr>
-            <p:extLst>
-              <p:ext uri="{386F3935-93C4-4BCD-93E2-E3B085C9AB24}">
-                <p16:designElem xmlns:p16="http://schemas.microsoft.com/office/powerpoint/2015/main" val="1"/>
-              </p:ext>
-            </p:extLst>
-          </p:nvPr>
-        </p:nvSpPr>
-        <p:spPr>
-          <a:xfrm>
-            <a:off x="643278" y="2372868"/>
-            <a:ext cx="3255095" cy="18288"/>
-          </a:xfrm>
-          <a:custGeom>
-            <a:avLst/>
-            <a:gdLst>
-              <a:gd name="csX0" fmla="*/ 0 w 3255095"/>
-              <a:gd name="csY0" fmla="*/ 0 h 18288"/>
-              <a:gd name="csX1" fmla="*/ 618468 w 3255095"/>
-              <a:gd name="csY1" fmla="*/ 0 h 18288"/>
-              <a:gd name="csX2" fmla="*/ 1269487 w 3255095"/>
-              <a:gd name="csY2" fmla="*/ 0 h 18288"/>
-              <a:gd name="csX3" fmla="*/ 1953057 w 3255095"/>
-              <a:gd name="csY3" fmla="*/ 0 h 18288"/>
-              <a:gd name="csX4" fmla="*/ 2636627 w 3255095"/>
-              <a:gd name="csY4" fmla="*/ 0 h 18288"/>
-              <a:gd name="csX5" fmla="*/ 3255095 w 3255095"/>
-              <a:gd name="csY5" fmla="*/ 0 h 18288"/>
-              <a:gd name="csX6" fmla="*/ 3255095 w 3255095"/>
-              <a:gd name="csY6" fmla="*/ 18288 h 18288"/>
-              <a:gd name="csX7" fmla="*/ 2538974 w 3255095"/>
-              <a:gd name="csY7" fmla="*/ 18288 h 18288"/>
-              <a:gd name="csX8" fmla="*/ 1822853 w 3255095"/>
-              <a:gd name="csY8" fmla="*/ 18288 h 18288"/>
-              <a:gd name="csX9" fmla="*/ 1171834 w 3255095"/>
-              <a:gd name="csY9" fmla="*/ 18288 h 18288"/>
-              <a:gd name="csX10" fmla="*/ 0 w 3255095"/>
-              <a:gd name="csY10" fmla="*/ 18288 h 18288"/>
-              <a:gd name="csX11" fmla="*/ 0 w 3255095"/>
-              <a:gd name="csY11" fmla="*/ 0 h 18288"/>
-            </a:gdLst>
-            <a:ahLst/>
-            <a:cxnLst>
-              <a:cxn ang="0">
-                <a:pos x="csX0" y="csY0"/>
-              </a:cxn>
-              <a:cxn ang="0">
-                <a:pos x="csX1" y="csY1"/>
-              </a:cxn>
-              <a:cxn ang="0">
-                <a:pos x="csX2" y="csY2"/>
-              </a:cxn>
-              <a:cxn ang="0">
-                <a:pos x="csX3" y="csY3"/>
-              </a:cxn>
-              <a:cxn ang="0">
-                <a:pos x="csX4" y="csY4"/>
-              </a:cxn>
-              <a:cxn ang="0">
-                <a:pos x="csX5" y="csY5"/>
-              </a:cxn>
-              <a:cxn ang="0">
-                <a:pos x="csX6" y="csY6"/>
-              </a:cxn>
-              <a:cxn ang="0">
-                <a:pos x="csX7" y="csY7"/>
-              </a:cxn>
-              <a:cxn ang="0">
-                <a:pos x="csX8" y="csY8"/>
-              </a:cxn>
-              <a:cxn ang="0">
-                <a:pos x="csX9" y="csY9"/>
-              </a:cxn>
-              <a:cxn ang="0">
-                <a:pos x="csX10" y="csY10"/>
-              </a:cxn>
-              <a:cxn ang="0">
-                <a:pos x="csX11" y="csY11"/>
-              </a:cxn>
-            </a:cxnLst>
-            <a:rect l="l" t="t" r="r" b="b"/>
-            <a:pathLst>
-              <a:path w="3255095" h="18288" fill="none" extrusionOk="0">
-                <a:moveTo>
-                  <a:pt x="0" y="0"/>
-                </a:moveTo>
-                <a:cubicBezTo>
-                  <a:pt x="240201" y="-22123"/>
-                  <a:pt x="462021" y="-19623"/>
-                  <a:pt x="618468" y="0"/>
-                </a:cubicBezTo>
-                <a:cubicBezTo>
-                  <a:pt x="774915" y="19623"/>
-                  <a:pt x="974734" y="2035"/>
-                  <a:pt x="1269487" y="0"/>
-                </a:cubicBezTo>
-                <a:cubicBezTo>
-                  <a:pt x="1564240" y="-2035"/>
-                  <a:pt x="1733579" y="10639"/>
-                  <a:pt x="1953057" y="0"/>
-                </a:cubicBezTo>
-                <a:cubicBezTo>
-                  <a:pt x="2172535" y="-10639"/>
-                  <a:pt x="2453962" y="14018"/>
-                  <a:pt x="2636627" y="0"/>
-                </a:cubicBezTo>
-                <a:cubicBezTo>
-                  <a:pt x="2819292" y="-14018"/>
-                  <a:pt x="3121375" y="5399"/>
-                  <a:pt x="3255095" y="0"/>
-                </a:cubicBezTo>
-                <a:cubicBezTo>
-                  <a:pt x="3254386" y="8157"/>
-                  <a:pt x="3254682" y="12125"/>
-                  <a:pt x="3255095" y="18288"/>
-                </a:cubicBezTo>
-                <a:cubicBezTo>
-                  <a:pt x="3088545" y="23203"/>
-                  <a:pt x="2687475" y="7419"/>
-                  <a:pt x="2538974" y="18288"/>
-                </a:cubicBezTo>
-                <a:cubicBezTo>
-                  <a:pt x="2390473" y="29157"/>
-                  <a:pt x="2137381" y="-8959"/>
-                  <a:pt x="1822853" y="18288"/>
-                </a:cubicBezTo>
-                <a:cubicBezTo>
-                  <a:pt x="1508325" y="45535"/>
-                  <a:pt x="1466437" y="20385"/>
-                  <a:pt x="1171834" y="18288"/>
-                </a:cubicBezTo>
-                <a:cubicBezTo>
-                  <a:pt x="877231" y="16191"/>
-                  <a:pt x="561097" y="37643"/>
-                  <a:pt x="0" y="18288"/>
-                </a:cubicBezTo>
-                <a:cubicBezTo>
-                  <a:pt x="-46" y="12483"/>
-                  <a:pt x="-203" y="6491"/>
-                  <a:pt x="0" y="0"/>
-                </a:cubicBezTo>
-                <a:close/>
-              </a:path>
-              <a:path w="3255095" h="18288" stroke="0" extrusionOk="0">
-                <a:moveTo>
-                  <a:pt x="0" y="0"/>
-                </a:moveTo>
-                <a:cubicBezTo>
-                  <a:pt x="291965" y="19429"/>
-                  <a:pt x="363155" y="8568"/>
-                  <a:pt x="618468" y="0"/>
-                </a:cubicBezTo>
-                <a:cubicBezTo>
-                  <a:pt x="873781" y="-8568"/>
-                  <a:pt x="904459" y="-19505"/>
-                  <a:pt x="1171834" y="0"/>
-                </a:cubicBezTo>
-                <a:cubicBezTo>
-                  <a:pt x="1439209" y="19505"/>
-                  <a:pt x="1744369" y="9790"/>
-                  <a:pt x="1887955" y="0"/>
-                </a:cubicBezTo>
-                <a:cubicBezTo>
-                  <a:pt x="2031541" y="-9790"/>
-                  <a:pt x="2346378" y="21240"/>
-                  <a:pt x="2506423" y="0"/>
-                </a:cubicBezTo>
-                <a:cubicBezTo>
-                  <a:pt x="2666468" y="-21240"/>
-                  <a:pt x="2990257" y="30414"/>
-                  <a:pt x="3255095" y="0"/>
-                </a:cubicBezTo>
-                <a:cubicBezTo>
-                  <a:pt x="3254831" y="4493"/>
-                  <a:pt x="3255479" y="9472"/>
-                  <a:pt x="3255095" y="18288"/>
-                </a:cubicBezTo>
-                <a:cubicBezTo>
-                  <a:pt x="3120743" y="16690"/>
-                  <a:pt x="2759628" y="42462"/>
-                  <a:pt x="2604076" y="18288"/>
-                </a:cubicBezTo>
-                <a:cubicBezTo>
-                  <a:pt x="2448524" y="-5886"/>
-                  <a:pt x="2184336" y="19599"/>
-                  <a:pt x="1887955" y="18288"/>
-                </a:cubicBezTo>
-                <a:cubicBezTo>
-                  <a:pt x="1591574" y="16977"/>
-                  <a:pt x="1548845" y="6870"/>
-                  <a:pt x="1334589" y="18288"/>
-                </a:cubicBezTo>
-                <a:cubicBezTo>
-                  <a:pt x="1120333" y="29706"/>
-                  <a:pt x="996014" y="9662"/>
-                  <a:pt x="683570" y="18288"/>
-                </a:cubicBezTo>
-                <a:cubicBezTo>
-                  <a:pt x="371126" y="26914"/>
-                  <a:pt x="198687" y="16167"/>
-                  <a:pt x="0" y="18288"/>
-                </a:cubicBezTo>
-                <a:cubicBezTo>
-                  <a:pt x="843" y="9577"/>
-                  <a:pt x="371" y="6900"/>
-                  <a:pt x="0" y="0"/>
-                </a:cubicBezTo>
-                <a:close/>
-              </a:path>
-            </a:pathLst>
-          </a:custGeom>
-          <a:solidFill>
-            <a:schemeClr val="accent2"/>
-          </a:solidFill>
-          <a:ln w="38100" cap="rnd">
-            <a:solidFill>
-              <a:schemeClr val="accent2"/>
-            </a:solidFill>
-            <a:round/>
-            <a:extLst>
-              <a:ext uri="{C807C97D-BFC1-408E-A445-0C87EB9F89A2}">
-                <ask:lineSketchStyleProps xmlns:ask="http://schemas.microsoft.com/office/drawing/2018/sketchyshapes" sd="1219033472">
-                  <a:prstGeom prst="rect">
-                    <a:avLst/>
-                  </a:prstGeom>
-                  <ask:type>
-                    <ask:lineSketchFreehand/>
-                  </ask:type>
-                </ask:lineSketchStyleProps>
-              </a:ext>
-            </a:extLst>
-          </a:ln>
-        </p:spPr>
-        <p:style>
-          <a:lnRef idx="2">
-            <a:schemeClr val="accent1">
-              <a:shade val="50000"/>
-            </a:schemeClr>
-          </a:lnRef>
-          <a:fillRef idx="1">
-            <a:schemeClr val="accent1"/>
-          </a:fillRef>
-          <a:effectRef idx="0">
-            <a:schemeClr val="accent1"/>
-          </a:effectRef>
-          <a:fontRef idx="minor">
-            <a:schemeClr val="lt1"/>
-          </a:fontRef>
-        </p:style>
-        <p:txBody>
-          <a:bodyPr rtlCol="0" anchor="ctr"/>
-          <a:lstStyle/>
-          <a:p>
-            <a:pPr algn="ctr"/>
-            <a:endParaRPr lang="en-US"/>
-          </a:p>
-        </p:txBody>
-      </p:sp>
-      <p:sp>
-        <p:nvSpPr>
-          <p:cNvPr id="3" name="Content Placeholder 2">
-            <a:extLst>
-              <a:ext uri="{FF2B5EF4-FFF2-40B4-BE49-F238E27FC236}">
-                <a16:creationId xmlns:a16="http://schemas.microsoft.com/office/drawing/2014/main" id="{5F2610FC-C8BD-1B28-5CF1-C94A6C57EF7E}"/>
-              </a:ext>
-            </a:extLst>
-          </p:cNvPr>
-          <p:cNvSpPr>
-            <a:spLocks noGrp="1"/>
-          </p:cNvSpPr>
-          <p:nvPr>
-            <p:ph idx="1"/>
-          </p:nvPr>
-        </p:nvSpPr>
-        <p:spPr>
-          <a:xfrm>
-            <a:off x="630936" y="2660904"/>
-            <a:ext cx="4818888" cy="3547872"/>
-          </a:xfrm>
-        </p:spPr>
-        <p:txBody>
-          <a:bodyPr anchor="t">
-            <a:normAutofit/>
-          </a:bodyPr>
-          <a:lstStyle/>
-          <a:p>
-            <a:pPr marL="0" indent="0">
-              <a:buNone/>
-            </a:pPr>
-            <a:r>
-              <a:rPr lang="en-US" sz="2200" dirty="0" err="1"/>
-              <a:t>Rank_vs_TourneyAvg</a:t>
-            </a:r>
-            <a:r>
-              <a:rPr lang="en-US" sz="2200" dirty="0"/>
-              <a:t> was our top predictor with </a:t>
-            </a:r>
-            <a:r>
-              <a:rPr lang="en-US" sz="2200" dirty="0" err="1"/>
-              <a:t>SeedNum</a:t>
-            </a:r>
-            <a:r>
-              <a:rPr lang="en-US" sz="2200" dirty="0"/>
-              <a:t> being a close second. Showing that although the teams seed number was low by the tournament committee their underlying Massey Ratings metric mathematically placed them above.</a:t>
-            </a:r>
-          </a:p>
-        </p:txBody>
-      </p:sp>
-      <p:pic>
-        <p:nvPicPr>
-          <p:cNvPr id="6" name="Picture 5">
-            <a:extLst>
-              <a:ext uri="{FF2B5EF4-FFF2-40B4-BE49-F238E27FC236}">
-                <a16:creationId xmlns:a16="http://schemas.microsoft.com/office/drawing/2014/main" id="{D02FCB11-0CC0-1720-5033-8A80D2267BD8}"/>
-              </a:ext>
-            </a:extLst>
-          </p:cNvPr>
-          <p:cNvPicPr>
-            <a:picLocks noChangeAspect="1"/>
-          </p:cNvPicPr>
-          <p:nvPr/>
-        </p:nvPicPr>
-        <p:blipFill>
-          <a:blip r:embed="rId2">
-            <a:extLst>
-              <a:ext uri="{28A0092B-C50C-407E-A947-70E740481C1C}">
-                <a14:useLocalDpi xmlns:a14="http://schemas.microsoft.com/office/drawing/2010/main" val="0"/>
-              </a:ext>
-            </a:extLst>
-          </a:blip>
-          <a:stretch>
-            <a:fillRect/>
-          </a:stretch>
-        </p:blipFill>
-        <p:spPr>
-          <a:xfrm>
-            <a:off x="5449824" y="1165092"/>
-            <a:ext cx="6253816" cy="4527815"/>
-          </a:xfrm>
-          <a:prstGeom prst="rect">
-            <a:avLst/>
-          </a:prstGeom>
-        </p:spPr>
-      </p:pic>
-    </p:spTree>
-    <p:extLst>
-      <p:ext uri="{BB962C8B-B14F-4D97-AF65-F5344CB8AC3E}">
-        <p14:creationId xmlns:p14="http://schemas.microsoft.com/office/powerpoint/2010/main" val="954167436"/>
-      </p:ext>
-    </p:extLst>
-  </p:cSld>
-  <p:clrMapOvr>
-    <a:masterClrMapping/>
-  </p:clrMapOvr>
-</p:sld>
-</file>
-
 <file path=ppt/theme/theme1.xml><?xml version="1.0" encoding="utf-8"?>
 <a:theme xmlns:a="http://schemas.openxmlformats.org/drawingml/2006/main" name="Office Theme">
   <a:themeElements>

</xml_diff>